<commit_message>
feat: synchronize visual charts and legends across slides and dashboard
</commit_message>
<xml_diff>
--- a/presentation/board_deck.pptx
+++ b/presentation/board_deck.pptx
@@ -140,7 +140,7 @@
               <c:strCache>
                 <c:ptCount val="1"/>
                 <c:pt idx="0">
-                  <c:v>s</c:v>
+                  <c:v>Gross sales ($M)</c:v>
                 </c:pt>
               </c:strCache>
             </c:strRef>
@@ -187,6 +187,67 @@
                 </c:pt>
                 <c:pt idx="3">
                   <c:v>4.3</c:v>
+                </c:pt>
+              </c:numCache>
+            </c:numRef>
+          </c:val>
+        </c:ser>
+        <c:ser>
+          <c:idx val="1"/>
+          <c:order val="1"/>
+          <c:tx>
+            <c:strRef>
+              <c:f>Sheet1!$C$1</c:f>
+              <c:strCache>
+                <c:ptCount val="1"/>
+                <c:pt idx="0">
+                  <c:v>Operating profit ($M)</c:v>
+                </c:pt>
+              </c:strCache>
+            </c:strRef>
+          </c:tx>
+          <c:spPr>
+            <a:solidFill>
+              <a:srgbClr val="5A3921"/>
+            </a:solidFill>
+          </c:spPr>
+          <c:cat>
+            <c:strRef>
+              <c:f>Sheet1!$A$2:$A$5</c:f>
+              <c:strCache>
+                <c:ptCount val="4"/>
+                <c:pt idx="0">
+                  <c:v>FY2011</c:v>
+                </c:pt>
+                <c:pt idx="1">
+                  <c:v>FY2012</c:v>
+                </c:pt>
+                <c:pt idx="2">
+                  <c:v>FY2013</c:v>
+                </c:pt>
+                <c:pt idx="3">
+                  <c:v>FY2014</c:v>
+                </c:pt>
+              </c:strCache>
+            </c:strRef>
+          </c:cat>
+          <c:val>
+            <c:numRef>
+              <c:f>Sheet1!$C$2:$C$5</c:f>
+              <c:numCache>
+                <c:formatCode>General</c:formatCode>
+                <c:ptCount val="4"/>
+                <c:pt idx="0">
+                  <c:v>0.25</c:v>
+                </c:pt>
+                <c:pt idx="1">
+                  <c:v>0.31</c:v>
+                </c:pt>
+                <c:pt idx="2">
+                  <c:v>0.41</c:v>
+                </c:pt>
+                <c:pt idx="3">
+                  <c:v>0.5</c:v>
                 </c:pt>
               </c:numCache>
             </c:numRef>
@@ -299,6 +360,9 @@
         <c:crosses val="autoZero"/>
       </c:valAx>
     </c:plotArea>
+    <c:legend>
+      <c:overlay val="0"/>
+    </c:legend>
     <c:dispBlanksAs val="gap"/>
   </c:chart>
   <c:txPr>
@@ -15542,13 +15606,7 @@
               </a:spcAft>
             </a:pPr>
             <a:r>
-              <a:rPr sz="1200" b="1" i="0">
-                <a:solidFill>
-                  <a:srgbClr val="5A3921"/>
-                </a:solidFill>
-                <a:latin typeface="Georgia"/>
-              </a:rPr>
-              <a:t>Gross sales by fiscal year</a:t>
+              <a:t>Gross sales and operating profit</a:t>
             </a:r>
           </a:p>
         </p:txBody>
@@ -15622,13 +15680,7 @@
               </a:spcAft>
             </a:pPr>
             <a:r>
-              <a:rPr sz="800" b="0" i="0">
-                <a:solidFill>
-                  <a:srgbClr val="8A7B6B"/>
-                </a:solidFill>
-                <a:latin typeface="Arial"/>
-              </a:rPr>
-              <a:t>$ million, FY2011-FY2014</a:t>
+              <a:t>$ million (bars) · $ thousand (bars), FY2011-FY2014</a:t>
             </a:r>
           </a:p>
         </p:txBody>
@@ -15713,13 +15765,7 @@
               </a:spcAft>
             </a:pPr>
             <a:r>
-              <a:rPr sz="800" b="0" i="0">
-                <a:solidFill>
-                  <a:srgbClr val="322014"/>
-                </a:solidFill>
-                <a:latin typeface="Arial"/>
-              </a:rPr>
-              <a:t>Gross sales</a:t>
+              <a:t>Gross sales ($M) &amp; Operating profit ($M)</a:t>
             </a:r>
           </a:p>
         </p:txBody>
@@ -15909,13 +15955,7 @@
               <a:buChar char="•"/>
             </a:pPr>
             <a:r>
-              <a:rPr sz="1100" b="0" i="0">
-                <a:solidFill>
-                  <a:srgbClr val="322014"/>
-                </a:solidFill>
-                <a:latin typeface="Arial"/>
-              </a:rPr>
-              <a:t>Operating profit rose every year too, from $249K to $504K.</a:t>
+              <a:t>Operating profit rose every year too, from $249K to $504K (+102.5%).</a:t>
             </a:r>
           </a:p>
           <a:p>
@@ -16009,6 +16049,60 @@
                 <a:latin typeface="Arial"/>
               </a:rPr>
               <a:t>Source: Global Superstore transaction ledger, FY2011-FY2014. Operating profit is reported profit after cost of goods and freight.</a:t>
+            </a:r>
+          </a:p>
+        </p:txBody>
+      </p:sp>
+      <p:sp>
+        <p:nvSpPr>
+          <p:cNvPr id="20" name="Rectangle 19"/>
+          <p:cNvSpPr/>
+          <p:nvPr/>
+        </p:nvSpPr>
+        <p:spPr>
+          <a:xfrm>
+            <a:off x="7589520" y="5303520"/>
+            <a:ext cx="4114800" cy="731520"/>
+          </a:xfrm>
+          <a:prstGeom prst="rect">
+            <a:avLst/>
+          </a:prstGeom>
+          <a:solidFill>
+            <a:srgbClr val="EFEEE8"/>
+          </a:solidFill>
+          <a:ln>
+            <a:solidFill>
+              <a:srgbClr val="C5A681"/>
+            </a:solidFill>
+          </a:ln>
+        </p:spPr>
+        <p:style>
+          <a:lnRef idx="1">
+            <a:schemeClr val="accent1"/>
+          </a:lnRef>
+          <a:fillRef idx="3">
+            <a:schemeClr val="accent1"/>
+          </a:fillRef>
+          <a:effectRef idx="2">
+            <a:schemeClr val="accent1"/>
+          </a:effectRef>
+          <a:fontRef idx="minor">
+            <a:schemeClr val="lt1"/>
+          </a:fontRef>
+        </p:style>
+        <p:txBody>
+          <a:bodyPr rtlCol="0" anchor="ctr" wrap="square"/>
+          <a:lstStyle/>
+          <a:p>
+            <a:pPr algn="ctr">
+              <a:defRPr sz="1000" b="1">
+                <a:solidFill>
+                  <a:srgbClr val="322014"/>
+                </a:solidFill>
+              </a:defRPr>
+            </a:pPr>
+            <a:r>
+              <a:t>Order Volume: 4,440 → 8,531 (+92.1%)  |  Avg Order Value: ~$505 (flat, -0.9%)</a:t>
             </a:r>
           </a:p>
         </p:txBody>
@@ -20143,6 +20237,166 @@
                 <a:latin typeface="Arial"/>
               </a:rPr>
               <a:t>Source: Global Superstore transaction ledger, FY2011-FY2014. Bands follow the discount distribution in the ledger.</a:t>
+            </a:r>
+          </a:p>
+        </p:txBody>
+      </p:sp>
+      <p:sp>
+        <p:nvSpPr>
+          <p:cNvPr id="19" name="Rectangle 18"/>
+          <p:cNvSpPr/>
+          <p:nvPr/>
+        </p:nvSpPr>
+        <p:spPr>
+          <a:xfrm>
+            <a:off x="566928" y="5852160"/>
+            <a:ext cx="137160" cy="137160"/>
+          </a:xfrm>
+          <a:prstGeom prst="rect">
+            <a:avLst/>
+          </a:prstGeom>
+          <a:solidFill>
+            <a:srgbClr val="5A3921"/>
+          </a:solidFill>
+          <a:ln>
+            <a:solidFill>
+              <a:srgbClr val="5A3921"/>
+            </a:solidFill>
+          </a:ln>
+        </p:spPr>
+        <p:style>
+          <a:lnRef idx="1">
+            <a:schemeClr val="accent1"/>
+          </a:lnRef>
+          <a:fillRef idx="3">
+            <a:schemeClr val="accent1"/>
+          </a:fillRef>
+          <a:effectRef idx="2">
+            <a:schemeClr val="accent1"/>
+          </a:effectRef>
+          <a:fontRef idx="minor">
+            <a:schemeClr val="lt1"/>
+          </a:fontRef>
+        </p:style>
+        <p:txBody>
+          <a:bodyPr rtlCol="0" anchor="ctr"/>
+          <a:lstStyle/>
+          <a:p>
+            <a:pPr algn="ctr"/>
+          </a:p>
+        </p:txBody>
+      </p:sp>
+      <p:sp>
+        <p:nvSpPr>
+          <p:cNvPr id="20" name="TextBox 19"/>
+          <p:cNvSpPr txBox="1"/>
+          <p:nvPr/>
+        </p:nvSpPr>
+        <p:spPr>
+          <a:xfrm>
+            <a:off x="749808" y="5806440"/>
+            <a:ext cx="2286000" cy="228600"/>
+          </a:xfrm>
+          <a:prstGeom prst="rect">
+            <a:avLst/>
+          </a:prstGeom>
+          <a:noFill/>
+        </p:spPr>
+        <p:txBody>
+          <a:bodyPr wrap="none">
+            <a:spAutoFit/>
+          </a:bodyPr>
+          <a:lstStyle/>
+          <a:p>
+            <a:pPr>
+              <a:defRPr sz="900">
+                <a:solidFill>
+                  <a:srgbClr val="322014"/>
+                </a:solidFill>
+              </a:defRPr>
+            </a:pPr>
+            <a:r>
+              <a:t>Profitable (≤20% discount)</a:t>
+            </a:r>
+          </a:p>
+        </p:txBody>
+      </p:sp>
+      <p:sp>
+        <p:nvSpPr>
+          <p:cNvPr id="21" name="Rectangle 20"/>
+          <p:cNvSpPr/>
+          <p:nvPr/>
+        </p:nvSpPr>
+        <p:spPr>
+          <a:xfrm>
+            <a:off x="3108960" y="5852160"/>
+            <a:ext cx="137160" cy="137160"/>
+          </a:xfrm>
+          <a:prstGeom prst="rect">
+            <a:avLst/>
+          </a:prstGeom>
+          <a:solidFill>
+            <a:srgbClr val="A22727"/>
+          </a:solidFill>
+          <a:ln>
+            <a:solidFill>
+              <a:srgbClr val="A22727"/>
+            </a:solidFill>
+          </a:ln>
+        </p:spPr>
+        <p:style>
+          <a:lnRef idx="1">
+            <a:schemeClr val="accent1"/>
+          </a:lnRef>
+          <a:fillRef idx="3">
+            <a:schemeClr val="accent1"/>
+          </a:fillRef>
+          <a:effectRef idx="2">
+            <a:schemeClr val="accent1"/>
+          </a:effectRef>
+          <a:fontRef idx="minor">
+            <a:schemeClr val="lt1"/>
+          </a:fontRef>
+        </p:style>
+        <p:txBody>
+          <a:bodyPr rtlCol="0" anchor="ctr"/>
+          <a:lstStyle/>
+          <a:p>
+            <a:pPr algn="ctr"/>
+          </a:p>
+        </p:txBody>
+      </p:sp>
+      <p:sp>
+        <p:nvSpPr>
+          <p:cNvPr id="22" name="TextBox 21"/>
+          <p:cNvSpPr txBox="1"/>
+          <p:nvPr/>
+        </p:nvSpPr>
+        <p:spPr>
+          <a:xfrm>
+            <a:off x="3291840" y="5806440"/>
+            <a:ext cx="2286000" cy="228600"/>
+          </a:xfrm>
+          <a:prstGeom prst="rect">
+            <a:avLst/>
+          </a:prstGeom>
+          <a:noFill/>
+        </p:spPr>
+        <p:txBody>
+          <a:bodyPr wrap="none">
+            <a:spAutoFit/>
+          </a:bodyPr>
+          <a:lstStyle/>
+          <a:p>
+            <a:pPr>
+              <a:defRPr sz="900">
+                <a:solidFill>
+                  <a:srgbClr val="322014"/>
+                </a:solidFill>
+              </a:defRPr>
+            </a:pPr>
+            <a:r>
+              <a:t>Operating deficit (&gt;20% discount)</a:t>
             </a:r>
           </a:p>
         </p:txBody>

</xml_diff>

<commit_message>
feat: major version update
</commit_message>
<xml_diff>
--- a/presentation/board_deck.pptx
+++ b/presentation/board_deck.pptx
@@ -2177,6 +2177,1781 @@
     <c:autoUpdate val="0"/>
   </c:externalData>
 </c:chartSpace>
+</file>
+
+<file path=ppt/notesMasters/notesMaster1.xml><?xml version="1.0" encoding="utf-8"?>
+<p:notesMaster xmlns:a="http://schemas.openxmlformats.org/drawingml/2006/main" xmlns:p="http://schemas.openxmlformats.org/presentationml/2006/main" xmlns:r="http://schemas.openxmlformats.org/officeDocument/2006/relationships">
+  <p:cSld>
+    <p:bg>
+      <p:bgRef idx="1001">
+        <a:schemeClr val="bg1"/>
+      </p:bgRef>
+    </p:bg>
+    <p:spTree>
+      <p:nvGrpSpPr>
+        <p:cNvPr id="1" name=""/>
+        <p:cNvGrpSpPr/>
+        <p:nvPr/>
+      </p:nvGrpSpPr>
+      <p:grpSpPr>
+        <a:xfrm>
+          <a:off x="0" y="0"/>
+          <a:ext cx="0" cy="0"/>
+          <a:chOff x="0" y="0"/>
+          <a:chExt cx="0" cy="0"/>
+        </a:xfrm>
+      </p:grpSpPr>
+      <p:sp>
+        <p:nvSpPr>
+          <p:cNvPr id="2" name="Header Placeholder 1"/>
+          <p:cNvSpPr>
+            <a:spLocks noGrp="1"/>
+          </p:cNvSpPr>
+          <p:nvPr>
+            <p:ph type="hdr" sz="quarter"/>
+          </p:nvPr>
+        </p:nvSpPr>
+        <p:spPr>
+          <a:xfrm>
+            <a:off x="0" y="0"/>
+            <a:ext cx="2971800" cy="457200"/>
+          </a:xfrm>
+          <a:prstGeom prst="rect">
+            <a:avLst/>
+          </a:prstGeom>
+        </p:spPr>
+        <p:txBody>
+          <a:bodyPr vert="horz" lIns="91440" tIns="45720" rIns="91440" bIns="45720" rtlCol="0"/>
+          <a:lstStyle>
+            <a:lvl1pPr algn="l">
+              <a:defRPr sz="1200"/>
+            </a:lvl1pPr>
+          </a:lstStyle>
+          <a:p>
+            <a:endParaRPr lang="en-US"/>
+          </a:p>
+        </p:txBody>
+      </p:sp>
+      <p:sp>
+        <p:nvSpPr>
+          <p:cNvPr id="3" name="Date Placeholder 2"/>
+          <p:cNvSpPr>
+            <a:spLocks noGrp="1"/>
+          </p:cNvSpPr>
+          <p:nvPr>
+            <p:ph type="dt" idx="1"/>
+          </p:nvPr>
+        </p:nvSpPr>
+        <p:spPr>
+          <a:xfrm>
+            <a:off x="3884613" y="0"/>
+            <a:ext cx="2971800" cy="457200"/>
+          </a:xfrm>
+          <a:prstGeom prst="rect">
+            <a:avLst/>
+          </a:prstGeom>
+        </p:spPr>
+        <p:txBody>
+          <a:bodyPr vert="horz" lIns="91440" tIns="45720" rIns="91440" bIns="45720" rtlCol="0"/>
+          <a:lstStyle>
+            <a:lvl1pPr algn="r">
+              <a:defRPr sz="1200"/>
+            </a:lvl1pPr>
+          </a:lstStyle>
+          <a:p>
+            <a:fld id="{0F89C1C7-3DCD-1040-A9CF-14679D8B5DDD}" type="datetimeFigureOut">
+              <a:rPr lang="en-US" smtClean="0"/>
+              <a:t>10/17/16</a:t>
+            </a:fld>
+            <a:endParaRPr lang="en-US"/>
+          </a:p>
+        </p:txBody>
+      </p:sp>
+      <p:sp>
+        <p:nvSpPr>
+          <p:cNvPr id="4" name="Slide Image Placeholder 3"/>
+          <p:cNvSpPr>
+            <a:spLocks noGrp="1" noRot="1" noChangeAspect="1"/>
+          </p:cNvSpPr>
+          <p:nvPr>
+            <p:ph type="sldImg" idx="2"/>
+          </p:nvPr>
+        </p:nvSpPr>
+        <p:spPr>
+          <a:xfrm>
+            <a:off x="1143000" y="685800"/>
+            <a:ext cx="4572000" cy="3429000"/>
+          </a:xfrm>
+          <a:prstGeom prst="rect">
+            <a:avLst/>
+          </a:prstGeom>
+          <a:noFill/>
+          <a:ln w="12700">
+            <a:solidFill>
+              <a:prstClr val="black"/>
+            </a:solidFill>
+          </a:ln>
+        </p:spPr>
+        <p:txBody>
+          <a:bodyPr vert="horz" lIns="91440" tIns="45720" rIns="91440" bIns="45720" rtlCol="0" anchor="ctr"/>
+          <a:lstStyle/>
+          <a:p>
+            <a:endParaRPr lang="en-US"/>
+          </a:p>
+        </p:txBody>
+      </p:sp>
+      <p:sp>
+        <p:nvSpPr>
+          <p:cNvPr id="5" name="Notes Placeholder 4"/>
+          <p:cNvSpPr>
+            <a:spLocks noGrp="1"/>
+          </p:cNvSpPr>
+          <p:nvPr>
+            <p:ph type="body" sz="quarter" idx="3"/>
+          </p:nvPr>
+        </p:nvSpPr>
+        <p:spPr>
+          <a:xfrm>
+            <a:off x="685800" y="4343400"/>
+            <a:ext cx="5486400" cy="4114800"/>
+          </a:xfrm>
+          <a:prstGeom prst="rect">
+            <a:avLst/>
+          </a:prstGeom>
+        </p:spPr>
+        <p:txBody>
+          <a:bodyPr vert="horz" lIns="91440" tIns="45720" rIns="91440" bIns="45720" rtlCol="0"/>
+          <a:lstStyle/>
+          <a:p>
+            <a:pPr lvl="0"/>
+            <a:r>
+              <a:rPr lang="en-US" smtClean="0"/>
+              <a:t>Click to edit Master text styles</a:t>
+            </a:r>
+          </a:p>
+          <a:p>
+            <a:pPr lvl="1"/>
+            <a:r>
+              <a:rPr lang="en-US" smtClean="0"/>
+              <a:t>Second level</a:t>
+            </a:r>
+          </a:p>
+          <a:p>
+            <a:pPr lvl="2"/>
+            <a:r>
+              <a:rPr lang="en-US" smtClean="0"/>
+              <a:t>Third level</a:t>
+            </a:r>
+          </a:p>
+          <a:p>
+            <a:pPr lvl="3"/>
+            <a:r>
+              <a:rPr lang="en-US" smtClean="0"/>
+              <a:t>Fourth level</a:t>
+            </a:r>
+          </a:p>
+          <a:p>
+            <a:pPr lvl="4"/>
+            <a:r>
+              <a:rPr lang="en-US" smtClean="0"/>
+              <a:t>Fifth level</a:t>
+            </a:r>
+            <a:endParaRPr lang="en-US"/>
+          </a:p>
+        </p:txBody>
+      </p:sp>
+      <p:sp>
+        <p:nvSpPr>
+          <p:cNvPr id="6" name="Footer Placeholder 5"/>
+          <p:cNvSpPr>
+            <a:spLocks noGrp="1"/>
+          </p:cNvSpPr>
+          <p:nvPr>
+            <p:ph type="ftr" sz="quarter" idx="4"/>
+          </p:nvPr>
+        </p:nvSpPr>
+        <p:spPr>
+          <a:xfrm>
+            <a:off x="0" y="8685213"/>
+            <a:ext cx="2971800" cy="457200"/>
+          </a:xfrm>
+          <a:prstGeom prst="rect">
+            <a:avLst/>
+          </a:prstGeom>
+        </p:spPr>
+        <p:txBody>
+          <a:bodyPr vert="horz" lIns="91440" tIns="45720" rIns="91440" bIns="45720" rtlCol="0" anchor="b"/>
+          <a:lstStyle>
+            <a:lvl1pPr algn="l">
+              <a:defRPr sz="1200"/>
+            </a:lvl1pPr>
+          </a:lstStyle>
+          <a:p>
+            <a:endParaRPr lang="en-US"/>
+          </a:p>
+        </p:txBody>
+      </p:sp>
+      <p:sp>
+        <p:nvSpPr>
+          <p:cNvPr id="7" name="Slide Number Placeholder 6"/>
+          <p:cNvSpPr>
+            <a:spLocks noGrp="1"/>
+          </p:cNvSpPr>
+          <p:nvPr>
+            <p:ph type="sldNum" sz="quarter" idx="5"/>
+          </p:nvPr>
+        </p:nvSpPr>
+        <p:spPr>
+          <a:xfrm>
+            <a:off x="3884613" y="8685213"/>
+            <a:ext cx="2971800" cy="457200"/>
+          </a:xfrm>
+          <a:prstGeom prst="rect">
+            <a:avLst/>
+          </a:prstGeom>
+        </p:spPr>
+        <p:txBody>
+          <a:bodyPr vert="horz" lIns="91440" tIns="45720" rIns="91440" bIns="45720" rtlCol="0" anchor="b"/>
+          <a:lstStyle>
+            <a:lvl1pPr algn="r">
+              <a:defRPr sz="1200"/>
+            </a:lvl1pPr>
+          </a:lstStyle>
+          <a:p>
+            <a:fld id="{BB5E49A5-4136-284D-997B-48E1D791AD67}" type="slidenum">
+              <a:rPr lang="en-US" smtClean="0"/>
+              <a:t>‹#›</a:t>
+            </a:fld>
+            <a:endParaRPr lang="en-US"/>
+          </a:p>
+        </p:txBody>
+      </p:sp>
+    </p:spTree>
+    <p:extLst>
+      <p:ext uri="{BB962C8B-B14F-4D97-AF65-F5344CB8AC3E}">
+        <p14:creationId xmlns:p14="http://schemas.microsoft.com/office/powerpoint/2010/main" val="2623252185"/>
+      </p:ext>
+    </p:extLst>
+  </p:cSld>
+  <p:clrMap bg1="lt1" tx1="dk1" bg2="lt2" tx2="dk2" accent1="accent1" accent2="accent2" accent3="accent3" accent4="accent4" accent5="accent5" accent6="accent6" hlink="hlink" folHlink="folHlink"/>
+  <p:notesStyle>
+    <a:lvl1pPr marL="0" algn="l" defTabSz="457200" rtl="0" eaLnBrk="1" latinLnBrk="0" hangingPunct="1">
+      <a:defRPr sz="1200" kern="1200">
+        <a:solidFill>
+          <a:schemeClr val="tx1"/>
+        </a:solidFill>
+        <a:latin typeface="+mn-lt"/>
+        <a:ea typeface="+mn-ea"/>
+        <a:cs typeface="+mn-cs"/>
+      </a:defRPr>
+    </a:lvl1pPr>
+    <a:lvl2pPr marL="457200" algn="l" defTabSz="457200" rtl="0" eaLnBrk="1" latinLnBrk="0" hangingPunct="1">
+      <a:defRPr sz="1200" kern="1200">
+        <a:solidFill>
+          <a:schemeClr val="tx1"/>
+        </a:solidFill>
+        <a:latin typeface="+mn-lt"/>
+        <a:ea typeface="+mn-ea"/>
+        <a:cs typeface="+mn-cs"/>
+      </a:defRPr>
+    </a:lvl2pPr>
+    <a:lvl3pPr marL="914400" algn="l" defTabSz="457200" rtl="0" eaLnBrk="1" latinLnBrk="0" hangingPunct="1">
+      <a:defRPr sz="1200" kern="1200">
+        <a:solidFill>
+          <a:schemeClr val="tx1"/>
+        </a:solidFill>
+        <a:latin typeface="+mn-lt"/>
+        <a:ea typeface="+mn-ea"/>
+        <a:cs typeface="+mn-cs"/>
+      </a:defRPr>
+    </a:lvl3pPr>
+    <a:lvl4pPr marL="1371600" algn="l" defTabSz="457200" rtl="0" eaLnBrk="1" latinLnBrk="0" hangingPunct="1">
+      <a:defRPr sz="1200" kern="1200">
+        <a:solidFill>
+          <a:schemeClr val="tx1"/>
+        </a:solidFill>
+        <a:latin typeface="+mn-lt"/>
+        <a:ea typeface="+mn-ea"/>
+        <a:cs typeface="+mn-cs"/>
+      </a:defRPr>
+    </a:lvl4pPr>
+    <a:lvl5pPr marL="1828800" algn="l" defTabSz="457200" rtl="0" eaLnBrk="1" latinLnBrk="0" hangingPunct="1">
+      <a:defRPr sz="1200" kern="1200">
+        <a:solidFill>
+          <a:schemeClr val="tx1"/>
+        </a:solidFill>
+        <a:latin typeface="+mn-lt"/>
+        <a:ea typeface="+mn-ea"/>
+        <a:cs typeface="+mn-cs"/>
+      </a:defRPr>
+    </a:lvl5pPr>
+    <a:lvl6pPr marL="2286000" algn="l" defTabSz="457200" rtl="0" eaLnBrk="1" latinLnBrk="0" hangingPunct="1">
+      <a:defRPr sz="1200" kern="1200">
+        <a:solidFill>
+          <a:schemeClr val="tx1"/>
+        </a:solidFill>
+        <a:latin typeface="+mn-lt"/>
+        <a:ea typeface="+mn-ea"/>
+        <a:cs typeface="+mn-cs"/>
+      </a:defRPr>
+    </a:lvl6pPr>
+    <a:lvl7pPr marL="2743200" algn="l" defTabSz="457200" rtl="0" eaLnBrk="1" latinLnBrk="0" hangingPunct="1">
+      <a:defRPr sz="1200" kern="1200">
+        <a:solidFill>
+          <a:schemeClr val="tx1"/>
+        </a:solidFill>
+        <a:latin typeface="+mn-lt"/>
+        <a:ea typeface="+mn-ea"/>
+        <a:cs typeface="+mn-cs"/>
+      </a:defRPr>
+    </a:lvl7pPr>
+    <a:lvl8pPr marL="3200400" algn="l" defTabSz="457200" rtl="0" eaLnBrk="1" latinLnBrk="0" hangingPunct="1">
+      <a:defRPr sz="1200" kern="1200">
+        <a:solidFill>
+          <a:schemeClr val="tx1"/>
+        </a:solidFill>
+        <a:latin typeface="+mn-lt"/>
+        <a:ea typeface="+mn-ea"/>
+        <a:cs typeface="+mn-cs"/>
+      </a:defRPr>
+    </a:lvl8pPr>
+    <a:lvl9pPr marL="3657600" algn="l" defTabSz="457200" rtl="0" eaLnBrk="1" latinLnBrk="0" hangingPunct="1">
+      <a:defRPr sz="1200" kern="1200">
+        <a:solidFill>
+          <a:schemeClr val="tx1"/>
+        </a:solidFill>
+        <a:latin typeface="+mn-lt"/>
+        <a:ea typeface="+mn-ea"/>
+        <a:cs typeface="+mn-cs"/>
+      </a:defRPr>
+    </a:lvl9pPr>
+  </p:notesStyle>
+</p:notesMaster>
+</file>
+
+<file path=ppt/notesSlides/notesSlide1.xml><?xml version="1.0" encoding="utf-8"?>
+<p:notes xmlns:a="http://schemas.openxmlformats.org/drawingml/2006/main" xmlns:p="http://schemas.openxmlformats.org/presentationml/2006/main" xmlns:r="http://schemas.openxmlformats.org/officeDocument/2006/relationships">
+  <p:cSld>
+    <p:spTree>
+      <p:nvGrpSpPr>
+        <p:cNvPr id="1" name=""/>
+        <p:cNvGrpSpPr/>
+        <p:nvPr/>
+      </p:nvGrpSpPr>
+      <p:grpSpPr>
+        <a:xfrm>
+          <a:off x="0" y="0"/>
+          <a:ext cx="0" cy="0"/>
+          <a:chOff x="0" y="0"/>
+          <a:chExt cx="0" cy="0"/>
+        </a:xfrm>
+      </p:grpSpPr>
+      <p:sp>
+        <p:nvSpPr>
+          <p:cNvPr id="2" name="Slide Image Placeholder 1"/>
+          <p:cNvSpPr>
+            <a:spLocks noGrp="1"/>
+          </p:cNvSpPr>
+          <p:nvPr>
+            <p:ph type="sldImg" idx="2"/>
+          </p:nvPr>
+        </p:nvSpPr>
+        <p:spPr/>
+      </p:sp>
+      <p:sp>
+        <p:nvSpPr>
+          <p:cNvPr id="3" name="Notes Placeholder 2"/>
+          <p:cNvSpPr>
+            <a:spLocks noGrp="1"/>
+          </p:cNvSpPr>
+          <p:nvPr>
+            <p:ph type="body" idx="3" sz="quarter"/>
+          </p:nvPr>
+        </p:nvSpPr>
+        <p:spPr/>
+        <p:txBody>
+          <a:bodyPr/>
+          <a:lstStyle/>
+          <a:p>
+            <a:r>
+              <a:t>[0:30 - Slide 1 of 17]</a:t>
+            </a:r>
+          </a:p>
+          <a:p>
+            <a:r>
+              <a:t>SAY: "Good morning. Four years of transaction data - 51,290 order lines - and one finding: Global Superstore does not have a growth problem. It has a pricing problem. In the next ten minutes we will show you exactly where the profit leaks, and a three-lever plan that recovers $1.23M without a dollar of new capital."</a:t>
+            </a:r>
+          </a:p>
+          <a:p>
+            <a:r>
+              <a:t>DELIVERY: One line of team intro - Syndicate 6, seven analysts - then move. Do not read the roster aloud.</a:t>
+            </a:r>
+          </a:p>
+          <a:p>
+            <a:r>
+              <a:t>TRANSITION: "Let us start with the headline number."</a:t>
+            </a:r>
+          </a:p>
+        </p:txBody>
+      </p:sp>
+      <p:sp>
+        <p:nvSpPr>
+          <p:cNvPr id="4" name="Slide Number Placeholder 3"/>
+          <p:cNvSpPr>
+            <a:spLocks noGrp="1"/>
+          </p:cNvSpPr>
+          <p:nvPr>
+            <p:ph type="sldNum" idx="5" sz="quarter"/>
+          </p:nvPr>
+        </p:nvSpPr>
+        <p:spPr/>
+      </p:sp>
+    </p:spTree>
+  </p:cSld>
+  <p:clrMapOvr>
+    <a:masterClrMapping/>
+  </p:clrMapOvr>
+</p:notes>
+</file>
+
+<file path=ppt/notesSlides/notesSlide10.xml><?xml version="1.0" encoding="utf-8"?>
+<p:notes xmlns:a="http://schemas.openxmlformats.org/drawingml/2006/main" xmlns:p="http://schemas.openxmlformats.org/presentationml/2006/main" xmlns:r="http://schemas.openxmlformats.org/officeDocument/2006/relationships">
+  <p:cSld>
+    <p:spTree>
+      <p:nvGrpSpPr>
+        <p:cNvPr id="1" name=""/>
+        <p:cNvGrpSpPr/>
+        <p:nvPr/>
+      </p:nvGrpSpPr>
+      <p:grpSpPr>
+        <a:xfrm>
+          <a:off x="0" y="0"/>
+          <a:ext cx="0" cy="0"/>
+          <a:chOff x="0" y="0"/>
+          <a:chExt cx="0" cy="0"/>
+        </a:xfrm>
+      </p:grpSpPr>
+      <p:sp>
+        <p:nvSpPr>
+          <p:cNvPr id="2" name="Slide Image Placeholder 1"/>
+          <p:cNvSpPr>
+            <a:spLocks noGrp="1"/>
+          </p:cNvSpPr>
+          <p:nvPr>
+            <p:ph type="sldImg" idx="2"/>
+          </p:nvPr>
+        </p:nvSpPr>
+        <p:spPr/>
+      </p:sp>
+      <p:sp>
+        <p:nvSpPr>
+          <p:cNvPr id="3" name="Notes Placeholder 2"/>
+          <p:cNvSpPr>
+            <a:spLocks noGrp="1"/>
+          </p:cNvSpPr>
+          <p:nvPr>
+            <p:ph type="body" idx="3" sz="quarter"/>
+          </p:nvPr>
+        </p:nvSpPr>
+        <p:spPr/>
+        <p:txBody>
+          <a:bodyPr/>
+          <a:lstStyle/>
+          <a:p>
+            <a:r>
+              <a:t>[0:30 - Slide 10 of 17]</a:t>
+            </a:r>
+          </a:p>
+          <a:p>
+            <a:r>
+              <a:t>SAY: Three root causes, all policy, none market-driven. Uncontrolled discounting, worth +$1.03M to fix. Loss-making overseas territories served direct, +$0.18M. Bulky Tables freight never billed, +$0.05M. Recovery exceeds the reported $921K leak because capping discounts returns those lines to positive margin - not just to break-even.</a:t>
+            </a:r>
+          </a:p>
+          <a:p>
+            <a:r>
+              <a:t>TRANSITION: "Before we commit to this plan - what else did we consider?"</a:t>
+            </a:r>
+          </a:p>
+        </p:txBody>
+      </p:sp>
+      <p:sp>
+        <p:nvSpPr>
+          <p:cNvPr id="4" name="Slide Number Placeholder 3"/>
+          <p:cNvSpPr>
+            <a:spLocks noGrp="1"/>
+          </p:cNvSpPr>
+          <p:nvPr>
+            <p:ph type="sldNum" idx="5" sz="quarter"/>
+          </p:nvPr>
+        </p:nvSpPr>
+        <p:spPr/>
+      </p:sp>
+    </p:spTree>
+  </p:cSld>
+  <p:clrMapOvr>
+    <a:masterClrMapping/>
+  </p:clrMapOvr>
+</p:notes>
+</file>
+
+<file path=ppt/notesSlides/notesSlide11.xml><?xml version="1.0" encoding="utf-8"?>
+<p:notes xmlns:a="http://schemas.openxmlformats.org/drawingml/2006/main" xmlns:p="http://schemas.openxmlformats.org/presentationml/2006/main" xmlns:r="http://schemas.openxmlformats.org/officeDocument/2006/relationships">
+  <p:cSld>
+    <p:spTree>
+      <p:nvGrpSpPr>
+        <p:cNvPr id="1" name=""/>
+        <p:cNvGrpSpPr/>
+        <p:nvPr/>
+      </p:nvGrpSpPr>
+      <p:grpSpPr>
+        <a:xfrm>
+          <a:off x="0" y="0"/>
+          <a:ext cx="0" cy="0"/>
+          <a:chOff x="0" y="0"/>
+          <a:chExt cx="0" cy="0"/>
+        </a:xfrm>
+      </p:grpSpPr>
+      <p:sp>
+        <p:nvSpPr>
+          <p:cNvPr id="2" name="Slide Image Placeholder 1"/>
+          <p:cNvSpPr>
+            <a:spLocks noGrp="1"/>
+          </p:cNvSpPr>
+          <p:nvPr>
+            <p:ph type="sldImg" idx="2"/>
+          </p:nvPr>
+        </p:nvSpPr>
+        <p:spPr/>
+      </p:sp>
+      <p:sp>
+        <p:nvSpPr>
+          <p:cNvPr id="3" name="Notes Placeholder 2"/>
+          <p:cNvSpPr>
+            <a:spLocks noGrp="1"/>
+          </p:cNvSpPr>
+          <p:nvPr>
+            <p:ph type="body" idx="3" sz="quarter"/>
+          </p:nvPr>
+        </p:nvSpPr>
+        <p:spPr/>
+        <p:txBody>
+          <a:bodyPr/>
+          <a:lstStyle/>
+          <a:p>
+            <a:r>
+              <a:t>[0:45 - Slide 11 of 17]</a:t>
+            </a:r>
+          </a:p>
+          <a:p>
+            <a:r>
+              <a:t>SAY: Three alternatives, three eliminations. First: raise list prices and allow deeper discounts - rejected, because the leak follows the discount depth, not the list price: 88.5% of loss dollars sit above the 20% line, so a bigger cap re-opens the wound. Second: exit Turkey and Nigeria - rejected: it forfeits $163K of revenue; 3PL removes the same $179K loss while keeping every sale. Third: renegotiate all carrier rates - demoted to support: a realistic 10% cut returns about $0.14M after a year of contracting and never touches the $814,682 discount leak.</a:t>
+            </a:r>
+          </a:p>
+          <a:p>
+            <a:r>
+              <a:t>IF ASKED "why not raise prices anyway?": A price rise hits our 75.5% healthy lines too. The cap only touches the 22% that lose money.</a:t>
+            </a:r>
+          </a:p>
+          <a:p>
+            <a:r>
+              <a:t>TRANSITION: "That leaves the three-lever plan - here it is."</a:t>
+            </a:r>
+          </a:p>
+        </p:txBody>
+      </p:sp>
+      <p:sp>
+        <p:nvSpPr>
+          <p:cNvPr id="4" name="Slide Number Placeholder 3"/>
+          <p:cNvSpPr>
+            <a:spLocks noGrp="1"/>
+          </p:cNvSpPr>
+          <p:nvPr>
+            <p:ph type="sldNum" idx="5" sz="quarter"/>
+          </p:nvPr>
+        </p:nvSpPr>
+        <p:spPr/>
+      </p:sp>
+    </p:spTree>
+  </p:cSld>
+  <p:clrMapOvr>
+    <a:masterClrMapping/>
+  </p:clrMapOvr>
+</p:notes>
+</file>
+
+<file path=ppt/notesSlides/notesSlide12.xml><?xml version="1.0" encoding="utf-8"?>
+<p:notes xmlns:a="http://schemas.openxmlformats.org/drawingml/2006/main" xmlns:p="http://schemas.openxmlformats.org/presentationml/2006/main" xmlns:r="http://schemas.openxmlformats.org/officeDocument/2006/relationships">
+  <p:cSld>
+    <p:spTree>
+      <p:nvGrpSpPr>
+        <p:cNvPr id="1" name=""/>
+        <p:cNvGrpSpPr/>
+        <p:nvPr/>
+      </p:nvGrpSpPr>
+      <p:grpSpPr>
+        <a:xfrm>
+          <a:off x="0" y="0"/>
+          <a:ext cx="0" cy="0"/>
+          <a:chOff x="0" y="0"/>
+          <a:chExt cx="0" cy="0"/>
+        </a:xfrm>
+      </p:grpSpPr>
+      <p:sp>
+        <p:nvSpPr>
+          <p:cNvPr id="2" name="Slide Image Placeholder 1"/>
+          <p:cNvSpPr>
+            <a:spLocks noGrp="1"/>
+          </p:cNvSpPr>
+          <p:nvPr>
+            <p:ph type="sldImg" idx="2"/>
+          </p:nvPr>
+        </p:nvSpPr>
+        <p:spPr/>
+      </p:sp>
+      <p:sp>
+        <p:nvSpPr>
+          <p:cNvPr id="3" name="Notes Placeholder 2"/>
+          <p:cNvSpPr>
+            <a:spLocks noGrp="1"/>
+          </p:cNvSpPr>
+          <p:nvPr>
+            <p:ph type="body" idx="3" sz="quarter"/>
+          </p:nvPr>
+        </p:nvSpPr>
+        <p:spPr/>
+        <p:txBody>
+          <a:bodyPr/>
+          <a:lstStyle/>
+          <a:p>
+            <a:r>
+              <a:t>[0:45 - Slide 12 of 17]</a:t>
+            </a:r>
+          </a:p>
+          <a:p>
+            <a:r>
+              <a:t>SAY: Three initiatives, each with an owner and a date. One: pricing governance - a hard 20% cap in order entry - Chief Commercial Officer, months 1-2, +$1.03M. Two: Turkey and Nigeria restructured to bonded third-party logistics - VP Global Supply Chain, months 3-4, +$0.18M. Three: Tables freight pass-through and repricing - Head of Merchandising, months 5-7, +$0.05M. Note the KPI column: the first one is "no order above 15% discount below 2% of orders".</a:t>
+            </a:r>
+          </a:p>
+          <a:p>
+            <a:r>
+              <a:t>TRANSITION: "Net of churn, here is the money."</a:t>
+            </a:r>
+          </a:p>
+        </p:txBody>
+      </p:sp>
+      <p:sp>
+        <p:nvSpPr>
+          <p:cNvPr id="4" name="Slide Number Placeholder 3"/>
+          <p:cNvSpPr>
+            <a:spLocks noGrp="1"/>
+          </p:cNvSpPr>
+          <p:nvPr>
+            <p:ph type="sldNum" idx="5" sz="quarter"/>
+          </p:nvPr>
+        </p:nvSpPr>
+        <p:spPr/>
+      </p:sp>
+    </p:spTree>
+  </p:cSld>
+  <p:clrMapOvr>
+    <a:masterClrMapping/>
+  </p:clrMapOvr>
+</p:notes>
+</file>
+
+<file path=ppt/notesSlides/notesSlide13.xml><?xml version="1.0" encoding="utf-8"?>
+<p:notes xmlns:a="http://schemas.openxmlformats.org/drawingml/2006/main" xmlns:p="http://schemas.openxmlformats.org/presentationml/2006/main" xmlns:r="http://schemas.openxmlformats.org/officeDocument/2006/relationships">
+  <p:cSld>
+    <p:spTree>
+      <p:nvGrpSpPr>
+        <p:cNvPr id="1" name=""/>
+        <p:cNvGrpSpPr/>
+        <p:nvPr/>
+      </p:nvGrpSpPr>
+      <p:grpSpPr>
+        <a:xfrm>
+          <a:off x="0" y="0"/>
+          <a:ext cx="0" cy="0"/>
+          <a:chOff x="0" y="0"/>
+          <a:chExt cx="0" cy="0"/>
+        </a:xfrm>
+      </p:grpSpPr>
+      <p:sp>
+        <p:nvSpPr>
+          <p:cNvPr id="2" name="Slide Image Placeholder 1"/>
+          <p:cNvSpPr>
+            <a:spLocks noGrp="1"/>
+          </p:cNvSpPr>
+          <p:nvPr>
+            <p:ph type="sldImg" idx="2"/>
+          </p:nvPr>
+        </p:nvSpPr>
+        <p:spPr/>
+      </p:sp>
+      <p:sp>
+        <p:nvSpPr>
+          <p:cNvPr id="3" name="Notes Placeholder 2"/>
+          <p:cNvSpPr>
+            <a:spLocks noGrp="1"/>
+          </p:cNvSpPr>
+          <p:nvPr>
+            <p:ph type="body" idx="3" sz="quarter"/>
+          </p:nvPr>
+        </p:nvSpPr>
+        <p:spPr/>
+        <p:txBody>
+          <a:bodyPr/>
+          <a:lstStyle/>
+          <a:p>
+            <a:r>
+              <a:t>[0:30 - Slide 13 of 17]</a:t>
+            </a:r>
+          </a:p>
+          <a:p>
+            <a:r>
+              <a:t>SAY: From $1.47M baseline: plus $1.03M from the cap, plus $0.18M from 3PL, plus $0.05M freight, minus $0.02M for a 5% churn allowance - landing at $2.70M projected. Margin moves from 11.6% to 19.9%. That is about $0.31M a year on the same run-rate.</a:t>
+            </a:r>
+          </a:p>
+          <a:p>
+            <a:r>
+              <a:t>IF ASKED about the 5% churn: It is a deliberate penalty for price-sensitive buyers who walk. The stress test on the next slide shows we are robust even at 7%.</a:t>
+            </a:r>
+          </a:p>
+          <a:p>
+            <a:r>
+              <a:t>TRANSITION: "And the plan holds under stress."</a:t>
+            </a:r>
+          </a:p>
+        </p:txBody>
+      </p:sp>
+      <p:sp>
+        <p:nvSpPr>
+          <p:cNvPr id="4" name="Slide Number Placeholder 3"/>
+          <p:cNvSpPr>
+            <a:spLocks noGrp="1"/>
+          </p:cNvSpPr>
+          <p:nvPr>
+            <p:ph type="sldNum" idx="5" sz="quarter"/>
+          </p:nvPr>
+        </p:nvSpPr>
+        <p:spPr/>
+      </p:sp>
+    </p:spTree>
+  </p:cSld>
+  <p:clrMapOvr>
+    <a:masterClrMapping/>
+  </p:clrMapOvr>
+</p:notes>
+</file>
+
+<file path=ppt/notesSlides/notesSlide14.xml><?xml version="1.0" encoding="utf-8"?>
+<p:notes xmlns:a="http://schemas.openxmlformats.org/drawingml/2006/main" xmlns:p="http://schemas.openxmlformats.org/presentationml/2006/main" xmlns:r="http://schemas.openxmlformats.org/officeDocument/2006/relationships">
+  <p:cSld>
+    <p:spTree>
+      <p:nvGrpSpPr>
+        <p:cNvPr id="1" name=""/>
+        <p:cNvGrpSpPr/>
+        <p:nvPr/>
+      </p:nvGrpSpPr>
+      <p:grpSpPr>
+        <a:xfrm>
+          <a:off x="0" y="0"/>
+          <a:ext cx="0" cy="0"/>
+          <a:chOff x="0" y="0"/>
+          <a:chExt cx="0" cy="0"/>
+        </a:xfrm>
+      </p:grpSpPr>
+      <p:sp>
+        <p:nvSpPr>
+          <p:cNvPr id="2" name="Slide Image Placeholder 1"/>
+          <p:cNvSpPr>
+            <a:spLocks noGrp="1"/>
+          </p:cNvSpPr>
+          <p:nvPr>
+            <p:ph type="sldImg" idx="2"/>
+          </p:nvPr>
+        </p:nvSpPr>
+        <p:spPr/>
+      </p:sp>
+      <p:sp>
+        <p:nvSpPr>
+          <p:cNvPr id="3" name="Notes Placeholder 2"/>
+          <p:cNvSpPr>
+            <a:spLocks noGrp="1"/>
+          </p:cNvSpPr>
+          <p:nvPr>
+            <p:ph type="body" idx="3" sz="quarter"/>
+          </p:nvPr>
+        </p:nvSpPr>
+        <p:spPr/>
+        <p:txBody>
+          <a:bodyPr/>
+          <a:lstStyle/>
+          <a:p>
+            <a:r>
+              <a:t>[0:30 - Slide 14 of 17]</a:t>
+            </a:r>
+          </a:p>
+          <a:p>
+            <a:r>
+              <a:t>SAY: The conservative case - a 25% cap, no surcharge, 7% churn, half the 3PL transition - still lifts profit +$0.91M to $2.37M. The aggressive case reaches $3.0M. The recommendation does not depend on optimism; every scenario beats the status quo decisively.</a:t>
+            </a:r>
+          </a:p>
+          <a:p>
+            <a:r>
+              <a:t>TRANSITION: "Execution is a four-phase, twelve-month program."</a:t>
+            </a:r>
+          </a:p>
+        </p:txBody>
+      </p:sp>
+      <p:sp>
+        <p:nvSpPr>
+          <p:cNvPr id="4" name="Slide Number Placeholder 3"/>
+          <p:cNvSpPr>
+            <a:spLocks noGrp="1"/>
+          </p:cNvSpPr>
+          <p:nvPr>
+            <p:ph type="sldNum" idx="5" sz="quarter"/>
+          </p:nvPr>
+        </p:nvSpPr>
+        <p:spPr/>
+      </p:sp>
+    </p:spTree>
+  </p:cSld>
+  <p:clrMapOvr>
+    <a:masterClrMapping/>
+  </p:clrMapOvr>
+</p:notes>
+</file>
+
+<file path=ppt/notesSlides/notesSlide15.xml><?xml version="1.0" encoding="utf-8"?>
+<p:notes xmlns:a="http://schemas.openxmlformats.org/drawingml/2006/main" xmlns:p="http://schemas.openxmlformats.org/presentationml/2006/main" xmlns:r="http://schemas.openxmlformats.org/officeDocument/2006/relationships">
+  <p:cSld>
+    <p:spTree>
+      <p:nvGrpSpPr>
+        <p:cNvPr id="1" name=""/>
+        <p:cNvGrpSpPr/>
+        <p:nvPr/>
+      </p:nvGrpSpPr>
+      <p:grpSpPr>
+        <a:xfrm>
+          <a:off x="0" y="0"/>
+          <a:ext cx="0" cy="0"/>
+          <a:chOff x="0" y="0"/>
+          <a:chExt cx="0" cy="0"/>
+        </a:xfrm>
+      </p:grpSpPr>
+      <p:sp>
+        <p:nvSpPr>
+          <p:cNvPr id="2" name="Slide Image Placeholder 1"/>
+          <p:cNvSpPr>
+            <a:spLocks noGrp="1"/>
+          </p:cNvSpPr>
+          <p:nvPr>
+            <p:ph type="sldImg" idx="2"/>
+          </p:nvPr>
+        </p:nvSpPr>
+        <p:spPr/>
+      </p:sp>
+      <p:sp>
+        <p:nvSpPr>
+          <p:cNvPr id="3" name="Notes Placeholder 2"/>
+          <p:cNvSpPr>
+            <a:spLocks noGrp="1"/>
+          </p:cNvSpPr>
+          <p:nvPr>
+            <p:ph type="body" idx="3" sz="quarter"/>
+          </p:nvPr>
+        </p:nvSpPr>
+        <p:spPr/>
+        <p:txBody>
+          <a:bodyPr/>
+          <a:lstStyle/>
+          <a:p>
+            <a:r>
+              <a:t>[0:30 - Slide 15 of 17]</a:t>
+            </a:r>
+          </a:p>
+          <a:p>
+            <a:r>
+              <a:t>SAY: Phase 1, months 1-2, is an order-entry rule - no capital, no new systems. Phase 2, months 3-4, cuts the regional loss by 70%. Phase 3, months 5-7, brings Tables back to break-even. Phase 4, months 8-12, makes it permanent: quarterly margin audits and a standing margin committee, with company margin above 15.5% as the exit target.</a:t>
+            </a:r>
+          </a:p>
+          <a:p>
+            <a:r>
+              <a:t>TRANSITION: "Which brings us to the three approvals we need today."</a:t>
+            </a:r>
+          </a:p>
+        </p:txBody>
+      </p:sp>
+      <p:sp>
+        <p:nvSpPr>
+          <p:cNvPr id="4" name="Slide Number Placeholder 3"/>
+          <p:cNvSpPr>
+            <a:spLocks noGrp="1"/>
+          </p:cNvSpPr>
+          <p:nvPr>
+            <p:ph type="sldNum" idx="5" sz="quarter"/>
+          </p:nvPr>
+        </p:nvSpPr>
+        <p:spPr/>
+      </p:sp>
+    </p:spTree>
+  </p:cSld>
+  <p:clrMapOvr>
+    <a:masterClrMapping/>
+  </p:clrMapOvr>
+</p:notes>
+</file>
+
+<file path=ppt/notesSlides/notesSlide16.xml><?xml version="1.0" encoding="utf-8"?>
+<p:notes xmlns:a="http://schemas.openxmlformats.org/drawingml/2006/main" xmlns:p="http://schemas.openxmlformats.org/presentationml/2006/main" xmlns:r="http://schemas.openxmlformats.org/officeDocument/2006/relationships">
+  <p:cSld>
+    <p:spTree>
+      <p:nvGrpSpPr>
+        <p:cNvPr id="1" name=""/>
+        <p:cNvGrpSpPr/>
+        <p:nvPr/>
+      </p:nvGrpSpPr>
+      <p:grpSpPr>
+        <a:xfrm>
+          <a:off x="0" y="0"/>
+          <a:ext cx="0" cy="0"/>
+          <a:chOff x="0" y="0"/>
+          <a:chExt cx="0" cy="0"/>
+        </a:xfrm>
+      </p:grpSpPr>
+      <p:sp>
+        <p:nvSpPr>
+          <p:cNvPr id="2" name="Slide Image Placeholder 1"/>
+          <p:cNvSpPr>
+            <a:spLocks noGrp="1"/>
+          </p:cNvSpPr>
+          <p:nvPr>
+            <p:ph type="sldImg" idx="2"/>
+          </p:nvPr>
+        </p:nvSpPr>
+        <p:spPr/>
+      </p:sp>
+      <p:sp>
+        <p:nvSpPr>
+          <p:cNvPr id="3" name="Notes Placeholder 2"/>
+          <p:cNvSpPr>
+            <a:spLocks noGrp="1"/>
+          </p:cNvSpPr>
+          <p:nvPr>
+            <p:ph type="body" idx="3" sz="quarter"/>
+          </p:nvPr>
+        </p:nvSpPr>
+        <p:spPr/>
+        <p:txBody>
+          <a:bodyPr/>
+          <a:lstStyle/>
+          <a:p>
+            <a:r>
+              <a:t>[0:30 - Slide 16 of 17]</a:t>
+            </a:r>
+          </a:p>
+          <a:p>
+            <a:r>
+              <a:t>SAY: Three decisions. Approve the 20% discount cap with VP sign-off between 15% and 20% and a hard block above 20%. Authorize the 3PL transition for Turkey and Nigeria. Charter a margin committee chaired by the CFO. Zero new capital; first savings inside 90 days; +$1.23M and a 19.9% margin on the full ledger.</a:t>
+            </a:r>
+          </a:p>
+          <a:p>
+            <a:r>
+              <a:t>IF ASKED "what if we only approve the cap?": The cap alone delivers $1.03M of the $1.23M - but the territories keep bleeding $179K, so we would be back asking for phase 2 within the year.</a:t>
+            </a:r>
+          </a:p>
+          <a:p>
+            <a:r>
+              <a:t>TRANSITION: "Thank you - we are ready for your questions."</a:t>
+            </a:r>
+          </a:p>
+        </p:txBody>
+      </p:sp>
+      <p:sp>
+        <p:nvSpPr>
+          <p:cNvPr id="4" name="Slide Number Placeholder 3"/>
+          <p:cNvSpPr>
+            <a:spLocks noGrp="1"/>
+          </p:cNvSpPr>
+          <p:nvPr>
+            <p:ph type="sldNum" idx="5" sz="quarter"/>
+          </p:nvPr>
+        </p:nvSpPr>
+        <p:spPr/>
+      </p:sp>
+    </p:spTree>
+  </p:cSld>
+  <p:clrMapOvr>
+    <a:masterClrMapping/>
+  </p:clrMapOvr>
+</p:notes>
+</file>
+
+<file path=ppt/notesSlides/notesSlide17.xml><?xml version="1.0" encoding="utf-8"?>
+<p:notes xmlns:a="http://schemas.openxmlformats.org/drawingml/2006/main" xmlns:p="http://schemas.openxmlformats.org/presentationml/2006/main" xmlns:r="http://schemas.openxmlformats.org/officeDocument/2006/relationships">
+  <p:cSld>
+    <p:spTree>
+      <p:nvGrpSpPr>
+        <p:cNvPr id="1" name=""/>
+        <p:cNvGrpSpPr/>
+        <p:nvPr/>
+      </p:nvGrpSpPr>
+      <p:grpSpPr>
+        <a:xfrm>
+          <a:off x="0" y="0"/>
+          <a:ext cx="0" cy="0"/>
+          <a:chOff x="0" y="0"/>
+          <a:chExt cx="0" cy="0"/>
+        </a:xfrm>
+      </p:grpSpPr>
+      <p:sp>
+        <p:nvSpPr>
+          <p:cNvPr id="2" name="Slide Image Placeholder 1"/>
+          <p:cNvSpPr>
+            <a:spLocks noGrp="1"/>
+          </p:cNvSpPr>
+          <p:nvPr>
+            <p:ph type="sldImg" idx="2"/>
+          </p:nvPr>
+        </p:nvSpPr>
+        <p:spPr/>
+      </p:sp>
+      <p:sp>
+        <p:nvSpPr>
+          <p:cNvPr id="3" name="Notes Placeholder 2"/>
+          <p:cNvSpPr>
+            <a:spLocks noGrp="1"/>
+          </p:cNvSpPr>
+          <p:nvPr>
+            <p:ph type="body" idx="3" sz="quarter"/>
+          </p:nvPr>
+        </p:nvSpPr>
+        <p:spPr/>
+        <p:txBody>
+          <a:bodyPr/>
+          <a:lstStyle/>
+          <a:p>
+            <a:r>
+              <a:t>[0:15 - Slide 17 of 17]</a:t>
+            </a:r>
+          </a:p>
+          <a:p>
+            <a:r>
+              <a:t>SAY: Close on the quote, then: "The ship is taking on $921K a year. We know exactly where the leak is, and the repair is three decisions - not a rescue plan. We recommend approval this quarter."</a:t>
+            </a:r>
+          </a:p>
+          <a:p>
+            <a:r>
+              <a:t>Q&amp;A PREP - the three toughest questions:</a:t>
+            </a:r>
+          </a:p>
+          <a:p>
+            <a:r>
+              <a:t>1. "Is 5% churn not optimistic?" - Conservative case carries 7% churn and still returns +$0.91M (slide 14).</a:t>
+            </a:r>
+          </a:p>
+          <a:p>
+            <a:r>
+              <a:t>2. "Why not simply raise prices?" - The leak follows discount depth, not list price; 88.5% of losses sit above the 20% cap (slide 11).</a:t>
+            </a:r>
+          </a:p>
+          <a:p>
+            <a:r>
+              <a:t>3. "3PL execution risk in volatile markets?" - Phased and reversible per country, bonded master distributors, break-even KPI inside 90 days (slide 12).</a:t>
+            </a:r>
+          </a:p>
+        </p:txBody>
+      </p:sp>
+      <p:sp>
+        <p:nvSpPr>
+          <p:cNvPr id="4" name="Slide Number Placeholder 3"/>
+          <p:cNvSpPr>
+            <a:spLocks noGrp="1"/>
+          </p:cNvSpPr>
+          <p:nvPr>
+            <p:ph type="sldNum" idx="5" sz="quarter"/>
+          </p:nvPr>
+        </p:nvSpPr>
+        <p:spPr/>
+      </p:sp>
+    </p:spTree>
+  </p:cSld>
+  <p:clrMapOvr>
+    <a:masterClrMapping/>
+  </p:clrMapOvr>
+</p:notes>
+</file>
+
+<file path=ppt/notesSlides/notesSlide2.xml><?xml version="1.0" encoding="utf-8"?>
+<p:notes xmlns:a="http://schemas.openxmlformats.org/drawingml/2006/main" xmlns:p="http://schemas.openxmlformats.org/presentationml/2006/main" xmlns:r="http://schemas.openxmlformats.org/officeDocument/2006/relationships">
+  <p:cSld>
+    <p:spTree>
+      <p:nvGrpSpPr>
+        <p:cNvPr id="1" name=""/>
+        <p:cNvGrpSpPr/>
+        <p:nvPr/>
+      </p:nvGrpSpPr>
+      <p:grpSpPr>
+        <a:xfrm>
+          <a:off x="0" y="0"/>
+          <a:ext cx="0" cy="0"/>
+          <a:chOff x="0" y="0"/>
+          <a:chExt cx="0" cy="0"/>
+        </a:xfrm>
+      </p:grpSpPr>
+      <p:sp>
+        <p:nvSpPr>
+          <p:cNvPr id="2" name="Slide Image Placeholder 1"/>
+          <p:cNvSpPr>
+            <a:spLocks noGrp="1"/>
+          </p:cNvSpPr>
+          <p:nvPr>
+            <p:ph type="sldImg" idx="2"/>
+          </p:nvPr>
+        </p:nvSpPr>
+        <p:spPr/>
+      </p:sp>
+      <p:sp>
+        <p:nvSpPr>
+          <p:cNvPr id="3" name="Notes Placeholder 2"/>
+          <p:cNvSpPr>
+            <a:spLocks noGrp="1"/>
+          </p:cNvSpPr>
+          <p:nvPr>
+            <p:ph type="body" idx="3" sz="quarter"/>
+          </p:nvPr>
+        </p:nvSpPr>
+        <p:spPr/>
+        <p:txBody>
+          <a:bodyPr/>
+          <a:lstStyle/>
+          <a:p>
+            <a:r>
+              <a:t>[1:00 - Slide 2 of 17]</a:t>
+            </a:r>
+          </a:p>
+          <a:p>
+            <a:r>
+              <a:t>SAY: Four numbers tell the whole story. Revenue nearly doubled, $2.26M to $4.30M, up 90.3% - so the rumors of stagnation are false. Yet margin is stuck at 11.6%. Why? One in four order lines sells at a loss, destroying $920,646. The fix is not more sales - it is three policy levers that recover $1.23M, an 84% uplift, with zero new capital.</a:t>
+            </a:r>
+          </a:p>
+          <a:p>
+            <a:r>
+              <a:t>DELIVERY: Point at each of the four cards as you name it. Pause after "$920,646".</a:t>
+            </a:r>
+          </a:p>
+          <a:p>
+            <a:r>
+              <a:t>IF ASKED "is $1.23M realistic?": It is the base case of our simulator; even the conservative case returns +$0.91M - slide 14 covers the stress test.</a:t>
+            </a:r>
+          </a:p>
+          <a:p>
+            <a:r>
+              <a:t>TRANSITION: "First, the diagnosis. Is the growth real?"</a:t>
+            </a:r>
+          </a:p>
+        </p:txBody>
+      </p:sp>
+      <p:sp>
+        <p:nvSpPr>
+          <p:cNvPr id="4" name="Slide Number Placeholder 3"/>
+          <p:cNvSpPr>
+            <a:spLocks noGrp="1"/>
+          </p:cNvSpPr>
+          <p:nvPr>
+            <p:ph type="sldNum" idx="5" sz="quarter"/>
+          </p:nvPr>
+        </p:nvSpPr>
+        <p:spPr/>
+      </p:sp>
+    </p:spTree>
+  </p:cSld>
+  <p:clrMapOvr>
+    <a:masterClrMapping/>
+  </p:clrMapOvr>
+</p:notes>
+</file>
+
+<file path=ppt/notesSlides/notesSlide3.xml><?xml version="1.0" encoding="utf-8"?>
+<p:notes xmlns:a="http://schemas.openxmlformats.org/drawingml/2006/main" xmlns:p="http://schemas.openxmlformats.org/presentationml/2006/main" xmlns:r="http://schemas.openxmlformats.org/officeDocument/2006/relationships">
+  <p:cSld>
+    <p:spTree>
+      <p:nvGrpSpPr>
+        <p:cNvPr id="1" name=""/>
+        <p:cNvGrpSpPr/>
+        <p:nvPr/>
+      </p:nvGrpSpPr>
+      <p:grpSpPr>
+        <a:xfrm>
+          <a:off x="0" y="0"/>
+          <a:ext cx="0" cy="0"/>
+          <a:chOff x="0" y="0"/>
+          <a:chExt cx="0" cy="0"/>
+        </a:xfrm>
+      </p:grpSpPr>
+      <p:sp>
+        <p:nvSpPr>
+          <p:cNvPr id="2" name="Slide Image Placeholder 1"/>
+          <p:cNvSpPr>
+            <a:spLocks noGrp="1"/>
+          </p:cNvSpPr>
+          <p:nvPr>
+            <p:ph type="sldImg" idx="2"/>
+          </p:nvPr>
+        </p:nvSpPr>
+        <p:spPr/>
+      </p:sp>
+      <p:sp>
+        <p:nvSpPr>
+          <p:cNvPr id="3" name="Notes Placeholder 2"/>
+          <p:cNvSpPr>
+            <a:spLocks noGrp="1"/>
+          </p:cNvSpPr>
+          <p:nvPr>
+            <p:ph type="body" idx="3" sz="quarter"/>
+          </p:nvPr>
+        </p:nvSpPr>
+        <p:spPr/>
+        <p:txBody>
+          <a:bodyPr/>
+          <a:lstStyle/>
+          <a:p>
+            <a:r>
+              <a:t>[0:30 - Slide 3 of 17]</a:t>
+            </a:r>
+          </a:p>
+          <a:p>
+            <a:r>
+              <a:t>SAY: Growth is genuine and volume-driven. Revenue rose every single year - +18.5%, +27.2%, +26.3% - and operating profit more than doubled to $504K. Orders grew from 4,440 to 8,531; average order value stayed flat at about $505. We grew by adding customers and orders, not by raising prices - which is precisely why margin never improved.</a:t>
+            </a:r>
+          </a:p>
+          <a:p>
+            <a:r>
+              <a:t>TRANSITION: "Zoom out and the pattern is stark: every extra dollar arrived at the same thin margin."</a:t>
+            </a:r>
+          </a:p>
+        </p:txBody>
+      </p:sp>
+      <p:sp>
+        <p:nvSpPr>
+          <p:cNvPr id="4" name="Slide Number Placeholder 3"/>
+          <p:cNvSpPr>
+            <a:spLocks noGrp="1"/>
+          </p:cNvSpPr>
+          <p:nvPr>
+            <p:ph type="sldNum" idx="5" sz="quarter"/>
+          </p:nvPr>
+        </p:nvSpPr>
+        <p:spPr/>
+      </p:sp>
+    </p:spTree>
+  </p:cSld>
+  <p:clrMapOvr>
+    <a:masterClrMapping/>
+  </p:clrMapOvr>
+</p:notes>
+</file>
+
+<file path=ppt/notesSlides/notesSlide4.xml><?xml version="1.0" encoding="utf-8"?>
+<p:notes xmlns:a="http://schemas.openxmlformats.org/drawingml/2006/main" xmlns:p="http://schemas.openxmlformats.org/presentationml/2006/main" xmlns:r="http://schemas.openxmlformats.org/officeDocument/2006/relationships">
+  <p:cSld>
+    <p:spTree>
+      <p:nvGrpSpPr>
+        <p:cNvPr id="1" name=""/>
+        <p:cNvGrpSpPr/>
+        <p:nvPr/>
+      </p:nvGrpSpPr>
+      <p:grpSpPr>
+        <a:xfrm>
+          <a:off x="0" y="0"/>
+          <a:ext cx="0" cy="0"/>
+          <a:chOff x="0" y="0"/>
+          <a:chExt cx="0" cy="0"/>
+        </a:xfrm>
+      </p:grpSpPr>
+      <p:sp>
+        <p:nvSpPr>
+          <p:cNvPr id="2" name="Slide Image Placeholder 1"/>
+          <p:cNvSpPr>
+            <a:spLocks noGrp="1"/>
+          </p:cNvSpPr>
+          <p:nvPr>
+            <p:ph type="sldImg" idx="2"/>
+          </p:nvPr>
+        </p:nvSpPr>
+        <p:spPr/>
+      </p:sp>
+      <p:sp>
+        <p:nvSpPr>
+          <p:cNvPr id="3" name="Notes Placeholder 2"/>
+          <p:cNvSpPr>
+            <a:spLocks noGrp="1"/>
+          </p:cNvSpPr>
+          <p:nvPr>
+            <p:ph type="body" idx="3" sz="quarter"/>
+          </p:nvPr>
+        </p:nvSpPr>
+        <p:spPr/>
+        <p:txBody>
+          <a:bodyPr/>
+          <a:lstStyle/>
+          <a:p>
+            <a:r>
+              <a:t>[0:30 - Slide 4 of 17]</a:t>
+            </a:r>
+          </a:p>
+          <a:p>
+            <a:r>
+              <a:t>SAY: Margin hovered between 11.0% and 11.9% for four straight years - profit grew exactly in line with revenue, so scale bought us nothing. The reason is incentive design: we measure and pay for gross volume, so nobody defended price. Margin - not revenue - is the number this Board should track from here.</a:t>
+            </a:r>
+          </a:p>
+          <a:p>
+            <a:r>
+              <a:t>TRANSITION: "So where does the profit actually go? A quarter of everything we sell loses money."</a:t>
+            </a:r>
+          </a:p>
+        </p:txBody>
+      </p:sp>
+      <p:sp>
+        <p:nvSpPr>
+          <p:cNvPr id="4" name="Slide Number Placeholder 3"/>
+          <p:cNvSpPr>
+            <a:spLocks noGrp="1"/>
+          </p:cNvSpPr>
+          <p:nvPr>
+            <p:ph type="sldNum" idx="5" sz="quarter"/>
+          </p:nvPr>
+        </p:nvSpPr>
+        <p:spPr/>
+      </p:sp>
+    </p:spTree>
+  </p:cSld>
+  <p:clrMapOvr>
+    <a:masterClrMapping/>
+  </p:clrMapOvr>
+</p:notes>
+</file>
+
+<file path=ppt/notesSlides/notesSlide5.xml><?xml version="1.0" encoding="utf-8"?>
+<p:notes xmlns:a="http://schemas.openxmlformats.org/drawingml/2006/main" xmlns:p="http://schemas.openxmlformats.org/presentationml/2006/main" xmlns:r="http://schemas.openxmlformats.org/officeDocument/2006/relationships">
+  <p:cSld>
+    <p:spTree>
+      <p:nvGrpSpPr>
+        <p:cNvPr id="1" name=""/>
+        <p:cNvGrpSpPr/>
+        <p:nvPr/>
+      </p:nvGrpSpPr>
+      <p:grpSpPr>
+        <a:xfrm>
+          <a:off x="0" y="0"/>
+          <a:ext cx="0" cy="0"/>
+          <a:chOff x="0" y="0"/>
+          <a:chExt cx="0" cy="0"/>
+        </a:xfrm>
+      </p:grpSpPr>
+      <p:sp>
+        <p:nvSpPr>
+          <p:cNvPr id="2" name="Slide Image Placeholder 1"/>
+          <p:cNvSpPr>
+            <a:spLocks noGrp="1"/>
+          </p:cNvSpPr>
+          <p:nvPr>
+            <p:ph type="sldImg" idx="2"/>
+          </p:nvPr>
+        </p:nvSpPr>
+        <p:spPr/>
+      </p:sp>
+      <p:sp>
+        <p:nvSpPr>
+          <p:cNvPr id="3" name="Notes Placeholder 2"/>
+          <p:cNvSpPr>
+            <a:spLocks noGrp="1"/>
+          </p:cNvSpPr>
+          <p:nvPr>
+            <p:ph type="body" idx="3" sz="quarter"/>
+          </p:nvPr>
+        </p:nvSpPr>
+        <p:spPr/>
+        <p:txBody>
+          <a:bodyPr/>
+          <a:lstStyle/>
+          <a:p>
+            <a:r>
+              <a:t>[0:45 - Slide 5 of 17]</a:t>
+            </a:r>
+          </a:p>
+          <a:p>
+            <a:r>
+              <a:t>SAY: Walk the bridge. Profitable lines earn $2.39M - that core is strong on its own. But 12,544 lines - one in four - were priced below cost and wiped out $920,646 of it. Reported profit: $1.47M. Our healthy core is being taxed by our own pricing.</a:t>
+            </a:r>
+          </a:p>
+          <a:p>
+            <a:r>
+              <a:t>DELIVERY: Slow down on "one in four".</a:t>
+            </a:r>
+          </a:p>
+          <a:p>
+            <a:r>
+              <a:t>IF ASKED "is 24.5% normal?": Healthy retail runs low-single-digit loss-line rates. Ours is an outlier caused by policy, not by the market - slide 8 shows the exact mechanism.</a:t>
+            </a:r>
+          </a:p>
+          <a:p>
+            <a:r>
+              <a:t>TRANSITION: "Where is the loss concentrated? First, geography."</a:t>
+            </a:r>
+          </a:p>
+        </p:txBody>
+      </p:sp>
+      <p:sp>
+        <p:nvSpPr>
+          <p:cNvPr id="4" name="Slide Number Placeholder 3"/>
+          <p:cNvSpPr>
+            <a:spLocks noGrp="1"/>
+          </p:cNvSpPr>
+          <p:nvPr>
+            <p:ph type="sldNum" idx="5" sz="quarter"/>
+          </p:nvPr>
+        </p:nvSpPr>
+        <p:spPr/>
+      </p:sp>
+    </p:spTree>
+  </p:cSld>
+  <p:clrMapOvr>
+    <a:masterClrMapping/>
+  </p:clrMapOvr>
+</p:notes>
+</file>
+
+<file path=ppt/notesSlides/notesSlide6.xml><?xml version="1.0" encoding="utf-8"?>
+<p:notes xmlns:a="http://schemas.openxmlformats.org/drawingml/2006/main" xmlns:p="http://schemas.openxmlformats.org/presentationml/2006/main" xmlns:r="http://schemas.openxmlformats.org/officeDocument/2006/relationships">
+  <p:cSld>
+    <p:spTree>
+      <p:nvGrpSpPr>
+        <p:cNvPr id="1" name=""/>
+        <p:cNvGrpSpPr/>
+        <p:nvPr/>
+      </p:nvGrpSpPr>
+      <p:grpSpPr>
+        <a:xfrm>
+          <a:off x="0" y="0"/>
+          <a:ext cx="0" cy="0"/>
+          <a:chOff x="0" y="0"/>
+          <a:chExt cx="0" cy="0"/>
+        </a:xfrm>
+      </p:grpSpPr>
+      <p:sp>
+        <p:nvSpPr>
+          <p:cNvPr id="2" name="Slide Image Placeholder 1"/>
+          <p:cNvSpPr>
+            <a:spLocks noGrp="1"/>
+          </p:cNvSpPr>
+          <p:nvPr>
+            <p:ph type="sldImg" idx="2"/>
+          </p:nvPr>
+        </p:nvSpPr>
+        <p:spPr/>
+      </p:sp>
+      <p:sp>
+        <p:nvSpPr>
+          <p:cNvPr id="3" name="Notes Placeholder 2"/>
+          <p:cNvSpPr>
+            <a:spLocks noGrp="1"/>
+          </p:cNvSpPr>
+          <p:nvPr>
+            <p:ph type="body" idx="3" sz="quarter"/>
+          </p:nvPr>
+        </p:nvSpPr>
+        <p:spPr/>
+        <p:txBody>
+          <a:bodyPr/>
+          <a:lstStyle/>
+          <a:p>
+            <a:r>
+              <a:t>[0:30 - Slide 6 of 17]</a:t>
+            </a:r>
+          </a:p>
+          <a:p>
+            <a:r>
+              <a:t>SAY: 29 of 147 countries are net-negative, and Turkey (-$98K) and Nigeria (-$81K) carry most of the deficit. Both were sold at 60-70% average discounts, with cross-border freight absorbed centrally. This is a company-policy loss, not a market loss: EMEA runs 5.4% margin against 12-13% in our healthy markets.</a:t>
+            </a:r>
+          </a:p>
+          <a:p>
+            <a:r>
+              <a:t>TRANSITION: "One product line tells exactly the same story."</a:t>
+            </a:r>
+          </a:p>
+        </p:txBody>
+      </p:sp>
+      <p:sp>
+        <p:nvSpPr>
+          <p:cNvPr id="4" name="Slide Number Placeholder 3"/>
+          <p:cNvSpPr>
+            <a:spLocks noGrp="1"/>
+          </p:cNvSpPr>
+          <p:nvPr>
+            <p:ph type="sldNum" idx="5" sz="quarter"/>
+          </p:nvPr>
+        </p:nvSpPr>
+        <p:spPr/>
+      </p:sp>
+    </p:spTree>
+  </p:cSld>
+  <p:clrMapOvr>
+    <a:masterClrMapping/>
+  </p:clrMapOvr>
+</p:notes>
+</file>
+
+<file path=ppt/notesSlides/notesSlide7.xml><?xml version="1.0" encoding="utf-8"?>
+<p:notes xmlns:a="http://schemas.openxmlformats.org/drawingml/2006/main" xmlns:p="http://schemas.openxmlformats.org/presentationml/2006/main" xmlns:r="http://schemas.openxmlformats.org/officeDocument/2006/relationships">
+  <p:cSld>
+    <p:spTree>
+      <p:nvGrpSpPr>
+        <p:cNvPr id="1" name=""/>
+        <p:cNvGrpSpPr/>
+        <p:nvPr/>
+      </p:nvGrpSpPr>
+      <p:grpSpPr>
+        <a:xfrm>
+          <a:off x="0" y="0"/>
+          <a:ext cx="0" cy="0"/>
+          <a:chOff x="0" y="0"/>
+          <a:chExt cx="0" cy="0"/>
+        </a:xfrm>
+      </p:grpSpPr>
+      <p:sp>
+        <p:nvSpPr>
+          <p:cNvPr id="2" name="Slide Image Placeholder 1"/>
+          <p:cNvSpPr>
+            <a:spLocks noGrp="1"/>
+          </p:cNvSpPr>
+          <p:nvPr>
+            <p:ph type="sldImg" idx="2"/>
+          </p:nvPr>
+        </p:nvSpPr>
+        <p:spPr/>
+      </p:sp>
+      <p:sp>
+        <p:nvSpPr>
+          <p:cNvPr id="3" name="Notes Placeholder 2"/>
+          <p:cNvSpPr>
+            <a:spLocks noGrp="1"/>
+          </p:cNvSpPr>
+          <p:nvPr>
+            <p:ph type="body" idx="3" sz="quarter"/>
+          </p:nvPr>
+        </p:nvSpPr>
+        <p:spPr/>
+        <p:txBody>
+          <a:bodyPr/>
+          <a:lstStyle/>
+          <a:p>
+            <a:r>
+              <a:t>[0:30 - Slide 7 of 17]</a:t>
+            </a:r>
+          </a:p>
+          <a:p>
+            <a:r>
+              <a:t>SAY: Sixteen of seventeen sub-categories are profitable - Copiers +$259K, Phones +$217K. Tables is the only loser: -$64.1K on $757K of sales, carrying a 29.1% average discount plus the highest freight per unit in the catalogue. That drags Furniture to a 6.9% margin against Technology's 14.0%.</a:t>
+            </a:r>
+          </a:p>
+          <a:p>
+            <a:r>
+              <a:t>TRANSITION: "But the biggest single cause is a line you can draw on a chart: twenty percent."</a:t>
+            </a:r>
+          </a:p>
+        </p:txBody>
+      </p:sp>
+      <p:sp>
+        <p:nvSpPr>
+          <p:cNvPr id="4" name="Slide Number Placeholder 3"/>
+          <p:cNvSpPr>
+            <a:spLocks noGrp="1"/>
+          </p:cNvSpPr>
+          <p:nvPr>
+            <p:ph type="sldNum" idx="5" sz="quarter"/>
+          </p:nvPr>
+        </p:nvSpPr>
+        <p:spPr/>
+      </p:sp>
+    </p:spTree>
+  </p:cSld>
+  <p:clrMapOvr>
+    <a:masterClrMapping/>
+  </p:clrMapOvr>
+</p:notes>
+</file>
+
+<file path=ppt/notesSlides/notesSlide8.xml><?xml version="1.0" encoding="utf-8"?>
+<p:notes xmlns:a="http://schemas.openxmlformats.org/drawingml/2006/main" xmlns:p="http://schemas.openxmlformats.org/presentationml/2006/main" xmlns:r="http://schemas.openxmlformats.org/officeDocument/2006/relationships">
+  <p:cSld>
+    <p:spTree>
+      <p:nvGrpSpPr>
+        <p:cNvPr id="1" name=""/>
+        <p:cNvGrpSpPr/>
+        <p:nvPr/>
+      </p:nvGrpSpPr>
+      <p:grpSpPr>
+        <a:xfrm>
+          <a:off x="0" y="0"/>
+          <a:ext cx="0" cy="0"/>
+          <a:chOff x="0" y="0"/>
+          <a:chExt cx="0" cy="0"/>
+        </a:xfrm>
+      </p:grpSpPr>
+      <p:sp>
+        <p:nvSpPr>
+          <p:cNvPr id="2" name="Slide Image Placeholder 1"/>
+          <p:cNvSpPr>
+            <a:spLocks noGrp="1"/>
+          </p:cNvSpPr>
+          <p:nvPr>
+            <p:ph type="sldImg" idx="2"/>
+          </p:nvPr>
+        </p:nvSpPr>
+        <p:spPr/>
+      </p:sp>
+      <p:sp>
+        <p:nvSpPr>
+          <p:cNvPr id="3" name="Notes Placeholder 2"/>
+          <p:cNvSpPr>
+            <a:spLocks noGrp="1"/>
+          </p:cNvSpPr>
+          <p:nvPr>
+            <p:ph type="body" idx="3" sz="quarter"/>
+          </p:nvPr>
+        </p:nvSpPr>
+        <p:spPr/>
+        <p:txBody>
+          <a:bodyPr/>
+          <a:lstStyle/>
+          <a:p>
+            <a:r>
+              <a:t>[1:00 - Slide 8 of 17]</a:t>
+            </a:r>
+          </a:p>
+          <a:p>
+            <a:r>
+              <a:t>SAY: This is the most important chart in the deck. Below 20% discount, every band is profitable: +25.3% with no discount, still +9.9% at 10-20%. Above 20%, every band loses: -5.5%, worsening to -111% past 50%. 11,328 lines - 22.1% of the ledger - were priced past that line and lost $814,682: that is 88.5% of ALL loss dollars.</a:t>
+            </a:r>
+          </a:p>
+          <a:p>
+            <a:r>
+              <a:t>DELIVERY: Trace the cliff with your hand. Pause at "88.5%".</a:t>
+            </a:r>
+          </a:p>
+          <a:p>
+            <a:r>
+              <a:t>IF ASKED "why 20% exactly?": It is where the data inverts, not a round number we picked - gross margin cannot carry concessions deeper than 20%.</a:t>
+            </a:r>
+          </a:p>
+          <a:p>
+            <a:r>
+              <a:t>TRANSITION: "Discounting has an accomplice: freight."</a:t>
+            </a:r>
+          </a:p>
+        </p:txBody>
+      </p:sp>
+      <p:sp>
+        <p:nvSpPr>
+          <p:cNvPr id="4" name="Slide Number Placeholder 3"/>
+          <p:cNvSpPr>
+            <a:spLocks noGrp="1"/>
+          </p:cNvSpPr>
+          <p:nvPr>
+            <p:ph type="sldNum" idx="5" sz="quarter"/>
+          </p:nvPr>
+        </p:nvSpPr>
+        <p:spPr/>
+      </p:sp>
+    </p:spTree>
+  </p:cSld>
+  <p:clrMapOvr>
+    <a:masterClrMapping/>
+  </p:clrMapOvr>
+</p:notes>
+</file>
+
+<file path=ppt/notesSlides/notesSlide9.xml><?xml version="1.0" encoding="utf-8"?>
+<p:notes xmlns:a="http://schemas.openxmlformats.org/drawingml/2006/main" xmlns:p="http://schemas.openxmlformats.org/presentationml/2006/main" xmlns:r="http://schemas.openxmlformats.org/officeDocument/2006/relationships">
+  <p:cSld>
+    <p:spTree>
+      <p:nvGrpSpPr>
+        <p:cNvPr id="1" name=""/>
+        <p:cNvGrpSpPr/>
+        <p:nvPr/>
+      </p:nvGrpSpPr>
+      <p:grpSpPr>
+        <a:xfrm>
+          <a:off x="0" y="0"/>
+          <a:ext cx="0" cy="0"/>
+          <a:chOff x="0" y="0"/>
+          <a:chExt cx="0" cy="0"/>
+        </a:xfrm>
+      </p:grpSpPr>
+      <p:sp>
+        <p:nvSpPr>
+          <p:cNvPr id="2" name="Slide Image Placeholder 1"/>
+          <p:cNvSpPr>
+            <a:spLocks noGrp="1"/>
+          </p:cNvSpPr>
+          <p:nvPr>
+            <p:ph type="sldImg" idx="2"/>
+          </p:nvPr>
+        </p:nvSpPr>
+        <p:spPr/>
+      </p:sp>
+      <p:sp>
+        <p:nvSpPr>
+          <p:cNvPr id="3" name="Notes Placeholder 2"/>
+          <p:cNvSpPr>
+            <a:spLocks noGrp="1"/>
+          </p:cNvSpPr>
+          <p:nvPr>
+            <p:ph type="body" idx="3" sz="quarter"/>
+          </p:nvPr>
+        </p:nvSpPr>
+        <p:spPr/>
+        <p:txBody>
+          <a:bodyPr/>
+          <a:lstStyle/>
+          <a:p>
+            <a:r>
+              <a:t>[0:30 - Slide 9 of 17]</a:t>
+            </a:r>
+          </a:p>
+          <a:p>
+            <a:r>
+              <a:t>SAY: Critical-priority orders spend 23.8% of their sales value on freight; Same Day spends 17.4% - against 8.1% for Standard Class, a third of the rate. Company-wide, freight is 10.7% of sales and is never charged back. Deep discounts and heavy freight land on the same orders - that is why they never recover.</a:t>
+            </a:r>
+          </a:p>
+          <a:p>
+            <a:r>
+              <a:t>TRANSITION: "Put the three together and the root causes are simple and few."</a:t>
+            </a:r>
+          </a:p>
+        </p:txBody>
+      </p:sp>
+      <p:sp>
+        <p:nvSpPr>
+          <p:cNvPr id="4" name="Slide Number Placeholder 3"/>
+          <p:cNvSpPr>
+            <a:spLocks noGrp="1"/>
+          </p:cNvSpPr>
+          <p:nvPr>
+            <p:ph type="sldNum" idx="5" sz="quarter"/>
+          </p:nvPr>
+        </p:nvSpPr>
+        <p:spPr/>
+      </p:sp>
+    </p:spTree>
+  </p:cSld>
+  <p:clrMapOvr>
+    <a:masterClrMapping/>
+  </p:clrMapOvr>
+</p:notes>
 </file>
 
 <file path=ppt/slideLayouts/slideLayout1.xml><?xml version="1.0" encoding="utf-8"?>
@@ -7005,6 +8780,992 @@
 </file>
 
 <file path=ppt/slides/slide11.xml><?xml version="1.0" encoding="utf-8"?>
+<p:sld xmlns:a="http://schemas.openxmlformats.org/drawingml/2006/main" xmlns:p="http://schemas.openxmlformats.org/presentationml/2006/main" xmlns:r="http://schemas.openxmlformats.org/officeDocument/2006/relationships">
+  <p:cSld>
+    <p:spTree>
+      <p:nvGrpSpPr>
+        <p:cNvPr id="1" name=""/>
+        <p:cNvGrpSpPr/>
+        <p:nvPr/>
+      </p:nvGrpSpPr>
+      <p:grpSpPr/>
+      <p:sp>
+        <p:nvSpPr>
+          <p:cNvPr id="2" name="TextBox 1"/>
+          <p:cNvSpPr txBox="1"/>
+          <p:nvPr/>
+        </p:nvSpPr>
+        <p:spPr>
+          <a:xfrm>
+            <a:off x="566928" y="310896"/>
+            <a:ext cx="6634703" cy="310896"/>
+          </a:xfrm>
+          <a:prstGeom prst="rect">
+            <a:avLst/>
+          </a:prstGeom>
+          <a:noFill/>
+        </p:spPr>
+        <p:txBody>
+          <a:bodyPr wrap="square" anchor="t" lIns="0" rIns="0" tIns="0" bIns="0">
+            <a:spAutoFit/>
+          </a:bodyPr>
+          <a:lstStyle/>
+          <a:p>
+            <a:pPr algn="l">
+              <a:lnSpc>
+                <a:spcPct val="106000"/>
+              </a:lnSpc>
+              <a:spcBef>
+                <a:spcPts val="0"/>
+              </a:spcBef>
+              <a:spcAft>
+                <a:spcPts val="300"/>
+              </a:spcAft>
+            </a:pPr>
+            <a:r>
+              <a:rPr sz="1800" b="1" i="0">
+                <a:solidFill>
+                  <a:srgbClr val="322014"/>
+                </a:solidFill>
+                <a:latin typeface="Georgia"/>
+              </a:rPr>
+              <a:t>Global Superstore · Revival Strategy</a:t>
+            </a:r>
+          </a:p>
+        </p:txBody>
+      </p:sp>
+      <p:sp>
+        <p:nvSpPr>
+          <p:cNvPr id="3" name="TextBox 2"/>
+          <p:cNvSpPr txBox="1"/>
+          <p:nvPr/>
+        </p:nvSpPr>
+        <p:spPr>
+          <a:xfrm>
+            <a:off x="7784287" y="429768"/>
+            <a:ext cx="3840480" cy="219456"/>
+          </a:xfrm>
+          <a:prstGeom prst="rect">
+            <a:avLst/>
+          </a:prstGeom>
+          <a:noFill/>
+        </p:spPr>
+        <p:txBody>
+          <a:bodyPr wrap="square" anchor="t" lIns="0" rIns="0" tIns="0" bIns="0">
+            <a:spAutoFit/>
+          </a:bodyPr>
+          <a:lstStyle/>
+          <a:p>
+            <a:pPr algn="r">
+              <a:lnSpc>
+                <a:spcPct val="106000"/>
+              </a:lnSpc>
+              <a:spcBef>
+                <a:spcPts val="0"/>
+              </a:spcBef>
+              <a:spcAft>
+                <a:spcPts val="300"/>
+              </a:spcAft>
+            </a:pPr>
+            <a:r>
+              <a:rPr sz="750" b="1" i="0">
+                <a:solidFill>
+                  <a:srgbClr val="8A7B6B"/>
+                </a:solidFill>
+                <a:latin typeface="Arial"/>
+              </a:rPr>
+              <a:t>Turnaround · Options considered</a:t>
+            </a:r>
+          </a:p>
+        </p:txBody>
+      </p:sp>
+      <p:cxnSp>
+        <p:nvCxnSpPr>
+          <p:cNvPr id="4" name="Connector 3"/>
+          <p:cNvCxnSpPr/>
+          <p:nvPr/>
+        </p:nvCxnSpPr>
+        <p:spPr>
+          <a:xfrm>
+            <a:off x="566928" y="658368"/>
+            <a:ext cx="11057839" cy="0"/>
+          </a:xfrm>
+          <a:prstGeom prst="line">
+            <a:avLst/>
+          </a:prstGeom>
+          <a:ln w="12700">
+            <a:solidFill>
+              <a:srgbClr val="322014"/>
+            </a:solidFill>
+          </a:ln>
+        </p:spPr>
+        <p:style>
+          <a:lnRef idx="2">
+            <a:schemeClr val="accent1"/>
+          </a:lnRef>
+          <a:fillRef idx="0">
+            <a:schemeClr val="accent1"/>
+          </a:fillRef>
+          <a:effectRef idx="1">
+            <a:schemeClr val="accent1"/>
+          </a:effectRef>
+          <a:fontRef idx="minor">
+            <a:schemeClr val="tx1"/>
+          </a:fontRef>
+        </p:style>
+      </p:cxnSp>
+      <p:cxnSp>
+        <p:nvCxnSpPr>
+          <p:cNvPr id="5" name="Connector 4"/>
+          <p:cNvCxnSpPr/>
+          <p:nvPr/>
+        </p:nvCxnSpPr>
+        <p:spPr>
+          <a:xfrm>
+            <a:off x="566928" y="6355080"/>
+            <a:ext cx="11057839" cy="0"/>
+          </a:xfrm>
+          <a:prstGeom prst="line">
+            <a:avLst/>
+          </a:prstGeom>
+          <a:ln w="9525">
+            <a:solidFill>
+              <a:srgbClr val="C5A681"/>
+            </a:solidFill>
+          </a:ln>
+        </p:spPr>
+        <p:style>
+          <a:lnRef idx="2">
+            <a:schemeClr val="accent1"/>
+          </a:lnRef>
+          <a:fillRef idx="0">
+            <a:schemeClr val="accent1"/>
+          </a:fillRef>
+          <a:effectRef idx="1">
+            <a:schemeClr val="accent1"/>
+          </a:effectRef>
+          <a:fontRef idx="minor">
+            <a:schemeClr val="tx1"/>
+          </a:fontRef>
+        </p:style>
+      </p:cxnSp>
+      <p:sp>
+        <p:nvSpPr>
+          <p:cNvPr id="6" name="TextBox 5"/>
+          <p:cNvSpPr txBox="1"/>
+          <p:nvPr/>
+        </p:nvSpPr>
+        <p:spPr>
+          <a:xfrm>
+            <a:off x="566928" y="6400800"/>
+            <a:ext cx="7740487" cy="219456"/>
+          </a:xfrm>
+          <a:prstGeom prst="rect">
+            <a:avLst/>
+          </a:prstGeom>
+          <a:noFill/>
+        </p:spPr>
+        <p:txBody>
+          <a:bodyPr wrap="square" anchor="t" lIns="0" rIns="0" tIns="0" bIns="0">
+            <a:spAutoFit/>
+          </a:bodyPr>
+          <a:lstStyle/>
+          <a:p>
+            <a:pPr algn="l">
+              <a:lnSpc>
+                <a:spcPct val="106000"/>
+              </a:lnSpc>
+              <a:spcBef>
+                <a:spcPts val="0"/>
+              </a:spcBef>
+              <a:spcAft>
+                <a:spcPts val="300"/>
+              </a:spcAft>
+            </a:pPr>
+            <a:r>
+              <a:rPr sz="850" b="1" i="0">
+                <a:solidFill>
+                  <a:srgbClr val="322014"/>
+                </a:solidFill>
+                <a:latin typeface="Arial"/>
+              </a:rPr>
+              <a:t>Global Superstore · Revival Strategy</a:t>
+            </a:r>
+          </a:p>
+        </p:txBody>
+      </p:sp>
+      <p:sp>
+        <p:nvSpPr>
+          <p:cNvPr id="7" name="TextBox 6"/>
+          <p:cNvSpPr txBox="1"/>
+          <p:nvPr/>
+        </p:nvSpPr>
+        <p:spPr>
+          <a:xfrm>
+            <a:off x="10710367" y="6400800"/>
+            <a:ext cx="914400" cy="219456"/>
+          </a:xfrm>
+          <a:prstGeom prst="rect">
+            <a:avLst/>
+          </a:prstGeom>
+          <a:noFill/>
+        </p:spPr>
+        <p:txBody>
+          <a:bodyPr wrap="square" anchor="t" lIns="0" rIns="0" tIns="0" bIns="0">
+            <a:spAutoFit/>
+          </a:bodyPr>
+          <a:lstStyle/>
+          <a:p>
+            <a:pPr algn="r">
+              <a:lnSpc>
+                <a:spcPct val="106000"/>
+              </a:lnSpc>
+              <a:spcBef>
+                <a:spcPts val="0"/>
+              </a:spcBef>
+              <a:spcAft>
+                <a:spcPts val="300"/>
+              </a:spcAft>
+            </a:pPr>
+            <a:r>
+              <a:rPr sz="850" b="0" i="0">
+                <a:solidFill>
+                  <a:srgbClr val="8A7B6B"/>
+                </a:solidFill>
+                <a:latin typeface="Arial"/>
+              </a:rPr>
+              <a:t>10</a:t>
+            </a:r>
+          </a:p>
+        </p:txBody>
+      </p:sp>
+      <p:sp>
+        <p:nvSpPr>
+          <p:cNvPr id="8" name="TextBox 7"/>
+          <p:cNvSpPr txBox="1"/>
+          <p:nvPr/>
+        </p:nvSpPr>
+        <p:spPr>
+          <a:xfrm>
+            <a:off x="566928" y="731520"/>
+            <a:ext cx="11057839" cy="822960"/>
+          </a:xfrm>
+          <a:prstGeom prst="rect">
+            <a:avLst/>
+          </a:prstGeom>
+          <a:noFill/>
+        </p:spPr>
+        <p:txBody>
+          <a:bodyPr wrap="square" anchor="t" lIns="0" rIns="0" tIns="0" bIns="0">
+            <a:spAutoFit/>
+          </a:bodyPr>
+          <a:lstStyle/>
+          <a:p>
+            <a:pPr algn="l">
+              <a:lnSpc>
+                <a:spcPct val="102000"/>
+              </a:lnSpc>
+              <a:spcBef>
+                <a:spcPts val="0"/>
+              </a:spcBef>
+              <a:spcAft>
+                <a:spcPts val="300"/>
+              </a:spcAft>
+            </a:pPr>
+            <a:r>
+              <a:rPr sz="2100" b="1" i="0">
+                <a:solidFill>
+                  <a:srgbClr val="322014"/>
+                </a:solidFill>
+                <a:latin typeface="Georgia"/>
+              </a:rPr>
+              <a:t>The three-lever recovery plan outearns every alternative tested</a:t>
+            </a:r>
+          </a:p>
+        </p:txBody>
+      </p:sp>
+      <p:graphicFrame>
+        <p:nvGraphicFramePr>
+          <p:cNvPr id="9" name="Table 8"/>
+          <p:cNvGraphicFramePr>
+            <a:graphicFrameLocks noGrp="1"/>
+          </p:cNvGraphicFramePr>
+          <p:nvPr/>
+        </p:nvGraphicFramePr>
+        <p:xfrm>
+          <a:off x="566928" y="1737360"/>
+          <a:ext cx="11064240" cy="3803904"/>
+        </p:xfrm>
+        <a:graphic>
+          <a:graphicData uri="http://schemas.openxmlformats.org/drawingml/2006/table">
+            <a:tbl>
+              <a:tblPr>
+                <a:tableStyleId>{2D5ABB26-0587-4C30-8999-92F81FD0307C}</a:tableStyleId>
+              </a:tblPr>
+              <a:tblGrid>
+                <a:gridCol w="2606040"/>
+                <a:gridCol w="4160520"/>
+                <a:gridCol w="2606040"/>
+                <a:gridCol w="1691640"/>
+              </a:tblGrid>
+              <a:tr h="402336">
+                <a:tc>
+                  <a:txBody>
+                    <a:bodyPr wrap="square"/>
+                    <a:lstStyle/>
+                    <a:p>
+                      <a:pPr>
+                        <a:lnSpc>
+                          <a:spcPct val="105000"/>
+                        </a:lnSpc>
+                      </a:pPr>
+                      <a:r>
+                        <a:rPr sz="1200" b="1">
+                          <a:solidFill>
+                            <a:srgbClr val="322014"/>
+                          </a:solidFill>
+                          <a:latin typeface="Arial"/>
+                        </a:rPr>
+                        <a:t>Alternative considered</a:t>
+                      </a:r>
+                    </a:p>
+                  </a:txBody>
+                  <a:tcPr marL="91440" marR="73152" marT="45720" marB="45720" anchor="ctr">
+                    <a:lnB w="19050" cap="flat" cmpd="sng" algn="ctr">
+                      <a:solidFill>
+                        <a:srgbClr val="322014"/>
+                      </a:solidFill>
+                    </a:lnB>
+                    <a:solidFill>
+                      <a:srgbClr val="FFFFFF"/>
+                    </a:solidFill>
+                  </a:tcPr>
+                </a:tc>
+                <a:tc>
+                  <a:txBody>
+                    <a:bodyPr wrap="square"/>
+                    <a:lstStyle/>
+                    <a:p>
+                      <a:pPr>
+                        <a:lnSpc>
+                          <a:spcPct val="105000"/>
+                        </a:lnSpc>
+                      </a:pPr>
+                      <a:r>
+                        <a:rPr sz="1200" b="1">
+                          <a:solidFill>
+                            <a:srgbClr val="322014"/>
+                          </a:solidFill>
+                          <a:latin typeface="Arial"/>
+                        </a:rPr>
+                        <a:t>What it promises</a:t>
+                      </a:r>
+                    </a:p>
+                  </a:txBody>
+                  <a:tcPr marL="91440" marR="73152" marT="45720" marB="45720" anchor="ctr">
+                    <a:lnB w="19050" cap="flat" cmpd="sng" algn="ctr">
+                      <a:solidFill>
+                        <a:srgbClr val="322014"/>
+                      </a:solidFill>
+                    </a:lnB>
+                    <a:solidFill>
+                      <a:srgbClr val="FFFFFF"/>
+                    </a:solidFill>
+                  </a:tcPr>
+                </a:tc>
+                <a:tc>
+                  <a:txBody>
+                    <a:bodyPr wrap="square"/>
+                    <a:lstStyle/>
+                    <a:p>
+                      <a:pPr>
+                        <a:lnSpc>
+                          <a:spcPct val="105000"/>
+                        </a:lnSpc>
+                      </a:pPr>
+                      <a:r>
+                        <a:rPr sz="1200" b="1">
+                          <a:solidFill>
+                            <a:srgbClr val="322014"/>
+                          </a:solidFill>
+                          <a:latin typeface="Arial"/>
+                        </a:rPr>
+                        <a:t>Why it is eliminated</a:t>
+                      </a:r>
+                    </a:p>
+                  </a:txBody>
+                  <a:tcPr marL="91440" marR="73152" marT="45720" marB="45720" anchor="ctr">
+                    <a:lnB w="19050" cap="flat" cmpd="sng" algn="ctr">
+                      <a:solidFill>
+                        <a:srgbClr val="322014"/>
+                      </a:solidFill>
+                    </a:lnB>
+                    <a:solidFill>
+                      <a:srgbClr val="FFFFFF"/>
+                    </a:solidFill>
+                  </a:tcPr>
+                </a:tc>
+                <a:tc>
+                  <a:txBody>
+                    <a:bodyPr wrap="square"/>
+                    <a:lstStyle/>
+                    <a:p>
+                      <a:pPr>
+                        <a:lnSpc>
+                          <a:spcPct val="105000"/>
+                        </a:lnSpc>
+                      </a:pPr>
+                      <a:r>
+                        <a:rPr sz="1200" b="1">
+                          <a:solidFill>
+                            <a:srgbClr val="322014"/>
+                          </a:solidFill>
+                          <a:latin typeface="Arial"/>
+                        </a:rPr>
+                        <a:t>Verdict</a:t>
+                      </a:r>
+                    </a:p>
+                  </a:txBody>
+                  <a:tcPr marL="91440" marR="73152" marT="45720" marB="45720" anchor="ctr">
+                    <a:lnB w="19050" cap="flat" cmpd="sng" algn="ctr">
+                      <a:solidFill>
+                        <a:srgbClr val="322014"/>
+                      </a:solidFill>
+                    </a:lnB>
+                    <a:solidFill>
+                      <a:srgbClr val="FFFFFF"/>
+                    </a:solidFill>
+                  </a:tcPr>
+                </a:tc>
+              </a:tr>
+              <a:tr h="1133856">
+                <a:tc>
+                  <a:txBody>
+                    <a:bodyPr wrap="square"/>
+                    <a:lstStyle/>
+                    <a:p>
+                      <a:pPr>
+                        <a:lnSpc>
+                          <a:spcPct val="105000"/>
+                        </a:lnSpc>
+                      </a:pPr>
+                      <a:r>
+                        <a:rPr sz="1400" b="1">
+                          <a:solidFill>
+                            <a:srgbClr val="5A3921"/>
+                          </a:solidFill>
+                          <a:latin typeface="Georgia"/>
+                        </a:rPr>
+                        <a:t>Raise list prices, allow deeper discounts</a:t>
+                      </a:r>
+                    </a:p>
+                  </a:txBody>
+                  <a:tcPr marL="91440" marR="73152" marT="45720" marB="45720" anchor="ctr">
+                    <a:lnR w="19050" cap="flat" cmpd="sng" algn="ctr">
+                      <a:solidFill>
+                        <a:srgbClr val="322014"/>
+                      </a:solidFill>
+                    </a:lnR>
+                    <a:lnT w="9525" cap="flat" cmpd="sng" algn="ctr">
+                      <a:solidFill>
+                        <a:srgbClr val="E2DCD2"/>
+                      </a:solidFill>
+                    </a:lnT>
+                    <a:solidFill>
+                      <a:srgbClr val="FFFFFF"/>
+                    </a:solidFill>
+                  </a:tcPr>
+                </a:tc>
+                <a:tc>
+                  <a:txBody>
+                    <a:bodyPr wrap="square"/>
+                    <a:lstStyle/>
+                    <a:p>
+                      <a:pPr>
+                        <a:lnSpc>
+                          <a:spcPct val="105000"/>
+                        </a:lnSpc>
+                      </a:pPr>
+                      <a:r>
+                        <a:rPr sz="1100" b="0">
+                          <a:solidFill>
+                            <a:srgbClr val="322014"/>
+                          </a:solidFill>
+                          <a:latin typeface="Arial"/>
+                        </a:rPr>
+                        <a:t>Bigger concessions look affordable from a higher invoice price</a:t>
+                      </a:r>
+                    </a:p>
+                  </a:txBody>
+                  <a:tcPr marL="91440" marR="73152" marT="45720" marB="45720" anchor="ctr">
+                    <a:lnT w="9525" cap="flat" cmpd="sng" algn="ctr">
+                      <a:solidFill>
+                        <a:srgbClr val="E2DCD2"/>
+                      </a:solidFill>
+                    </a:lnT>
+                    <a:solidFill>
+                      <a:srgbClr val="FFFFFF"/>
+                    </a:solidFill>
+                  </a:tcPr>
+                </a:tc>
+                <a:tc>
+                  <a:txBody>
+                    <a:bodyPr wrap="square"/>
+                    <a:lstStyle/>
+                    <a:p>
+                      <a:pPr>
+                        <a:lnSpc>
+                          <a:spcPct val="105000"/>
+                        </a:lnSpc>
+                      </a:pPr>
+                      <a:r>
+                        <a:rPr sz="1100" b="0">
+                          <a:solidFill>
+                            <a:srgbClr val="322014"/>
+                          </a:solidFill>
+                          <a:latin typeface="Arial"/>
+                        </a:rPr>
+                        <a:t>The leak follows the discount, not the list price: margin runs +9.9% at 10-20% off but -5.5% at 20-30%, and 88.5% of loss dollars sit above the 20% line</a:t>
+                      </a:r>
+                    </a:p>
+                  </a:txBody>
+                  <a:tcPr marL="91440" marR="73152" marT="45720" marB="45720" anchor="ctr">
+                    <a:lnT w="9525" cap="flat" cmpd="sng" algn="ctr">
+                      <a:solidFill>
+                        <a:srgbClr val="E2DCD2"/>
+                      </a:solidFill>
+                    </a:lnT>
+                    <a:solidFill>
+                      <a:srgbClr val="FFFFFF"/>
+                    </a:solidFill>
+                  </a:tcPr>
+                </a:tc>
+                <a:tc>
+                  <a:txBody>
+                    <a:bodyPr wrap="square"/>
+                    <a:lstStyle/>
+                    <a:p>
+                      <a:pPr>
+                        <a:lnSpc>
+                          <a:spcPct val="105000"/>
+                        </a:lnSpc>
+                      </a:pPr>
+                      <a:r>
+                        <a:rPr sz="1100" b="1">
+                          <a:solidFill>
+                            <a:srgbClr val="322014"/>
+                          </a:solidFill>
+                          <a:latin typeface="Arial"/>
+                        </a:rPr>
+                        <a:t>Eliminated</a:t>
+                      </a:r>
+                    </a:p>
+                  </a:txBody>
+                  <a:tcPr marL="91440" marR="73152" marT="45720" marB="45720" anchor="ctr">
+                    <a:lnT w="9525" cap="flat" cmpd="sng" algn="ctr">
+                      <a:solidFill>
+                        <a:srgbClr val="E2DCD2"/>
+                      </a:solidFill>
+                    </a:lnT>
+                    <a:solidFill>
+                      <a:srgbClr val="FFFFFF"/>
+                    </a:solidFill>
+                  </a:tcPr>
+                </a:tc>
+              </a:tr>
+              <a:tr h="1133856">
+                <a:tc>
+                  <a:txBody>
+                    <a:bodyPr wrap="square"/>
+                    <a:lstStyle/>
+                    <a:p>
+                      <a:pPr>
+                        <a:lnSpc>
+                          <a:spcPct val="105000"/>
+                        </a:lnSpc>
+                      </a:pPr>
+                      <a:r>
+                        <a:rPr sz="1400" b="1">
+                          <a:solidFill>
+                            <a:srgbClr val="5A3921"/>
+                          </a:solidFill>
+                          <a:latin typeface="Georgia"/>
+                        </a:rPr>
+                        <a:t>Exit Turkey and Nigeria entirely</a:t>
+                      </a:r>
+                    </a:p>
+                  </a:txBody>
+                  <a:tcPr marL="91440" marR="73152" marT="45720" marB="45720" anchor="ctr">
+                    <a:lnR w="19050" cap="flat" cmpd="sng" algn="ctr">
+                      <a:solidFill>
+                        <a:srgbClr val="322014"/>
+                      </a:solidFill>
+                    </a:lnR>
+                    <a:lnT w="9525" cap="flat" cmpd="sng" algn="ctr">
+                      <a:solidFill>
+                        <a:srgbClr val="E2DCD2"/>
+                      </a:solidFill>
+                    </a:lnT>
+                    <a:solidFill>
+                      <a:srgbClr val="FFFFFF"/>
+                    </a:solidFill>
+                  </a:tcPr>
+                </a:tc>
+                <a:tc>
+                  <a:txBody>
+                    <a:bodyPr wrap="square"/>
+                    <a:lstStyle/>
+                    <a:p>
+                      <a:pPr>
+                        <a:lnSpc>
+                          <a:spcPct val="105000"/>
+                        </a:lnSpc>
+                      </a:pPr>
+                      <a:r>
+                        <a:rPr sz="1100" b="0">
+                          <a:solidFill>
+                            <a:srgbClr val="322014"/>
+                          </a:solidFill>
+                          <a:latin typeface="Arial"/>
+                        </a:rPr>
+                        <a:t>Instant stop to the -$179K country deficit</a:t>
+                      </a:r>
+                    </a:p>
+                  </a:txBody>
+                  <a:tcPr marL="91440" marR="73152" marT="45720" marB="45720" anchor="ctr">
+                    <a:lnT w="9525" cap="flat" cmpd="sng" algn="ctr">
+                      <a:solidFill>
+                        <a:srgbClr val="E2DCD2"/>
+                      </a:solidFill>
+                    </a:lnT>
+                    <a:solidFill>
+                      <a:srgbClr val="FFFFFF"/>
+                    </a:solidFill>
+                  </a:tcPr>
+                </a:tc>
+                <a:tc>
+                  <a:txBody>
+                    <a:bodyPr wrap="square"/>
+                    <a:lstStyle/>
+                    <a:p>
+                      <a:pPr>
+                        <a:lnSpc>
+                          <a:spcPct val="105000"/>
+                        </a:lnSpc>
+                      </a:pPr>
+                      <a:r>
+                        <a:rPr sz="1100" b="0">
+                          <a:solidFill>
+                            <a:srgbClr val="322014"/>
+                          </a:solidFill>
+                          <a:latin typeface="Arial"/>
+                        </a:rPr>
+                        <a:t>Abandons $163K of revenue and two developing markets; 3PL restructuring removes the same losses while keeping every sale</a:t>
+                      </a:r>
+                    </a:p>
+                  </a:txBody>
+                  <a:tcPr marL="91440" marR="73152" marT="45720" marB="45720" anchor="ctr">
+                    <a:lnT w="9525" cap="flat" cmpd="sng" algn="ctr">
+                      <a:solidFill>
+                        <a:srgbClr val="E2DCD2"/>
+                      </a:solidFill>
+                    </a:lnT>
+                    <a:solidFill>
+                      <a:srgbClr val="FFFFFF"/>
+                    </a:solidFill>
+                  </a:tcPr>
+                </a:tc>
+                <a:tc>
+                  <a:txBody>
+                    <a:bodyPr wrap="square"/>
+                    <a:lstStyle/>
+                    <a:p>
+                      <a:pPr>
+                        <a:lnSpc>
+                          <a:spcPct val="105000"/>
+                        </a:lnSpc>
+                      </a:pPr>
+                      <a:r>
+                        <a:rPr sz="1100" b="1">
+                          <a:solidFill>
+                            <a:srgbClr val="322014"/>
+                          </a:solidFill>
+                          <a:latin typeface="Arial"/>
+                        </a:rPr>
+                        <a:t>Eliminated</a:t>
+                      </a:r>
+                    </a:p>
+                  </a:txBody>
+                  <a:tcPr marL="91440" marR="73152" marT="45720" marB="45720" anchor="ctr">
+                    <a:lnT w="9525" cap="flat" cmpd="sng" algn="ctr">
+                      <a:solidFill>
+                        <a:srgbClr val="E2DCD2"/>
+                      </a:solidFill>
+                    </a:lnT>
+                    <a:solidFill>
+                      <a:srgbClr val="FFFFFF"/>
+                    </a:solidFill>
+                  </a:tcPr>
+                </a:tc>
+              </a:tr>
+              <a:tr h="1133856">
+                <a:tc>
+                  <a:txBody>
+                    <a:bodyPr wrap="square"/>
+                    <a:lstStyle/>
+                    <a:p>
+                      <a:pPr>
+                        <a:lnSpc>
+                          <a:spcPct val="105000"/>
+                        </a:lnSpc>
+                      </a:pPr>
+                      <a:r>
+                        <a:rPr sz="1400" b="1">
+                          <a:solidFill>
+                            <a:srgbClr val="5A3921"/>
+                          </a:solidFill>
+                          <a:latin typeface="Georgia"/>
+                        </a:rPr>
+                        <a:t>Renegotiate carrier rates company-wide</a:t>
+                      </a:r>
+                    </a:p>
+                  </a:txBody>
+                  <a:tcPr marL="91440" marR="73152" marT="45720" marB="45720" anchor="ctr">
+                    <a:lnR w="19050" cap="flat" cmpd="sng" algn="ctr">
+                      <a:solidFill>
+                        <a:srgbClr val="322014"/>
+                      </a:solidFill>
+                    </a:lnR>
+                    <a:lnB w="0" cap="flat" cmpd="sng" algn="ctr">
+                      <a:solidFill>
+                        <a:srgbClr val="FFFFFF"/>
+                      </a:solidFill>
+                    </a:lnB>
+                    <a:lnT w="9525" cap="flat" cmpd="sng" algn="ctr">
+                      <a:solidFill>
+                        <a:srgbClr val="E2DCD2"/>
+                      </a:solidFill>
+                    </a:lnT>
+                    <a:solidFill>
+                      <a:srgbClr val="FFFFFF"/>
+                    </a:solidFill>
+                  </a:tcPr>
+                </a:tc>
+                <a:tc>
+                  <a:txBody>
+                    <a:bodyPr wrap="square"/>
+                    <a:lstStyle/>
+                    <a:p>
+                      <a:pPr>
+                        <a:lnSpc>
+                          <a:spcPct val="105000"/>
+                        </a:lnSpc>
+                      </a:pPr>
+                      <a:r>
+                        <a:rPr sz="1100" b="0">
+                          <a:solidFill>
+                            <a:srgbClr val="322014"/>
+                          </a:solidFill>
+                          <a:latin typeface="Arial"/>
+                        </a:rPr>
+                        <a:t>Cheaper freight on every order</a:t>
+                      </a:r>
+                    </a:p>
+                  </a:txBody>
+                  <a:tcPr marL="91440" marR="73152" marT="45720" marB="45720" anchor="ctr">
+                    <a:lnB w="0" cap="flat" cmpd="sng" algn="ctr">
+                      <a:solidFill>
+                        <a:srgbClr val="FFFFFF"/>
+                      </a:solidFill>
+                    </a:lnB>
+                    <a:lnT w="9525" cap="flat" cmpd="sng" algn="ctr">
+                      <a:solidFill>
+                        <a:srgbClr val="E2DCD2"/>
+                      </a:solidFill>
+                    </a:lnT>
+                    <a:solidFill>
+                      <a:srgbClr val="FFFFFF"/>
+                    </a:solidFill>
+                  </a:tcPr>
+                </a:tc>
+                <a:tc>
+                  <a:txBody>
+                    <a:bodyPr wrap="square"/>
+                    <a:lstStyle/>
+                    <a:p>
+                      <a:pPr>
+                        <a:lnSpc>
+                          <a:spcPct val="105000"/>
+                        </a:lnSpc>
+                      </a:pPr>
+                      <a:r>
+                        <a:rPr sz="1100" b="0">
+                          <a:solidFill>
+                            <a:srgbClr val="322014"/>
+                          </a:solidFill>
+                          <a:latin typeface="Arial"/>
+                        </a:rPr>
+                        <a:t>Freight is $1.35M over four years; a realistic ~10% cut returns ~$0.14M after 12+ months of contracting, leaving the $814,682 discount leak untouched</a:t>
+                      </a:r>
+                    </a:p>
+                  </a:txBody>
+                  <a:tcPr marL="91440" marR="73152" marT="45720" marB="45720" anchor="ctr">
+                    <a:lnB w="0" cap="flat" cmpd="sng" algn="ctr">
+                      <a:solidFill>
+                        <a:srgbClr val="FFFFFF"/>
+                      </a:solidFill>
+                    </a:lnB>
+                    <a:lnT w="9525" cap="flat" cmpd="sng" algn="ctr">
+                      <a:solidFill>
+                        <a:srgbClr val="E2DCD2"/>
+                      </a:solidFill>
+                    </a:lnT>
+                    <a:solidFill>
+                      <a:srgbClr val="FFFFFF"/>
+                    </a:solidFill>
+                  </a:tcPr>
+                </a:tc>
+                <a:tc>
+                  <a:txBody>
+                    <a:bodyPr wrap="square"/>
+                    <a:lstStyle/>
+                    <a:p>
+                      <a:pPr>
+                        <a:lnSpc>
+                          <a:spcPct val="105000"/>
+                        </a:lnSpc>
+                      </a:pPr>
+                      <a:r>
+                        <a:rPr sz="1100" b="1">
+                          <a:solidFill>
+                            <a:srgbClr val="322014"/>
+                          </a:solidFill>
+                          <a:latin typeface="Arial"/>
+                        </a:rPr>
+                        <a:t>Support lever only</a:t>
+                      </a:r>
+                    </a:p>
+                  </a:txBody>
+                  <a:tcPr marL="91440" marR="73152" marT="45720" marB="45720" anchor="ctr">
+                    <a:lnB w="0" cap="flat" cmpd="sng" algn="ctr">
+                      <a:solidFill>
+                        <a:srgbClr val="FFFFFF"/>
+                      </a:solidFill>
+                    </a:lnB>
+                    <a:lnT w="9525" cap="flat" cmpd="sng" algn="ctr">
+                      <a:solidFill>
+                        <a:srgbClr val="E2DCD2"/>
+                      </a:solidFill>
+                    </a:lnT>
+                    <a:solidFill>
+                      <a:srgbClr val="FFFFFF"/>
+                    </a:solidFill>
+                  </a:tcPr>
+                </a:tc>
+              </a:tr>
+            </a:tbl>
+          </a:graphicData>
+        </a:graphic>
+      </p:graphicFrame>
+      <p:sp>
+        <p:nvSpPr>
+          <p:cNvPr id="10" name="TextBox 9"/>
+          <p:cNvSpPr txBox="1"/>
+          <p:nvPr/>
+        </p:nvSpPr>
+        <p:spPr>
+          <a:xfrm>
+            <a:off x="566928" y="5879592"/>
+            <a:ext cx="11057839" cy="201168"/>
+          </a:xfrm>
+          <a:prstGeom prst="rect">
+            <a:avLst/>
+          </a:prstGeom>
+          <a:noFill/>
+        </p:spPr>
+        <p:txBody>
+          <a:bodyPr wrap="square" anchor="t" lIns="0" rIns="0" tIns="0" bIns="0">
+            <a:spAutoFit/>
+          </a:bodyPr>
+          <a:lstStyle/>
+          <a:p>
+            <a:pPr algn="l">
+              <a:lnSpc>
+                <a:spcPct val="106000"/>
+              </a:lnSpc>
+              <a:spcBef>
+                <a:spcPts val="0"/>
+              </a:spcBef>
+              <a:spcAft>
+                <a:spcPts val="300"/>
+              </a:spcAft>
+            </a:pPr>
+            <a:r>
+              <a:rPr sz="850" b="0" i="0">
+                <a:solidFill>
+                  <a:srgbClr val="8A7B6B"/>
+                </a:solidFill>
+                <a:latin typeface="Arial"/>
+              </a:rPr>
+              <a:t>Capping discounts at 20% dominates: it is the only alternative that returns more than it risks, needs no capital, and takes effect inside two months.</a:t>
+            </a:r>
+          </a:p>
+        </p:txBody>
+      </p:sp>
+      <p:sp>
+        <p:nvSpPr>
+          <p:cNvPr id="11" name="TextBox 10"/>
+          <p:cNvSpPr txBox="1"/>
+          <p:nvPr/>
+        </p:nvSpPr>
+        <p:spPr>
+          <a:xfrm>
+            <a:off x="566928" y="6099048"/>
+            <a:ext cx="11057839" cy="237744"/>
+          </a:xfrm>
+          <a:prstGeom prst="rect">
+            <a:avLst/>
+          </a:prstGeom>
+          <a:noFill/>
+        </p:spPr>
+        <p:txBody>
+          <a:bodyPr wrap="square" anchor="t" lIns="0" rIns="0" tIns="0" bIns="0">
+            <a:spAutoFit/>
+          </a:bodyPr>
+          <a:lstStyle/>
+          <a:p>
+            <a:pPr algn="l">
+              <a:lnSpc>
+                <a:spcPct val="105000"/>
+              </a:lnSpc>
+              <a:spcBef>
+                <a:spcPts val="0"/>
+              </a:spcBef>
+              <a:spcAft>
+                <a:spcPts val="300"/>
+              </a:spcAft>
+            </a:pPr>
+            <a:r>
+              <a:rPr sz="750" b="0" i="0">
+                <a:solidFill>
+                  <a:srgbClr val="8A7B6B"/>
+                </a:solidFill>
+                <a:latin typeface="Arial"/>
+              </a:rPr>
+              <a:t>Source: alternatives assessed on the FY2011-FY2014 ledger. Freight totals $1.35M (10.7% of sales); deep-discount losses $814,682 across 11,328 lines; Turkey and Nigeria revenue $163K. Modelling estimates, not forecasts.</a:t>
+            </a:r>
+          </a:p>
+        </p:txBody>
+      </p:sp>
+    </p:spTree>
+  </p:cSld>
+  <p:clrMapOvr>
+    <a:masterClrMapping/>
+  </p:clrMapOvr>
+</p:sld>
+</file>
+
+<file path=ppt/slides/slide12.xml><?xml version="1.0" encoding="utf-8"?>
 <p:sld xmlns:a="http://schemas.openxmlformats.org/drawingml/2006/main" xmlns:p="http://schemas.openxmlformats.org/presentationml/2006/main" xmlns:r="http://schemas.openxmlformats.org/officeDocument/2006/relationships">
   <p:cSld>
     <p:spTree>
@@ -8127,7 +10888,7 @@
 </p:sld>
 </file>
 
-<file path=ppt/slides/slide12.xml><?xml version="1.0" encoding="utf-8"?>
+<file path=ppt/slides/slide13.xml><?xml version="1.0" encoding="utf-8"?>
 <p:sld xmlns:a="http://schemas.openxmlformats.org/drawingml/2006/main" xmlns:p="http://schemas.openxmlformats.org/presentationml/2006/main" xmlns:r="http://schemas.openxmlformats.org/officeDocument/2006/relationships">
   <p:cSld>
     <p:spTree>
@@ -10019,7 +12780,7 @@
 </p:sld>
 </file>
 
-<file path=ppt/slides/slide13.xml><?xml version="1.0" encoding="utf-8"?>
+<file path=ppt/slides/slide14.xml><?xml version="1.0" encoding="utf-8"?>
 <p:sld xmlns:a="http://schemas.openxmlformats.org/drawingml/2006/main" xmlns:p="http://schemas.openxmlformats.org/presentationml/2006/main" xmlns:r="http://schemas.openxmlformats.org/officeDocument/2006/relationships">
   <p:cSld>
     <p:spTree>
@@ -11593,7 +14354,7 @@
 </p:sld>
 </file>
 
-<file path=ppt/slides/slide14.xml><?xml version="1.0" encoding="utf-8"?>
+<file path=ppt/slides/slide15.xml><?xml version="1.0" encoding="utf-8"?>
 <p:sld xmlns:a="http://schemas.openxmlformats.org/drawingml/2006/main" xmlns:p="http://schemas.openxmlformats.org/presentationml/2006/main" xmlns:r="http://schemas.openxmlformats.org/officeDocument/2006/relationships">
   <p:cSld>
     <p:spTree>
@@ -12728,7 +15489,7 @@
 </p:sld>
 </file>
 
-<file path=ppt/slides/slide15.xml><?xml version="1.0" encoding="utf-8"?>
+<file path=ppt/slides/slide16.xml><?xml version="1.0" encoding="utf-8"?>
 <p:sld xmlns:a="http://schemas.openxmlformats.org/drawingml/2006/main" xmlns:p="http://schemas.openxmlformats.org/presentationml/2006/main" xmlns:r="http://schemas.openxmlformats.org/officeDocument/2006/relationships">
   <p:cSld>
     <p:spTree>
@@ -13892,7 +16653,7 @@
 </p:sld>
 </file>
 
-<file path=ppt/slides/slide16.xml><?xml version="1.0" encoding="utf-8"?>
+<file path=ppt/slides/slide17.xml><?xml version="1.0" encoding="utf-8"?>
 <p:sld xmlns:a="http://schemas.openxmlformats.org/drawingml/2006/main" xmlns:p="http://schemas.openxmlformats.org/presentationml/2006/main" xmlns:r="http://schemas.openxmlformats.org/officeDocument/2006/relationships">
   <p:cSld>
     <p:spTree>
@@ -14307,992 +17068,6 @@
                 <a:latin typeface="Arial"/>
               </a:rPr>
               <a:t>Source data: Global Superstore transaction ledger, FY2011-FY2014 (51,290 order lines). Deck produced with consulting-pptx-skill (github.com/carnot-tech/consulting-pptx-skill).</a:t>
-            </a:r>
-          </a:p>
-        </p:txBody>
-      </p:sp>
-    </p:spTree>
-  </p:cSld>
-  <p:clrMapOvr>
-    <a:masterClrMapping/>
-  </p:clrMapOvr>
-</p:sld>
-</file>
-
-<file path=ppt/slides/slide17.xml><?xml version="1.0" encoding="utf-8"?>
-<p:sld xmlns:a="http://schemas.openxmlformats.org/drawingml/2006/main" xmlns:p="http://schemas.openxmlformats.org/presentationml/2006/main" xmlns:r="http://schemas.openxmlformats.org/officeDocument/2006/relationships">
-  <p:cSld>
-    <p:spTree>
-      <p:nvGrpSpPr>
-        <p:cNvPr id="1" name=""/>
-        <p:cNvGrpSpPr/>
-        <p:nvPr/>
-      </p:nvGrpSpPr>
-      <p:grpSpPr/>
-      <p:sp>
-        <p:nvSpPr>
-          <p:cNvPr id="2" name="TextBox 1"/>
-          <p:cNvSpPr txBox="1"/>
-          <p:nvPr/>
-        </p:nvSpPr>
-        <p:spPr>
-          <a:xfrm>
-            <a:off x="566928" y="310896"/>
-            <a:ext cx="6634703" cy="310896"/>
-          </a:xfrm>
-          <a:prstGeom prst="rect">
-            <a:avLst/>
-          </a:prstGeom>
-          <a:noFill/>
-        </p:spPr>
-        <p:txBody>
-          <a:bodyPr wrap="square" anchor="t" lIns="0" rIns="0" tIns="0" bIns="0">
-            <a:spAutoFit/>
-          </a:bodyPr>
-          <a:lstStyle/>
-          <a:p>
-            <a:pPr algn="l">
-              <a:lnSpc>
-                <a:spcPct val="106000"/>
-              </a:lnSpc>
-              <a:spcBef>
-                <a:spcPts val="0"/>
-              </a:spcBef>
-              <a:spcAft>
-                <a:spcPts val="300"/>
-              </a:spcAft>
-            </a:pPr>
-            <a:r>
-              <a:rPr sz="1800" b="1" i="0">
-                <a:solidFill>
-                  <a:srgbClr val="322014"/>
-                </a:solidFill>
-                <a:latin typeface="Georgia"/>
-              </a:rPr>
-              <a:t>Global Superstore · Revival Strategy</a:t>
-            </a:r>
-          </a:p>
-        </p:txBody>
-      </p:sp>
-      <p:sp>
-        <p:nvSpPr>
-          <p:cNvPr id="3" name="TextBox 2"/>
-          <p:cNvSpPr txBox="1"/>
-          <p:nvPr/>
-        </p:nvSpPr>
-        <p:spPr>
-          <a:xfrm>
-            <a:off x="7784287" y="429768"/>
-            <a:ext cx="3840480" cy="219456"/>
-          </a:xfrm>
-          <a:prstGeom prst="rect">
-            <a:avLst/>
-          </a:prstGeom>
-          <a:noFill/>
-        </p:spPr>
-        <p:txBody>
-          <a:bodyPr wrap="square" anchor="t" lIns="0" rIns="0" tIns="0" bIns="0">
-            <a:spAutoFit/>
-          </a:bodyPr>
-          <a:lstStyle/>
-          <a:p>
-            <a:pPr algn="r">
-              <a:lnSpc>
-                <a:spcPct val="106000"/>
-              </a:lnSpc>
-              <a:spcBef>
-                <a:spcPts val="0"/>
-              </a:spcBef>
-              <a:spcAft>
-                <a:spcPts val="300"/>
-              </a:spcAft>
-            </a:pPr>
-            <a:r>
-              <a:rPr sz="750" b="1" i="0">
-                <a:solidFill>
-                  <a:srgbClr val="8A7B6B"/>
-                </a:solidFill>
-                <a:latin typeface="Arial"/>
-              </a:rPr>
-              <a:t>Turnaround · Options considered</a:t>
-            </a:r>
-          </a:p>
-        </p:txBody>
-      </p:sp>
-      <p:cxnSp>
-        <p:nvCxnSpPr>
-          <p:cNvPr id="4" name="Connector 3"/>
-          <p:cNvCxnSpPr/>
-          <p:nvPr/>
-        </p:nvCxnSpPr>
-        <p:spPr>
-          <a:xfrm>
-            <a:off x="566928" y="658368"/>
-            <a:ext cx="11057839" cy="0"/>
-          </a:xfrm>
-          <a:prstGeom prst="line">
-            <a:avLst/>
-          </a:prstGeom>
-          <a:ln w="12700">
-            <a:solidFill>
-              <a:srgbClr val="322014"/>
-            </a:solidFill>
-          </a:ln>
-        </p:spPr>
-        <p:style>
-          <a:lnRef idx="2">
-            <a:schemeClr val="accent1"/>
-          </a:lnRef>
-          <a:fillRef idx="0">
-            <a:schemeClr val="accent1"/>
-          </a:fillRef>
-          <a:effectRef idx="1">
-            <a:schemeClr val="accent1"/>
-          </a:effectRef>
-          <a:fontRef idx="minor">
-            <a:schemeClr val="tx1"/>
-          </a:fontRef>
-        </p:style>
-      </p:cxnSp>
-      <p:cxnSp>
-        <p:nvCxnSpPr>
-          <p:cNvPr id="5" name="Connector 4"/>
-          <p:cNvCxnSpPr/>
-          <p:nvPr/>
-        </p:nvCxnSpPr>
-        <p:spPr>
-          <a:xfrm>
-            <a:off x="566928" y="6355080"/>
-            <a:ext cx="11057839" cy="0"/>
-          </a:xfrm>
-          <a:prstGeom prst="line">
-            <a:avLst/>
-          </a:prstGeom>
-          <a:ln w="9525">
-            <a:solidFill>
-              <a:srgbClr val="C5A681"/>
-            </a:solidFill>
-          </a:ln>
-        </p:spPr>
-        <p:style>
-          <a:lnRef idx="2">
-            <a:schemeClr val="accent1"/>
-          </a:lnRef>
-          <a:fillRef idx="0">
-            <a:schemeClr val="accent1"/>
-          </a:fillRef>
-          <a:effectRef idx="1">
-            <a:schemeClr val="accent1"/>
-          </a:effectRef>
-          <a:fontRef idx="minor">
-            <a:schemeClr val="tx1"/>
-          </a:fontRef>
-        </p:style>
-      </p:cxnSp>
-      <p:sp>
-        <p:nvSpPr>
-          <p:cNvPr id="6" name="TextBox 5"/>
-          <p:cNvSpPr txBox="1"/>
-          <p:nvPr/>
-        </p:nvSpPr>
-        <p:spPr>
-          <a:xfrm>
-            <a:off x="566928" y="6400800"/>
-            <a:ext cx="7740487" cy="219456"/>
-          </a:xfrm>
-          <a:prstGeom prst="rect">
-            <a:avLst/>
-          </a:prstGeom>
-          <a:noFill/>
-        </p:spPr>
-        <p:txBody>
-          <a:bodyPr wrap="square" anchor="t" lIns="0" rIns="0" tIns="0" bIns="0">
-            <a:spAutoFit/>
-          </a:bodyPr>
-          <a:lstStyle/>
-          <a:p>
-            <a:pPr algn="l">
-              <a:lnSpc>
-                <a:spcPct val="106000"/>
-              </a:lnSpc>
-              <a:spcBef>
-                <a:spcPts val="0"/>
-              </a:spcBef>
-              <a:spcAft>
-                <a:spcPts val="300"/>
-              </a:spcAft>
-            </a:pPr>
-            <a:r>
-              <a:rPr sz="850" b="1" i="0">
-                <a:solidFill>
-                  <a:srgbClr val="322014"/>
-                </a:solidFill>
-                <a:latin typeface="Arial"/>
-              </a:rPr>
-              <a:t>Global Superstore · Revival Strategy</a:t>
-            </a:r>
-          </a:p>
-        </p:txBody>
-      </p:sp>
-      <p:sp>
-        <p:nvSpPr>
-          <p:cNvPr id="7" name="TextBox 6"/>
-          <p:cNvSpPr txBox="1"/>
-          <p:nvPr/>
-        </p:nvSpPr>
-        <p:spPr>
-          <a:xfrm>
-            <a:off x="10710367" y="6400800"/>
-            <a:ext cx="914400" cy="219456"/>
-          </a:xfrm>
-          <a:prstGeom prst="rect">
-            <a:avLst/>
-          </a:prstGeom>
-          <a:noFill/>
-        </p:spPr>
-        <p:txBody>
-          <a:bodyPr wrap="square" anchor="t" lIns="0" rIns="0" tIns="0" bIns="0">
-            <a:spAutoFit/>
-          </a:bodyPr>
-          <a:lstStyle/>
-          <a:p>
-            <a:pPr algn="r">
-              <a:lnSpc>
-                <a:spcPct val="106000"/>
-              </a:lnSpc>
-              <a:spcBef>
-                <a:spcPts val="0"/>
-              </a:spcBef>
-              <a:spcAft>
-                <a:spcPts val="300"/>
-              </a:spcAft>
-            </a:pPr>
-            <a:r>
-              <a:rPr sz="850" b="0" i="0">
-                <a:solidFill>
-                  <a:srgbClr val="8A7B6B"/>
-                </a:solidFill>
-                <a:latin typeface="Arial"/>
-              </a:rPr>
-              <a:t>10</a:t>
-            </a:r>
-          </a:p>
-        </p:txBody>
-      </p:sp>
-      <p:sp>
-        <p:nvSpPr>
-          <p:cNvPr id="8" name="TextBox 7"/>
-          <p:cNvSpPr txBox="1"/>
-          <p:nvPr/>
-        </p:nvSpPr>
-        <p:spPr>
-          <a:xfrm>
-            <a:off x="566928" y="731520"/>
-            <a:ext cx="11057839" cy="822960"/>
-          </a:xfrm>
-          <a:prstGeom prst="rect">
-            <a:avLst/>
-          </a:prstGeom>
-          <a:noFill/>
-        </p:spPr>
-        <p:txBody>
-          <a:bodyPr wrap="square" anchor="t" lIns="0" rIns="0" tIns="0" bIns="0">
-            <a:spAutoFit/>
-          </a:bodyPr>
-          <a:lstStyle/>
-          <a:p>
-            <a:pPr algn="l">
-              <a:lnSpc>
-                <a:spcPct val="102000"/>
-              </a:lnSpc>
-              <a:spcBef>
-                <a:spcPts val="0"/>
-              </a:spcBef>
-              <a:spcAft>
-                <a:spcPts val="300"/>
-              </a:spcAft>
-            </a:pPr>
-            <a:r>
-              <a:rPr sz="2100" b="1" i="0">
-                <a:solidFill>
-                  <a:srgbClr val="322014"/>
-                </a:solidFill>
-                <a:latin typeface="Georgia"/>
-              </a:rPr>
-              <a:t>The three-lever recovery plan outearns every alternative tested</a:t>
-            </a:r>
-          </a:p>
-        </p:txBody>
-      </p:sp>
-      <p:graphicFrame>
-        <p:nvGraphicFramePr>
-          <p:cNvPr id="9" name="Table 8"/>
-          <p:cNvGraphicFramePr>
-            <a:graphicFrameLocks noGrp="1"/>
-          </p:cNvGraphicFramePr>
-          <p:nvPr/>
-        </p:nvGraphicFramePr>
-        <p:xfrm>
-          <a:off x="566928" y="1737360"/>
-          <a:ext cx="11064240" cy="3803904"/>
-        </p:xfrm>
-        <a:graphic>
-          <a:graphicData uri="http://schemas.openxmlformats.org/drawingml/2006/table">
-            <a:tbl>
-              <a:tblPr>
-                <a:tableStyleId>{2D5ABB26-0587-4C30-8999-92F81FD0307C}</a:tableStyleId>
-              </a:tblPr>
-              <a:tblGrid>
-                <a:gridCol w="2606040"/>
-                <a:gridCol w="4160520"/>
-                <a:gridCol w="2606040"/>
-                <a:gridCol w="1691640"/>
-              </a:tblGrid>
-              <a:tr h="402336">
-                <a:tc>
-                  <a:txBody>
-                    <a:bodyPr wrap="square"/>
-                    <a:lstStyle/>
-                    <a:p>
-                      <a:pPr>
-                        <a:lnSpc>
-                          <a:spcPct val="105000"/>
-                        </a:lnSpc>
-                      </a:pPr>
-                      <a:r>
-                        <a:rPr sz="1200" b="1">
-                          <a:solidFill>
-                            <a:srgbClr val="322014"/>
-                          </a:solidFill>
-                          <a:latin typeface="Arial"/>
-                        </a:rPr>
-                        <a:t>Alternative considered</a:t>
-                      </a:r>
-                    </a:p>
-                  </a:txBody>
-                  <a:tcPr marL="91440" marR="73152" marT="45720" marB="45720" anchor="ctr">
-                    <a:lnB w="19050" cap="flat" cmpd="sng" algn="ctr">
-                      <a:solidFill>
-                        <a:srgbClr val="322014"/>
-                      </a:solidFill>
-                    </a:lnB>
-                    <a:solidFill>
-                      <a:srgbClr val="FFFFFF"/>
-                    </a:solidFill>
-                  </a:tcPr>
-                </a:tc>
-                <a:tc>
-                  <a:txBody>
-                    <a:bodyPr wrap="square"/>
-                    <a:lstStyle/>
-                    <a:p>
-                      <a:pPr>
-                        <a:lnSpc>
-                          <a:spcPct val="105000"/>
-                        </a:lnSpc>
-                      </a:pPr>
-                      <a:r>
-                        <a:rPr sz="1200" b="1">
-                          <a:solidFill>
-                            <a:srgbClr val="322014"/>
-                          </a:solidFill>
-                          <a:latin typeface="Arial"/>
-                        </a:rPr>
-                        <a:t>What it promises</a:t>
-                      </a:r>
-                    </a:p>
-                  </a:txBody>
-                  <a:tcPr marL="91440" marR="73152" marT="45720" marB="45720" anchor="ctr">
-                    <a:lnB w="19050" cap="flat" cmpd="sng" algn="ctr">
-                      <a:solidFill>
-                        <a:srgbClr val="322014"/>
-                      </a:solidFill>
-                    </a:lnB>
-                    <a:solidFill>
-                      <a:srgbClr val="FFFFFF"/>
-                    </a:solidFill>
-                  </a:tcPr>
-                </a:tc>
-                <a:tc>
-                  <a:txBody>
-                    <a:bodyPr wrap="square"/>
-                    <a:lstStyle/>
-                    <a:p>
-                      <a:pPr>
-                        <a:lnSpc>
-                          <a:spcPct val="105000"/>
-                        </a:lnSpc>
-                      </a:pPr>
-                      <a:r>
-                        <a:rPr sz="1200" b="1">
-                          <a:solidFill>
-                            <a:srgbClr val="322014"/>
-                          </a:solidFill>
-                          <a:latin typeface="Arial"/>
-                        </a:rPr>
-                        <a:t>Why it is eliminated</a:t>
-                      </a:r>
-                    </a:p>
-                  </a:txBody>
-                  <a:tcPr marL="91440" marR="73152" marT="45720" marB="45720" anchor="ctr">
-                    <a:lnB w="19050" cap="flat" cmpd="sng" algn="ctr">
-                      <a:solidFill>
-                        <a:srgbClr val="322014"/>
-                      </a:solidFill>
-                    </a:lnB>
-                    <a:solidFill>
-                      <a:srgbClr val="FFFFFF"/>
-                    </a:solidFill>
-                  </a:tcPr>
-                </a:tc>
-                <a:tc>
-                  <a:txBody>
-                    <a:bodyPr wrap="square"/>
-                    <a:lstStyle/>
-                    <a:p>
-                      <a:pPr>
-                        <a:lnSpc>
-                          <a:spcPct val="105000"/>
-                        </a:lnSpc>
-                      </a:pPr>
-                      <a:r>
-                        <a:rPr sz="1200" b="1">
-                          <a:solidFill>
-                            <a:srgbClr val="322014"/>
-                          </a:solidFill>
-                          <a:latin typeface="Arial"/>
-                        </a:rPr>
-                        <a:t>Verdict</a:t>
-                      </a:r>
-                    </a:p>
-                  </a:txBody>
-                  <a:tcPr marL="91440" marR="73152" marT="45720" marB="45720" anchor="ctr">
-                    <a:lnB w="19050" cap="flat" cmpd="sng" algn="ctr">
-                      <a:solidFill>
-                        <a:srgbClr val="322014"/>
-                      </a:solidFill>
-                    </a:lnB>
-                    <a:solidFill>
-                      <a:srgbClr val="FFFFFF"/>
-                    </a:solidFill>
-                  </a:tcPr>
-                </a:tc>
-              </a:tr>
-              <a:tr h="1133856">
-                <a:tc>
-                  <a:txBody>
-                    <a:bodyPr wrap="square"/>
-                    <a:lstStyle/>
-                    <a:p>
-                      <a:pPr>
-                        <a:lnSpc>
-                          <a:spcPct val="105000"/>
-                        </a:lnSpc>
-                      </a:pPr>
-                      <a:r>
-                        <a:rPr sz="1400" b="1">
-                          <a:solidFill>
-                            <a:srgbClr val="5A3921"/>
-                          </a:solidFill>
-                          <a:latin typeface="Georgia"/>
-                        </a:rPr>
-                        <a:t>Raise list prices, allow deeper discounts</a:t>
-                      </a:r>
-                    </a:p>
-                  </a:txBody>
-                  <a:tcPr marL="91440" marR="73152" marT="45720" marB="45720" anchor="ctr">
-                    <a:lnR w="19050" cap="flat" cmpd="sng" algn="ctr">
-                      <a:solidFill>
-                        <a:srgbClr val="322014"/>
-                      </a:solidFill>
-                    </a:lnR>
-                    <a:lnT w="9525" cap="flat" cmpd="sng" algn="ctr">
-                      <a:solidFill>
-                        <a:srgbClr val="E2DCD2"/>
-                      </a:solidFill>
-                    </a:lnT>
-                    <a:solidFill>
-                      <a:srgbClr val="FFFFFF"/>
-                    </a:solidFill>
-                  </a:tcPr>
-                </a:tc>
-                <a:tc>
-                  <a:txBody>
-                    <a:bodyPr wrap="square"/>
-                    <a:lstStyle/>
-                    <a:p>
-                      <a:pPr>
-                        <a:lnSpc>
-                          <a:spcPct val="105000"/>
-                        </a:lnSpc>
-                      </a:pPr>
-                      <a:r>
-                        <a:rPr sz="1100" b="0">
-                          <a:solidFill>
-                            <a:srgbClr val="322014"/>
-                          </a:solidFill>
-                          <a:latin typeface="Arial"/>
-                        </a:rPr>
-                        <a:t>Bigger concessions look affordable from a higher invoice price</a:t>
-                      </a:r>
-                    </a:p>
-                  </a:txBody>
-                  <a:tcPr marL="91440" marR="73152" marT="45720" marB="45720" anchor="ctr">
-                    <a:lnT w="9525" cap="flat" cmpd="sng" algn="ctr">
-                      <a:solidFill>
-                        <a:srgbClr val="E2DCD2"/>
-                      </a:solidFill>
-                    </a:lnT>
-                    <a:solidFill>
-                      <a:srgbClr val="FFFFFF"/>
-                    </a:solidFill>
-                  </a:tcPr>
-                </a:tc>
-                <a:tc>
-                  <a:txBody>
-                    <a:bodyPr wrap="square"/>
-                    <a:lstStyle/>
-                    <a:p>
-                      <a:pPr>
-                        <a:lnSpc>
-                          <a:spcPct val="105000"/>
-                        </a:lnSpc>
-                      </a:pPr>
-                      <a:r>
-                        <a:rPr sz="1100" b="0">
-                          <a:solidFill>
-                            <a:srgbClr val="322014"/>
-                          </a:solidFill>
-                          <a:latin typeface="Arial"/>
-                        </a:rPr>
-                        <a:t>The leak follows the discount, not the list price: margin runs +9.9% at 10-20% off but -5.5% at 20-30%, and 88.5% of loss dollars sit above the 20% line</a:t>
-                      </a:r>
-                    </a:p>
-                  </a:txBody>
-                  <a:tcPr marL="91440" marR="73152" marT="45720" marB="45720" anchor="ctr">
-                    <a:lnT w="9525" cap="flat" cmpd="sng" algn="ctr">
-                      <a:solidFill>
-                        <a:srgbClr val="E2DCD2"/>
-                      </a:solidFill>
-                    </a:lnT>
-                    <a:solidFill>
-                      <a:srgbClr val="FFFFFF"/>
-                    </a:solidFill>
-                  </a:tcPr>
-                </a:tc>
-                <a:tc>
-                  <a:txBody>
-                    <a:bodyPr wrap="square"/>
-                    <a:lstStyle/>
-                    <a:p>
-                      <a:pPr>
-                        <a:lnSpc>
-                          <a:spcPct val="105000"/>
-                        </a:lnSpc>
-                      </a:pPr>
-                      <a:r>
-                        <a:rPr sz="1100" b="1">
-                          <a:solidFill>
-                            <a:srgbClr val="322014"/>
-                          </a:solidFill>
-                          <a:latin typeface="Arial"/>
-                        </a:rPr>
-                        <a:t>Eliminated</a:t>
-                      </a:r>
-                    </a:p>
-                  </a:txBody>
-                  <a:tcPr marL="91440" marR="73152" marT="45720" marB="45720" anchor="ctr">
-                    <a:lnT w="9525" cap="flat" cmpd="sng" algn="ctr">
-                      <a:solidFill>
-                        <a:srgbClr val="E2DCD2"/>
-                      </a:solidFill>
-                    </a:lnT>
-                    <a:solidFill>
-                      <a:srgbClr val="FFFFFF"/>
-                    </a:solidFill>
-                  </a:tcPr>
-                </a:tc>
-              </a:tr>
-              <a:tr h="1133856">
-                <a:tc>
-                  <a:txBody>
-                    <a:bodyPr wrap="square"/>
-                    <a:lstStyle/>
-                    <a:p>
-                      <a:pPr>
-                        <a:lnSpc>
-                          <a:spcPct val="105000"/>
-                        </a:lnSpc>
-                      </a:pPr>
-                      <a:r>
-                        <a:rPr sz="1400" b="1">
-                          <a:solidFill>
-                            <a:srgbClr val="5A3921"/>
-                          </a:solidFill>
-                          <a:latin typeface="Georgia"/>
-                        </a:rPr>
-                        <a:t>Exit Turkey and Nigeria entirely</a:t>
-                      </a:r>
-                    </a:p>
-                  </a:txBody>
-                  <a:tcPr marL="91440" marR="73152" marT="45720" marB="45720" anchor="ctr">
-                    <a:lnR w="19050" cap="flat" cmpd="sng" algn="ctr">
-                      <a:solidFill>
-                        <a:srgbClr val="322014"/>
-                      </a:solidFill>
-                    </a:lnR>
-                    <a:lnT w="9525" cap="flat" cmpd="sng" algn="ctr">
-                      <a:solidFill>
-                        <a:srgbClr val="E2DCD2"/>
-                      </a:solidFill>
-                    </a:lnT>
-                    <a:solidFill>
-                      <a:srgbClr val="FFFFFF"/>
-                    </a:solidFill>
-                  </a:tcPr>
-                </a:tc>
-                <a:tc>
-                  <a:txBody>
-                    <a:bodyPr wrap="square"/>
-                    <a:lstStyle/>
-                    <a:p>
-                      <a:pPr>
-                        <a:lnSpc>
-                          <a:spcPct val="105000"/>
-                        </a:lnSpc>
-                      </a:pPr>
-                      <a:r>
-                        <a:rPr sz="1100" b="0">
-                          <a:solidFill>
-                            <a:srgbClr val="322014"/>
-                          </a:solidFill>
-                          <a:latin typeface="Arial"/>
-                        </a:rPr>
-                        <a:t>Instant stop to the -$179K country deficit</a:t>
-                      </a:r>
-                    </a:p>
-                  </a:txBody>
-                  <a:tcPr marL="91440" marR="73152" marT="45720" marB="45720" anchor="ctr">
-                    <a:lnT w="9525" cap="flat" cmpd="sng" algn="ctr">
-                      <a:solidFill>
-                        <a:srgbClr val="E2DCD2"/>
-                      </a:solidFill>
-                    </a:lnT>
-                    <a:solidFill>
-                      <a:srgbClr val="FFFFFF"/>
-                    </a:solidFill>
-                  </a:tcPr>
-                </a:tc>
-                <a:tc>
-                  <a:txBody>
-                    <a:bodyPr wrap="square"/>
-                    <a:lstStyle/>
-                    <a:p>
-                      <a:pPr>
-                        <a:lnSpc>
-                          <a:spcPct val="105000"/>
-                        </a:lnSpc>
-                      </a:pPr>
-                      <a:r>
-                        <a:rPr sz="1100" b="0">
-                          <a:solidFill>
-                            <a:srgbClr val="322014"/>
-                          </a:solidFill>
-                          <a:latin typeface="Arial"/>
-                        </a:rPr>
-                        <a:t>Abandons $163K of revenue and two developing markets; 3PL restructuring removes the same losses while keeping every sale</a:t>
-                      </a:r>
-                    </a:p>
-                  </a:txBody>
-                  <a:tcPr marL="91440" marR="73152" marT="45720" marB="45720" anchor="ctr">
-                    <a:lnT w="9525" cap="flat" cmpd="sng" algn="ctr">
-                      <a:solidFill>
-                        <a:srgbClr val="E2DCD2"/>
-                      </a:solidFill>
-                    </a:lnT>
-                    <a:solidFill>
-                      <a:srgbClr val="FFFFFF"/>
-                    </a:solidFill>
-                  </a:tcPr>
-                </a:tc>
-                <a:tc>
-                  <a:txBody>
-                    <a:bodyPr wrap="square"/>
-                    <a:lstStyle/>
-                    <a:p>
-                      <a:pPr>
-                        <a:lnSpc>
-                          <a:spcPct val="105000"/>
-                        </a:lnSpc>
-                      </a:pPr>
-                      <a:r>
-                        <a:rPr sz="1100" b="1">
-                          <a:solidFill>
-                            <a:srgbClr val="322014"/>
-                          </a:solidFill>
-                          <a:latin typeface="Arial"/>
-                        </a:rPr>
-                        <a:t>Eliminated</a:t>
-                      </a:r>
-                    </a:p>
-                  </a:txBody>
-                  <a:tcPr marL="91440" marR="73152" marT="45720" marB="45720" anchor="ctr">
-                    <a:lnT w="9525" cap="flat" cmpd="sng" algn="ctr">
-                      <a:solidFill>
-                        <a:srgbClr val="E2DCD2"/>
-                      </a:solidFill>
-                    </a:lnT>
-                    <a:solidFill>
-                      <a:srgbClr val="FFFFFF"/>
-                    </a:solidFill>
-                  </a:tcPr>
-                </a:tc>
-              </a:tr>
-              <a:tr h="1133856">
-                <a:tc>
-                  <a:txBody>
-                    <a:bodyPr wrap="square"/>
-                    <a:lstStyle/>
-                    <a:p>
-                      <a:pPr>
-                        <a:lnSpc>
-                          <a:spcPct val="105000"/>
-                        </a:lnSpc>
-                      </a:pPr>
-                      <a:r>
-                        <a:rPr sz="1400" b="1">
-                          <a:solidFill>
-                            <a:srgbClr val="5A3921"/>
-                          </a:solidFill>
-                          <a:latin typeface="Georgia"/>
-                        </a:rPr>
-                        <a:t>Renegotiate carrier rates company-wide</a:t>
-                      </a:r>
-                    </a:p>
-                  </a:txBody>
-                  <a:tcPr marL="91440" marR="73152" marT="45720" marB="45720" anchor="ctr">
-                    <a:lnR w="19050" cap="flat" cmpd="sng" algn="ctr">
-                      <a:solidFill>
-                        <a:srgbClr val="322014"/>
-                      </a:solidFill>
-                    </a:lnR>
-                    <a:lnB w="0" cap="flat" cmpd="sng" algn="ctr">
-                      <a:solidFill>
-                        <a:srgbClr val="FFFFFF"/>
-                      </a:solidFill>
-                    </a:lnB>
-                    <a:lnT w="9525" cap="flat" cmpd="sng" algn="ctr">
-                      <a:solidFill>
-                        <a:srgbClr val="E2DCD2"/>
-                      </a:solidFill>
-                    </a:lnT>
-                    <a:solidFill>
-                      <a:srgbClr val="FFFFFF"/>
-                    </a:solidFill>
-                  </a:tcPr>
-                </a:tc>
-                <a:tc>
-                  <a:txBody>
-                    <a:bodyPr wrap="square"/>
-                    <a:lstStyle/>
-                    <a:p>
-                      <a:pPr>
-                        <a:lnSpc>
-                          <a:spcPct val="105000"/>
-                        </a:lnSpc>
-                      </a:pPr>
-                      <a:r>
-                        <a:rPr sz="1100" b="0">
-                          <a:solidFill>
-                            <a:srgbClr val="322014"/>
-                          </a:solidFill>
-                          <a:latin typeface="Arial"/>
-                        </a:rPr>
-                        <a:t>Cheaper freight on every order</a:t>
-                      </a:r>
-                    </a:p>
-                  </a:txBody>
-                  <a:tcPr marL="91440" marR="73152" marT="45720" marB="45720" anchor="ctr">
-                    <a:lnB w="0" cap="flat" cmpd="sng" algn="ctr">
-                      <a:solidFill>
-                        <a:srgbClr val="FFFFFF"/>
-                      </a:solidFill>
-                    </a:lnB>
-                    <a:lnT w="9525" cap="flat" cmpd="sng" algn="ctr">
-                      <a:solidFill>
-                        <a:srgbClr val="E2DCD2"/>
-                      </a:solidFill>
-                    </a:lnT>
-                    <a:solidFill>
-                      <a:srgbClr val="FFFFFF"/>
-                    </a:solidFill>
-                  </a:tcPr>
-                </a:tc>
-                <a:tc>
-                  <a:txBody>
-                    <a:bodyPr wrap="square"/>
-                    <a:lstStyle/>
-                    <a:p>
-                      <a:pPr>
-                        <a:lnSpc>
-                          <a:spcPct val="105000"/>
-                        </a:lnSpc>
-                      </a:pPr>
-                      <a:r>
-                        <a:rPr sz="1100" b="0">
-                          <a:solidFill>
-                            <a:srgbClr val="322014"/>
-                          </a:solidFill>
-                          <a:latin typeface="Arial"/>
-                        </a:rPr>
-                        <a:t>Freight is $1.35M over four years; a realistic ~10% cut returns ~$0.14M after 12+ months of contracting, leaving the $814,682 discount leak untouched</a:t>
-                      </a:r>
-                    </a:p>
-                  </a:txBody>
-                  <a:tcPr marL="91440" marR="73152" marT="45720" marB="45720" anchor="ctr">
-                    <a:lnB w="0" cap="flat" cmpd="sng" algn="ctr">
-                      <a:solidFill>
-                        <a:srgbClr val="FFFFFF"/>
-                      </a:solidFill>
-                    </a:lnB>
-                    <a:lnT w="9525" cap="flat" cmpd="sng" algn="ctr">
-                      <a:solidFill>
-                        <a:srgbClr val="E2DCD2"/>
-                      </a:solidFill>
-                    </a:lnT>
-                    <a:solidFill>
-                      <a:srgbClr val="FFFFFF"/>
-                    </a:solidFill>
-                  </a:tcPr>
-                </a:tc>
-                <a:tc>
-                  <a:txBody>
-                    <a:bodyPr wrap="square"/>
-                    <a:lstStyle/>
-                    <a:p>
-                      <a:pPr>
-                        <a:lnSpc>
-                          <a:spcPct val="105000"/>
-                        </a:lnSpc>
-                      </a:pPr>
-                      <a:r>
-                        <a:rPr sz="1100" b="1">
-                          <a:solidFill>
-                            <a:srgbClr val="322014"/>
-                          </a:solidFill>
-                          <a:latin typeface="Arial"/>
-                        </a:rPr>
-                        <a:t>Support lever only</a:t>
-                      </a:r>
-                    </a:p>
-                  </a:txBody>
-                  <a:tcPr marL="91440" marR="73152" marT="45720" marB="45720" anchor="ctr">
-                    <a:lnB w="0" cap="flat" cmpd="sng" algn="ctr">
-                      <a:solidFill>
-                        <a:srgbClr val="FFFFFF"/>
-                      </a:solidFill>
-                    </a:lnB>
-                    <a:lnT w="9525" cap="flat" cmpd="sng" algn="ctr">
-                      <a:solidFill>
-                        <a:srgbClr val="E2DCD2"/>
-                      </a:solidFill>
-                    </a:lnT>
-                    <a:solidFill>
-                      <a:srgbClr val="FFFFFF"/>
-                    </a:solidFill>
-                  </a:tcPr>
-                </a:tc>
-              </a:tr>
-            </a:tbl>
-          </a:graphicData>
-        </a:graphic>
-      </p:graphicFrame>
-      <p:sp>
-        <p:nvSpPr>
-          <p:cNvPr id="10" name="TextBox 9"/>
-          <p:cNvSpPr txBox="1"/>
-          <p:nvPr/>
-        </p:nvSpPr>
-        <p:spPr>
-          <a:xfrm>
-            <a:off x="566928" y="5879592"/>
-            <a:ext cx="11057839" cy="201168"/>
-          </a:xfrm>
-          <a:prstGeom prst="rect">
-            <a:avLst/>
-          </a:prstGeom>
-          <a:noFill/>
-        </p:spPr>
-        <p:txBody>
-          <a:bodyPr wrap="square" anchor="t" lIns="0" rIns="0" tIns="0" bIns="0">
-            <a:spAutoFit/>
-          </a:bodyPr>
-          <a:lstStyle/>
-          <a:p>
-            <a:pPr algn="l">
-              <a:lnSpc>
-                <a:spcPct val="106000"/>
-              </a:lnSpc>
-              <a:spcBef>
-                <a:spcPts val="0"/>
-              </a:spcBef>
-              <a:spcAft>
-                <a:spcPts val="300"/>
-              </a:spcAft>
-            </a:pPr>
-            <a:r>
-              <a:rPr sz="850" b="0" i="0">
-                <a:solidFill>
-                  <a:srgbClr val="8A7B6B"/>
-                </a:solidFill>
-                <a:latin typeface="Arial"/>
-              </a:rPr>
-              <a:t>Capping discounts at 20% dominates: it is the only alternative that returns more than it risks, needs no capital, and takes effect inside two months.</a:t>
-            </a:r>
-          </a:p>
-        </p:txBody>
-      </p:sp>
-      <p:sp>
-        <p:nvSpPr>
-          <p:cNvPr id="11" name="TextBox 10"/>
-          <p:cNvSpPr txBox="1"/>
-          <p:nvPr/>
-        </p:nvSpPr>
-        <p:spPr>
-          <a:xfrm>
-            <a:off x="566928" y="6099048"/>
-            <a:ext cx="11057839" cy="237744"/>
-          </a:xfrm>
-          <a:prstGeom prst="rect">
-            <a:avLst/>
-          </a:prstGeom>
-          <a:noFill/>
-        </p:spPr>
-        <p:txBody>
-          <a:bodyPr wrap="square" anchor="t" lIns="0" rIns="0" tIns="0" bIns="0">
-            <a:spAutoFit/>
-          </a:bodyPr>
-          <a:lstStyle/>
-          <a:p>
-            <a:pPr algn="l">
-              <a:lnSpc>
-                <a:spcPct val="105000"/>
-              </a:lnSpc>
-              <a:spcBef>
-                <a:spcPts val="0"/>
-              </a:spcBef>
-              <a:spcAft>
-                <a:spcPts val="300"/>
-              </a:spcAft>
-            </a:pPr>
-            <a:r>
-              <a:rPr sz="750" b="0" i="0">
-                <a:solidFill>
-                  <a:srgbClr val="8A7B6B"/>
-                </a:solidFill>
-                <a:latin typeface="Arial"/>
-              </a:rPr>
-              <a:t>Source: alternatives assessed on the FY2011-FY2014 ledger. Freight totals $1.35M (10.7% of sales); deep-discount losses $814,682 across 11,328 lines; Turkey and Nigeria revenue $163K. Modelling estimates, not forecasts.</a:t>
             </a:r>
           </a:p>
         </p:txBody>
@@ -22854,4 +24629,324 @@
   </a:objectDefaults>
   <a:extraClrSchemeLst/>
 </a:theme>
+</file>
+
+<file path=ppt/theme/theme2.xml><?xml version="1.0" encoding="utf-8"?>
+<a:theme xmlns:a="http://schemas.openxmlformats.org/drawingml/2006/main" name="Office Theme">
+  <a:themeElements>
+    <a:clrScheme name="Office">
+      <a:dk1>
+        <a:sysClr val="windowText" lastClr="000000"/>
+      </a:dk1>
+      <a:lt1>
+        <a:sysClr val="window" lastClr="FFFFFF"/>
+      </a:lt1>
+      <a:dk2>
+        <a:srgbClr val="1F497D"/>
+      </a:dk2>
+      <a:lt2>
+        <a:srgbClr val="EEECE1"/>
+      </a:lt2>
+      <a:accent1>
+        <a:srgbClr val="4F81BD"/>
+      </a:accent1>
+      <a:accent2>
+        <a:srgbClr val="C0504D"/>
+      </a:accent2>
+      <a:accent3>
+        <a:srgbClr val="9BBB59"/>
+      </a:accent3>
+      <a:accent4>
+        <a:srgbClr val="8064A2"/>
+      </a:accent4>
+      <a:accent5>
+        <a:srgbClr val="4BACC6"/>
+      </a:accent5>
+      <a:accent6>
+        <a:srgbClr val="F79646"/>
+      </a:accent6>
+      <a:hlink>
+        <a:srgbClr val="0000FF"/>
+      </a:hlink>
+      <a:folHlink>
+        <a:srgbClr val="800080"/>
+      </a:folHlink>
+    </a:clrScheme>
+    <a:fontScheme name="Office">
+      <a:majorFont>
+        <a:latin typeface="Calibri"/>
+        <a:ea typeface=""/>
+        <a:cs typeface=""/>
+        <a:font script="Jpan" typeface="ＭＳ Ｐゴシック"/>
+        <a:font script="Hang" typeface="맑은 고딕"/>
+        <a:font script="Hans" typeface="宋体"/>
+        <a:font script="Hant" typeface="新細明體"/>
+        <a:font script="Arab" typeface="Times New Roman"/>
+        <a:font script="Hebr" typeface="Times New Roman"/>
+        <a:font script="Thai" typeface="Angsana New"/>
+        <a:font script="Ethi" typeface="Nyala"/>
+        <a:font script="Beng" typeface="Vrinda"/>
+        <a:font script="Gujr" typeface="Shruti"/>
+        <a:font script="Khmr" typeface="MoolBoran"/>
+        <a:font script="Knda" typeface="Tunga"/>
+        <a:font script="Guru" typeface="Raavi"/>
+        <a:font script="Cans" typeface="Euphemia"/>
+        <a:font script="Cher" typeface="Plantagenet Cherokee"/>
+        <a:font script="Yiii" typeface="Microsoft Yi Baiti"/>
+        <a:font script="Tibt" typeface="Microsoft Himalaya"/>
+        <a:font script="Thaa" typeface="MV Boli"/>
+        <a:font script="Deva" typeface="Mangal"/>
+        <a:font script="Telu" typeface="Gautami"/>
+        <a:font script="Taml" typeface="Latha"/>
+        <a:font script="Syrc" typeface="Estrangelo Edessa"/>
+        <a:font script="Orya" typeface="Kalinga"/>
+        <a:font script="Mlym" typeface="Kartika"/>
+        <a:font script="Laoo" typeface="DokChampa"/>
+        <a:font script="Sinh" typeface="Iskoola Pota"/>
+        <a:font script="Mong" typeface="Mongolian Baiti"/>
+        <a:font script="Viet" typeface="Times New Roman"/>
+        <a:font script="Uigh" typeface="Microsoft Uighur"/>
+        <a:font script="Geor" typeface="Sylfaen"/>
+      </a:majorFont>
+      <a:minorFont>
+        <a:latin typeface="Calibri"/>
+        <a:ea typeface=""/>
+        <a:cs typeface=""/>
+        <a:font script="Jpan" typeface="ＭＳ Ｐゴシック"/>
+        <a:font script="Hang" typeface="맑은 고딕"/>
+        <a:font script="Hans" typeface="宋体"/>
+        <a:font script="Hant" typeface="新細明體"/>
+        <a:font script="Arab" typeface="Arial"/>
+        <a:font script="Hebr" typeface="Arial"/>
+        <a:font script="Thai" typeface="Cordia New"/>
+        <a:font script="Ethi" typeface="Nyala"/>
+        <a:font script="Beng" typeface="Vrinda"/>
+        <a:font script="Gujr" typeface="Shruti"/>
+        <a:font script="Khmr" typeface="DaunPenh"/>
+        <a:font script="Knda" typeface="Tunga"/>
+        <a:font script="Guru" typeface="Raavi"/>
+        <a:font script="Cans" typeface="Euphemia"/>
+        <a:font script="Cher" typeface="Plantagenet Cherokee"/>
+        <a:font script="Yiii" typeface="Microsoft Yi Baiti"/>
+        <a:font script="Tibt" typeface="Microsoft Himalaya"/>
+        <a:font script="Thaa" typeface="MV Boli"/>
+        <a:font script="Deva" typeface="Mangal"/>
+        <a:font script="Telu" typeface="Gautami"/>
+        <a:font script="Taml" typeface="Latha"/>
+        <a:font script="Syrc" typeface="Estrangelo Edessa"/>
+        <a:font script="Orya" typeface="Kalinga"/>
+        <a:font script="Mlym" typeface="Kartika"/>
+        <a:font script="Laoo" typeface="DokChampa"/>
+        <a:font script="Sinh" typeface="Iskoola Pota"/>
+        <a:font script="Mong" typeface="Mongolian Baiti"/>
+        <a:font script="Viet" typeface="Arial"/>
+        <a:font script="Uigh" typeface="Microsoft Uighur"/>
+        <a:font script="Geor" typeface="Sylfaen"/>
+      </a:minorFont>
+    </a:fontScheme>
+    <a:fmtScheme name="Office">
+      <a:fillStyleLst>
+        <a:solidFill>
+          <a:schemeClr val="phClr"/>
+        </a:solidFill>
+        <a:gradFill rotWithShape="1">
+          <a:gsLst>
+            <a:gs pos="0">
+              <a:schemeClr val="phClr">
+                <a:tint val="50000"/>
+                <a:satMod val="300000"/>
+              </a:schemeClr>
+            </a:gs>
+            <a:gs pos="35000">
+              <a:schemeClr val="phClr">
+                <a:tint val="37000"/>
+                <a:satMod val="300000"/>
+              </a:schemeClr>
+            </a:gs>
+            <a:gs pos="100000">
+              <a:schemeClr val="phClr">
+                <a:tint val="15000"/>
+                <a:satMod val="350000"/>
+              </a:schemeClr>
+            </a:gs>
+          </a:gsLst>
+          <a:lin ang="16200000" scaled="1"/>
+        </a:gradFill>
+        <a:gradFill rotWithShape="1">
+          <a:gsLst>
+            <a:gs pos="0">
+              <a:schemeClr val="phClr">
+                <a:tint val="100000"/>
+                <a:shade val="100000"/>
+                <a:satMod val="130000"/>
+              </a:schemeClr>
+            </a:gs>
+            <a:gs pos="100000">
+              <a:schemeClr val="phClr">
+                <a:tint val="50000"/>
+                <a:shade val="100000"/>
+                <a:satMod val="350000"/>
+              </a:schemeClr>
+            </a:gs>
+          </a:gsLst>
+          <a:lin ang="16200000" scaled="0"/>
+        </a:gradFill>
+      </a:fillStyleLst>
+      <a:lnStyleLst>
+        <a:ln w="9525" cap="flat" cmpd="sng" algn="ctr">
+          <a:solidFill>
+            <a:schemeClr val="phClr">
+              <a:shade val="95000"/>
+              <a:satMod val="105000"/>
+            </a:schemeClr>
+          </a:solidFill>
+          <a:prstDash val="solid"/>
+        </a:ln>
+        <a:ln w="25400" cap="flat" cmpd="sng" algn="ctr">
+          <a:solidFill>
+            <a:schemeClr val="phClr"/>
+          </a:solidFill>
+          <a:prstDash val="solid"/>
+        </a:ln>
+        <a:ln w="38100" cap="flat" cmpd="sng" algn="ctr">
+          <a:solidFill>
+            <a:schemeClr val="phClr"/>
+          </a:solidFill>
+          <a:prstDash val="solid"/>
+        </a:ln>
+      </a:lnStyleLst>
+      <a:effectStyleLst>
+        <a:effectStyle>
+          <a:effectLst>
+            <a:outerShdw blurRad="40000" dist="20000" dir="5400000" rotWithShape="0">
+              <a:srgbClr val="000000">
+                <a:alpha val="38000"/>
+              </a:srgbClr>
+            </a:outerShdw>
+          </a:effectLst>
+        </a:effectStyle>
+        <a:effectStyle>
+          <a:effectLst>
+            <a:outerShdw blurRad="40000" dist="23000" dir="5400000" rotWithShape="0">
+              <a:srgbClr val="000000">
+                <a:alpha val="35000"/>
+              </a:srgbClr>
+            </a:outerShdw>
+          </a:effectLst>
+        </a:effectStyle>
+        <a:effectStyle>
+          <a:effectLst>
+            <a:outerShdw blurRad="40000" dist="23000" dir="5400000" rotWithShape="0">
+              <a:srgbClr val="000000">
+                <a:alpha val="35000"/>
+              </a:srgbClr>
+            </a:outerShdw>
+          </a:effectLst>
+          <a:scene3d>
+            <a:camera prst="orthographicFront">
+              <a:rot lat="0" lon="0" rev="0"/>
+            </a:camera>
+            <a:lightRig rig="threePt" dir="t">
+              <a:rot lat="0" lon="0" rev="1200000"/>
+            </a:lightRig>
+          </a:scene3d>
+          <a:sp3d>
+            <a:bevelT w="63500" h="25400"/>
+          </a:sp3d>
+        </a:effectStyle>
+      </a:effectStyleLst>
+      <a:bgFillStyleLst>
+        <a:solidFill>
+          <a:schemeClr val="phClr"/>
+        </a:solidFill>
+        <a:gradFill rotWithShape="1">
+          <a:gsLst>
+            <a:gs pos="0">
+              <a:schemeClr val="phClr">
+                <a:tint val="40000"/>
+                <a:satMod val="350000"/>
+              </a:schemeClr>
+            </a:gs>
+            <a:gs pos="40000">
+              <a:schemeClr val="phClr">
+                <a:tint val="45000"/>
+                <a:shade val="99000"/>
+                <a:satMod val="350000"/>
+              </a:schemeClr>
+            </a:gs>
+            <a:gs pos="100000">
+              <a:schemeClr val="phClr">
+                <a:shade val="20000"/>
+                <a:satMod val="255000"/>
+              </a:schemeClr>
+            </a:gs>
+          </a:gsLst>
+          <a:path path="circle">
+            <a:fillToRect l="50000" t="-80000" r="50000" b="180000"/>
+          </a:path>
+        </a:gradFill>
+        <a:gradFill rotWithShape="1">
+          <a:gsLst>
+            <a:gs pos="0">
+              <a:schemeClr val="phClr">
+                <a:tint val="80000"/>
+                <a:satMod val="300000"/>
+              </a:schemeClr>
+            </a:gs>
+            <a:gs pos="100000">
+              <a:schemeClr val="phClr">
+                <a:shade val="30000"/>
+                <a:satMod val="200000"/>
+              </a:schemeClr>
+            </a:gs>
+          </a:gsLst>
+          <a:path path="circle">
+            <a:fillToRect l="50000" t="50000" r="50000" b="50000"/>
+          </a:path>
+        </a:gradFill>
+      </a:bgFillStyleLst>
+    </a:fmtScheme>
+  </a:themeElements>
+  <a:objectDefaults>
+    <a:spDef>
+      <a:spPr/>
+      <a:bodyPr/>
+      <a:lstStyle/>
+      <a:style>
+        <a:lnRef idx="1">
+          <a:schemeClr val="accent1"/>
+        </a:lnRef>
+        <a:fillRef idx="3">
+          <a:schemeClr val="accent1"/>
+        </a:fillRef>
+        <a:effectRef idx="2">
+          <a:schemeClr val="accent1"/>
+        </a:effectRef>
+        <a:fontRef idx="minor">
+          <a:schemeClr val="lt1"/>
+        </a:fontRef>
+      </a:style>
+    </a:spDef>
+    <a:lnDef>
+      <a:spPr/>
+      <a:bodyPr/>
+      <a:lstStyle/>
+      <a:style>
+        <a:lnRef idx="2">
+          <a:schemeClr val="accent1"/>
+        </a:lnRef>
+        <a:fillRef idx="0">
+          <a:schemeClr val="accent1"/>
+        </a:fillRef>
+        <a:effectRef idx="1">
+          <a:schemeClr val="accent1"/>
+        </a:effectRef>
+        <a:fontRef idx="minor">
+          <a:schemeClr val="tx1"/>
+        </a:fontRef>
+      </a:style>
+    </a:lnDef>
+  </a:objectDefaults>
+  <a:extraClrSchemeLst/>
+</a:theme>
 </file>
</xml_diff>

<commit_message>
feat: predictive and fix on section 4
</commit_message>
<xml_diff>
--- a/presentation/board_deck.pptx
+++ b/presentation/board_deck.pptx
@@ -20,6 +20,7 @@
     <p:sldId id="267" r:id="rId18"/>
     <p:sldId id="268" r:id="rId19"/>
     <p:sldId id="269" r:id="rId20"/>
+    <p:sldId id="273" r:id="rId25"/>
     <p:sldId id="270" r:id="rId21"/>
     <p:sldId id="271" r:id="rId22"/>
   </p:sldIdLst>
@@ -15744,7 +15745,7 @@
                 </a:solidFill>
                 <a:latin typeface="Arial"/>
               </a:rPr>
-              <a:t>15</a:t>
+              <a:t>16</a:t>
             </a:r>
           </a:p>
         </p:txBody>
@@ -17080,7 +17081,7 @@
 </p:sld>
 </file>
 
-<file path=ppt/slides/slide2.xml><?xml version="1.0" encoding="utf-8"?>
+<file path=ppt/slides/slide18.xml><?xml version="1.0" encoding="utf-8"?>
 <p:sld xmlns:a="http://schemas.openxmlformats.org/drawingml/2006/main" xmlns:p="http://schemas.openxmlformats.org/presentationml/2006/main" xmlns:r="http://schemas.openxmlformats.org/officeDocument/2006/relationships">
   <p:cSld>
     <p:spTree>
@@ -17175,7 +17176,7 @@
                 </a:solidFill>
                 <a:latin typeface="Arial"/>
               </a:rPr>
-              <a:t>Executive summary</a:t>
+              <a:t>What's next</a:t>
             </a:r>
           </a:p>
         </p:txBody>
@@ -17335,6 +17336,992 @@
                 </a:solidFill>
                 <a:latin typeface="Arial"/>
               </a:rPr>
+              <a:t>15</a:t>
+            </a:r>
+          </a:p>
+        </p:txBody>
+      </p:sp>
+      <p:sp>
+        <p:nvSpPr>
+          <p:cNvPr id="8" name="TextBox 7"/>
+          <p:cNvSpPr txBox="1"/>
+          <p:nvPr/>
+        </p:nvSpPr>
+        <p:spPr>
+          <a:xfrm>
+            <a:off x="566928" y="731520"/>
+            <a:ext cx="11057839" cy="822960"/>
+          </a:xfrm>
+          <a:prstGeom prst="rect">
+            <a:avLst/>
+          </a:prstGeom>
+          <a:noFill/>
+        </p:spPr>
+        <p:txBody>
+          <a:bodyPr wrap="square" anchor="t" lIns="0" rIns="0" tIns="0" bIns="0">
+            <a:spAutoFit/>
+          </a:bodyPr>
+          <a:lstStyle/>
+          <a:p>
+            <a:pPr algn="l">
+              <a:lnSpc>
+                <a:spcPct val="102000"/>
+              </a:lnSpc>
+              <a:spcBef>
+                <a:spcPts val="0"/>
+              </a:spcBef>
+              <a:spcAft>
+                <a:spcPts val="300"/>
+              </a:spcAft>
+            </a:pPr>
+            <a:r>
+              <a:rPr sz="2100" b="1" i="0">
+                <a:solidFill>
+                  <a:srgbClr val="322014"/>
+                </a:solidFill>
+                <a:latin typeface="Georgia"/>
+              </a:rPr>
+              <a:t>What Happens Next: $5.3M Forecast, a Near-Neutral Cap, Named Churn Risks</a:t>
+            </a:r>
+          </a:p>
+        </p:txBody>
+      </p:sp>
+      <p:graphicFrame>
+        <p:nvGraphicFramePr>
+          <p:cNvPr id="9" name="Table 8"/>
+          <p:cNvGraphicFramePr>
+            <a:graphicFrameLocks noGrp="1"/>
+          </p:cNvGraphicFramePr>
+          <p:nvPr/>
+        </p:nvGraphicFramePr>
+        <p:xfrm>
+          <a:off x="566928" y="1737360"/>
+          <a:ext cx="11064240" cy="3803904"/>
+        </p:xfrm>
+        <a:graphic>
+          <a:graphicData uri="http://schemas.openxmlformats.org/drawingml/2006/table">
+            <a:tbl>
+              <a:tblPr>
+                <a:tableStyleId>{2D5ABB26-0587-4C30-8999-92F81FD0307C}</a:tableStyleId>
+              </a:tblPr>
+              <a:tblGrid>
+                <a:gridCol w="2606040"/>
+                <a:gridCol w="4160520"/>
+                <a:gridCol w="2606040"/>
+                <a:gridCol w="1691640"/>
+              </a:tblGrid>
+              <a:tr h="402336">
+                <a:tc>
+                  <a:txBody>
+                    <a:bodyPr wrap="square"/>
+                    <a:lstStyle/>
+                    <a:p>
+                      <a:pPr>
+                        <a:lnSpc>
+                          <a:spcPct val="105000"/>
+                        </a:lnSpc>
+                      </a:pPr>
+                      <a:r>
+                        <a:rPr sz="1200" b="1">
+                          <a:solidFill>
+                            <a:srgbClr val="322014"/>
+                          </a:solidFill>
+                          <a:latin typeface="Arial"/>
+                        </a:rPr>
+                        <a:t>What happens next</a:t>
+                      </a:r>
+                    </a:p>
+                  </a:txBody>
+                  <a:tcPr marL="91440" marR="73152" marT="45720" marB="45720" anchor="ctr">
+                    <a:lnB w="19050" cap="flat" cmpd="sng" algn="ctr">
+                      <a:solidFill>
+                        <a:srgbClr val="322014"/>
+                      </a:solidFill>
+                    </a:lnB>
+                    <a:solidFill>
+                      <a:srgbClr val="FFFFFF"/>
+                    </a:solidFill>
+                  </a:tcPr>
+                </a:tc>
+                <a:tc>
+                  <a:txBody>
+                    <a:bodyPr wrap="square"/>
+                    <a:lstStyle/>
+                    <a:p>
+                      <a:pPr>
+                        <a:lnSpc>
+                          <a:spcPct val="105000"/>
+                        </a:lnSpc>
+                      </a:pPr>
+                      <a:r>
+                        <a:rPr sz="1200" b="1">
+                          <a:solidFill>
+                            <a:srgbClr val="322014"/>
+                          </a:solidFill>
+                          <a:latin typeface="Arial"/>
+                        </a:rPr>
+                        <a:t>The number</a:t>
+                      </a:r>
+                    </a:p>
+                  </a:txBody>
+                  <a:tcPr marL="91440" marR="73152" marT="45720" marB="45720" anchor="ctr">
+                    <a:lnB w="19050" cap="flat" cmpd="sng" algn="ctr">
+                      <a:solidFill>
+                        <a:srgbClr val="322014"/>
+                      </a:solidFill>
+                    </a:lnB>
+                    <a:solidFill>
+                      <a:srgbClr val="FFFFFF"/>
+                    </a:solidFill>
+                  </a:tcPr>
+                </a:tc>
+                <a:tc>
+                  <a:txBody>
+                    <a:bodyPr wrap="square"/>
+                    <a:lstStyle/>
+                    <a:p>
+                      <a:pPr>
+                        <a:lnSpc>
+                          <a:spcPct val="105000"/>
+                        </a:lnSpc>
+                      </a:pPr>
+                      <a:r>
+                        <a:rPr sz="1200" b="1">
+                          <a:solidFill>
+                            <a:srgbClr val="322014"/>
+                          </a:solidFill>
+                          <a:latin typeface="Arial"/>
+                        </a:rPr>
+                        <a:t>How we know it is real</a:t>
+                      </a:r>
+                    </a:p>
+                  </a:txBody>
+                  <a:tcPr marL="91440" marR="73152" marT="45720" marB="45720" anchor="ctr">
+                    <a:lnB w="19050" cap="flat" cmpd="sng" algn="ctr">
+                      <a:solidFill>
+                        <a:srgbClr val="322014"/>
+                      </a:solidFill>
+                    </a:lnB>
+                    <a:solidFill>
+                      <a:srgbClr val="FFFFFF"/>
+                    </a:solidFill>
+                  </a:tcPr>
+                </a:tc>
+                <a:tc>
+                  <a:txBody>
+                    <a:bodyPr wrap="square"/>
+                    <a:lstStyle/>
+                    <a:p>
+                      <a:pPr>
+                        <a:lnSpc>
+                          <a:spcPct val="105000"/>
+                        </a:lnSpc>
+                      </a:pPr>
+                      <a:r>
+                        <a:rPr sz="1200" b="1">
+                          <a:solidFill>
+                            <a:srgbClr val="322014"/>
+                          </a:solidFill>
+                          <a:latin typeface="Arial"/>
+                        </a:rPr>
+                        <a:t>What it means</a:t>
+                      </a:r>
+                    </a:p>
+                  </a:txBody>
+                  <a:tcPr marL="91440" marR="73152" marT="45720" marB="45720" anchor="ctr">
+                    <a:lnB w="19050" cap="flat" cmpd="sng" algn="ctr">
+                      <a:solidFill>
+                        <a:srgbClr val="322014"/>
+                      </a:solidFill>
+                    </a:lnB>
+                    <a:solidFill>
+                      <a:srgbClr val="FFFFFF"/>
+                    </a:solidFill>
+                  </a:tcPr>
+                </a:tc>
+              </a:tr>
+              <a:tr h="1133856">
+                <a:tc>
+                  <a:txBody>
+                    <a:bodyPr wrap="square"/>
+                    <a:lstStyle/>
+                    <a:p>
+                      <a:pPr>
+                        <a:lnSpc>
+                          <a:spcPct val="105000"/>
+                        </a:lnSpc>
+                      </a:pPr>
+                      <a:r>
+                        <a:rPr sz="1400" b="1">
+                          <a:solidFill>
+                            <a:srgbClr val="5A3921"/>
+                          </a:solidFill>
+                          <a:latin typeface="Georgia"/>
+                        </a:rPr>
+                        <a:t>FY2015 revenue forecast</a:t>
+                      </a:r>
+                    </a:p>
+                  </a:txBody>
+                  <a:tcPr marL="91440" marR="73152" marT="45720" marB="45720" anchor="ctr">
+                    <a:lnR w="19050" cap="flat" cmpd="sng" algn="ctr">
+                      <a:solidFill>
+                        <a:srgbClr val="322014"/>
+                      </a:solidFill>
+                    </a:lnR>
+                    <a:lnT w="9525" cap="flat" cmpd="sng" algn="ctr">
+                      <a:solidFill>
+                        <a:srgbClr val="E2DCD2"/>
+                      </a:solidFill>
+                    </a:lnT>
+                    <a:solidFill>
+                      <a:srgbClr val="FFFFFF"/>
+                    </a:solidFill>
+                  </a:tcPr>
+                </a:tc>
+                <a:tc>
+                  <a:txBody>
+                    <a:bodyPr wrap="square"/>
+                    <a:lstStyle/>
+                    <a:p>
+                      <a:pPr>
+                        <a:lnSpc>
+                          <a:spcPct val="105000"/>
+                        </a:lnSpc>
+                      </a:pPr>
+                      <a:r>
+                        <a:rPr sz="1100" b="0">
+                          <a:solidFill>
+                            <a:srgbClr val="322014"/>
+                          </a:solidFill>
+                          <a:latin typeface="Arial"/>
+                        </a:rPr>
+                        <a:t>$5.28M (+22.8% vs FY2014)</a:t>
+                      </a:r>
+                    </a:p>
+                  </a:txBody>
+                  <a:tcPr marL="91440" marR="73152" marT="45720" marB="45720" anchor="ctr">
+                    <a:lnT w="9525" cap="flat" cmpd="sng" algn="ctr">
+                      <a:solidFill>
+                        <a:srgbClr val="E2DCD2"/>
+                      </a:solidFill>
+                    </a:lnT>
+                    <a:solidFill>
+                      <a:srgbClr val="FFFFFF"/>
+                    </a:solidFill>
+                  </a:tcPr>
+                </a:tc>
+                <a:tc>
+                  <a:txBody>
+                    <a:bodyPr wrap="square"/>
+                    <a:lstStyle/>
+                    <a:p>
+                      <a:pPr>
+                        <a:lnSpc>
+                          <a:spcPct val="105000"/>
+                        </a:lnSpc>
+                      </a:pPr>
+                      <a:r>
+                        <a:rPr sz="1100" b="0">
+                          <a:solidFill>
+                            <a:srgbClr val="322014"/>
+                          </a:solidFill>
+                          <a:latin typeface="Arial"/>
+                        </a:rPr>
+                        <a:t>Tested on FY2014, a year the model never saw: mean error 10%, bias -1%</a:t>
+                      </a:r>
+                    </a:p>
+                  </a:txBody>
+                  <a:tcPr marL="91440" marR="73152" marT="45720" marB="45720" anchor="ctr">
+                    <a:lnT w="9525" cap="flat" cmpd="sng" algn="ctr">
+                      <a:solidFill>
+                        <a:srgbClr val="E2DCD2"/>
+                      </a:solidFill>
+                    </a:lnT>
+                    <a:solidFill>
+                      <a:srgbClr val="FFFFFF"/>
+                    </a:solidFill>
+                  </a:tcPr>
+                </a:tc>
+                <a:tc>
+                  <a:txBody>
+                    <a:bodyPr wrap="square"/>
+                    <a:lstStyle/>
+                    <a:p>
+                      <a:pPr>
+                        <a:lnSpc>
+                          <a:spcPct val="105000"/>
+                        </a:lnSpc>
+                      </a:pPr>
+                      <a:r>
+                        <a:rPr sz="1100" b="1">
+                          <a:solidFill>
+                            <a:srgbClr val="322014"/>
+                          </a:solidFill>
+                          <a:latin typeface="Arial"/>
+                        </a:rPr>
+                        <a:t>The fix needs no heroic growth</a:t>
+                      </a:r>
+                    </a:p>
+                  </a:txBody>
+                  <a:tcPr marL="91440" marR="73152" marT="45720" marB="45720" anchor="ctr">
+                    <a:lnT w="9525" cap="flat" cmpd="sng" algn="ctr">
+                      <a:solidFill>
+                        <a:srgbClr val="E2DCD2"/>
+                      </a:solidFill>
+                    </a:lnT>
+                    <a:solidFill>
+                      <a:srgbClr val="FFFFFF"/>
+                    </a:solidFill>
+                  </a:tcPr>
+                </a:tc>
+              </a:tr>
+              <a:tr h="1133856">
+                <a:tc>
+                  <a:txBody>
+                    <a:bodyPr wrap="square"/>
+                    <a:lstStyle/>
+                    <a:p>
+                      <a:pPr>
+                        <a:lnSpc>
+                          <a:spcPct val="105000"/>
+                        </a:lnSpc>
+                      </a:pPr>
+                      <a:r>
+                        <a:rPr sz="1400" b="1">
+                          <a:solidFill>
+                            <a:srgbClr val="5A3921"/>
+                          </a:solidFill>
+                          <a:latin typeface="Georgia"/>
+                        </a:rPr>
+                        <a:t>Volume effect of the 20% cap</a:t>
+                      </a:r>
+                    </a:p>
+                  </a:txBody>
+                  <a:tcPr marL="91440" marR="73152" marT="45720" marB="45720" anchor="ctr">
+                    <a:lnR w="19050" cap="flat" cmpd="sng" algn="ctr">
+                      <a:solidFill>
+                        <a:srgbClr val="322014"/>
+                      </a:solidFill>
+                    </a:lnR>
+                    <a:lnT w="9525" cap="flat" cmpd="sng" algn="ctr">
+                      <a:solidFill>
+                        <a:srgbClr val="E2DCD2"/>
+                      </a:solidFill>
+                    </a:lnT>
+                    <a:solidFill>
+                      <a:srgbClr val="FFFFFF"/>
+                    </a:solidFill>
+                  </a:tcPr>
+                </a:tc>
+                <a:tc>
+                  <a:txBody>
+                    <a:bodyPr wrap="square"/>
+                    <a:lstStyle/>
+                    <a:p>
+                      <a:pPr>
+                        <a:lnSpc>
+                          <a:spcPct val="105000"/>
+                        </a:lnSpc>
+                      </a:pPr>
+                      <a:r>
+                        <a:rPr sz="1100" b="0">
+                          <a:solidFill>
+                            <a:srgbClr val="322014"/>
+                          </a:solidFill>
+                          <a:latin typeface="Arial"/>
+                        </a:rPr>
+                        <a:t>101% of volume kept</a:t>
+                      </a:r>
+                    </a:p>
+                  </a:txBody>
+                  <a:tcPr marL="91440" marR="73152" marT="45720" marB="45720" anchor="ctr">
+                    <a:lnT w="9525" cap="flat" cmpd="sng" algn="ctr">
+                      <a:solidFill>
+                        <a:srgbClr val="E2DCD2"/>
+                      </a:solidFill>
+                    </a:lnT>
+                    <a:solidFill>
+                      <a:srgbClr val="FFFFFF"/>
+                    </a:solidFill>
+                  </a:tcPr>
+                </a:tc>
+                <a:tc>
+                  <a:txBody>
+                    <a:bodyPr wrap="square"/>
+                    <a:lstStyle/>
+                    <a:p>
+                      <a:pPr>
+                        <a:lnSpc>
+                          <a:spcPct val="105000"/>
+                        </a:lnSpc>
+                      </a:pPr>
+                      <a:r>
+                        <a:rPr sz="1100" b="0">
+                          <a:solidFill>
+                            <a:srgbClr val="322014"/>
+                          </a:solidFill>
+                          <a:latin typeface="Arial"/>
+                        </a:rPr>
+                        <a:t>Measured from the ledger's own discount response, with product, market, and season controls</a:t>
+                      </a:r>
+                    </a:p>
+                  </a:txBody>
+                  <a:tcPr marL="91440" marR="73152" marT="45720" marB="45720" anchor="ctr">
+                    <a:lnT w="9525" cap="flat" cmpd="sng" algn="ctr">
+                      <a:solidFill>
+                        <a:srgbClr val="E2DCD2"/>
+                      </a:solidFill>
+                    </a:lnT>
+                    <a:solidFill>
+                      <a:srgbClr val="FFFFFF"/>
+                    </a:solidFill>
+                  </a:tcPr>
+                </a:tc>
+                <a:tc>
+                  <a:txBody>
+                    <a:bodyPr wrap="square"/>
+                    <a:lstStyle/>
+                    <a:p>
+                      <a:pPr>
+                        <a:lnSpc>
+                          <a:spcPct val="105000"/>
+                        </a:lnSpc>
+                      </a:pPr>
+                      <a:r>
+                        <a:rPr sz="1100" b="1">
+                          <a:solidFill>
+                            <a:srgbClr val="322014"/>
+                          </a:solidFill>
+                          <a:latin typeface="Arial"/>
+                        </a:rPr>
+                        <a:t>No churn guess needed</a:t>
+                      </a:r>
+                    </a:p>
+                  </a:txBody>
+                  <a:tcPr marL="91440" marR="73152" marT="45720" marB="45720" anchor="ctr">
+                    <a:lnT w="9525" cap="flat" cmpd="sng" algn="ctr">
+                      <a:solidFill>
+                        <a:srgbClr val="E2DCD2"/>
+                      </a:solidFill>
+                    </a:lnT>
+                    <a:solidFill>
+                      <a:srgbClr val="FFFFFF"/>
+                    </a:solidFill>
+                  </a:tcPr>
+                </a:tc>
+              </a:tr>
+              <a:tr h="1133856">
+                <a:tc>
+                  <a:txBody>
+                    <a:bodyPr wrap="square"/>
+                    <a:lstStyle/>
+                    <a:p>
+                      <a:pPr>
+                        <a:lnSpc>
+                          <a:spcPct val="105000"/>
+                        </a:lnSpc>
+                      </a:pPr>
+                      <a:r>
+                        <a:rPr sz="1400" b="1">
+                          <a:solidFill>
+                            <a:srgbClr val="5A3921"/>
+                          </a:solidFill>
+                          <a:latin typeface="Georgia"/>
+                        </a:rPr>
+                        <a:t>Customer churn risk</a:t>
+                      </a:r>
+                    </a:p>
+                  </a:txBody>
+                  <a:tcPr marL="91440" marR="73152" marT="45720" marB="45720" anchor="ctr">
+                    <a:lnR w="19050" cap="flat" cmpd="sng" algn="ctr">
+                      <a:solidFill>
+                        <a:srgbClr val="322014"/>
+                      </a:solidFill>
+                    </a:lnR>
+                    <a:lnB w="0" cap="flat" cmpd="sng" algn="ctr">
+                      <a:solidFill>
+                        <a:srgbClr val="FFFFFF"/>
+                      </a:solidFill>
+                    </a:lnB>
+                    <a:lnT w="9525" cap="flat" cmpd="sng" algn="ctr">
+                      <a:solidFill>
+                        <a:srgbClr val="E2DCD2"/>
+                      </a:solidFill>
+                    </a:lnT>
+                    <a:solidFill>
+                      <a:srgbClr val="FFFFFF"/>
+                    </a:solidFill>
+                  </a:tcPr>
+                </a:tc>
+                <a:tc>
+                  <a:txBody>
+                    <a:bodyPr wrap="square"/>
+                    <a:lstStyle/>
+                    <a:p>
+                      <a:pPr>
+                        <a:lnSpc>
+                          <a:spcPct val="105000"/>
+                        </a:lnSpc>
+                      </a:pPr>
+                      <a:r>
+                        <a:rPr sz="1100" b="0">
+                          <a:solidFill>
+                            <a:srgbClr val="322014"/>
+                          </a:solidFill>
+                          <a:latin typeface="Arial"/>
+                        </a:rPr>
+                        <a:t>Top tenth of customers lapse 2.9x the average rate</a:t>
+                      </a:r>
+                    </a:p>
+                  </a:txBody>
+                  <a:tcPr marL="91440" marR="73152" marT="45720" marB="45720" anchor="ctr">
+                    <a:lnB w="0" cap="flat" cmpd="sng" algn="ctr">
+                      <a:solidFill>
+                        <a:srgbClr val="FFFFFF"/>
+                      </a:solidFill>
+                    </a:lnB>
+                    <a:lnT w="9525" cap="flat" cmpd="sng" algn="ctr">
+                      <a:solidFill>
+                        <a:srgbClr val="E2DCD2"/>
+                      </a:solidFill>
+                    </a:lnT>
+                    <a:solidFill>
+                      <a:srgbClr val="FFFFFF"/>
+                    </a:solidFill>
+                  </a:tcPr>
+                </a:tc>
+                <a:tc>
+                  <a:txBody>
+                    <a:bodyPr wrap="square"/>
+                    <a:lstStyle/>
+                    <a:p>
+                      <a:pPr>
+                        <a:lnSpc>
+                          <a:spcPct val="105000"/>
+                        </a:lnSpc>
+                      </a:pPr>
+                      <a:r>
+                        <a:rPr sz="1100" b="0">
+                          <a:solidFill>
+                            <a:srgbClr val="322014"/>
+                          </a:solidFill>
+                          <a:latin typeface="Arial"/>
+                        </a:rPr>
+                        <a:t>Scored on pre-2014 behaviour only (AUC 0.80 on a customer holdout)</a:t>
+                      </a:r>
+                    </a:p>
+                  </a:txBody>
+                  <a:tcPr marL="91440" marR="73152" marT="45720" marB="45720" anchor="ctr">
+                    <a:lnB w="0" cap="flat" cmpd="sng" algn="ctr">
+                      <a:solidFill>
+                        <a:srgbClr val="FFFFFF"/>
+                      </a:solidFill>
+                    </a:lnB>
+                    <a:lnT w="9525" cap="flat" cmpd="sng" algn="ctr">
+                      <a:solidFill>
+                        <a:srgbClr val="E2DCD2"/>
+                      </a:solidFill>
+                    </a:lnT>
+                    <a:solidFill>
+                      <a:srgbClr val="FFFFFF"/>
+                    </a:solidFill>
+                  </a:tcPr>
+                </a:tc>
+                <a:tc>
+                  <a:txBody>
+                    <a:bodyPr wrap="square"/>
+                    <a:lstStyle/>
+                    <a:p>
+                      <a:pPr>
+                        <a:lnSpc>
+                          <a:spcPct val="105000"/>
+                        </a:lnSpc>
+                      </a:pPr>
+                      <a:r>
+                        <a:rPr sz="1100" b="1">
+                          <a:solidFill>
+                            <a:srgbClr val="322014"/>
+                          </a:solidFill>
+                          <a:latin typeface="Arial"/>
+                        </a:rPr>
+                        <a:t>Target retention effort first</a:t>
+                      </a:r>
+                    </a:p>
+                  </a:txBody>
+                  <a:tcPr marL="91440" marR="73152" marT="45720" marB="45720" anchor="ctr">
+                    <a:lnB w="0" cap="flat" cmpd="sng" algn="ctr">
+                      <a:solidFill>
+                        <a:srgbClr val="FFFFFF"/>
+                      </a:solidFill>
+                    </a:lnB>
+                    <a:lnT w="9525" cap="flat" cmpd="sng" algn="ctr">
+                      <a:solidFill>
+                        <a:srgbClr val="E2DCD2"/>
+                      </a:solidFill>
+                    </a:lnT>
+                    <a:solidFill>
+                      <a:srgbClr val="FFFFFF"/>
+                    </a:solidFill>
+                  </a:tcPr>
+                </a:tc>
+              </a:tr>
+            </a:tbl>
+          </a:graphicData>
+        </a:graphic>
+      </p:graphicFrame>
+      <p:sp>
+        <p:nvSpPr>
+          <p:cNvPr id="10" name="TextBox 9"/>
+          <p:cNvSpPr txBox="1"/>
+          <p:nvPr/>
+        </p:nvSpPr>
+        <p:spPr>
+          <a:xfrm>
+            <a:off x="566928" y="5879592"/>
+            <a:ext cx="11057839" cy="201168"/>
+          </a:xfrm>
+          <a:prstGeom prst="rect">
+            <a:avLst/>
+          </a:prstGeom>
+          <a:noFill/>
+        </p:spPr>
+        <p:txBody>
+          <a:bodyPr wrap="square" anchor="t" lIns="0" rIns="0" tIns="0" bIns="0">
+            <a:spAutoFit/>
+          </a:bodyPr>
+          <a:lstStyle/>
+          <a:p>
+            <a:pPr algn="l">
+              <a:lnSpc>
+                <a:spcPct val="106000"/>
+              </a:lnSpc>
+              <a:spcBef>
+                <a:spcPts val="0"/>
+              </a:spcBef>
+              <a:spcAft>
+                <a:spcPts val="300"/>
+              </a:spcAft>
+            </a:pPr>
+            <a:r>
+              <a:rPr sz="850" b="0" i="0">
+                <a:solidFill>
+                  <a:srgbClr val="8A7B6B"/>
+                </a:solidFill>
+                <a:latin typeface="Arial"/>
+              </a:rPr>
+              <a:t>FY2015 assumes current trends continue. The volume response is measured from the ledger's own discount history; the churn score uses only pre-2014 behaviour, so it is a genuine prediction.</a:t>
+            </a:r>
+          </a:p>
+        </p:txBody>
+      </p:sp>
+      <p:sp>
+        <p:nvSpPr>
+          <p:cNvPr id="11" name="TextBox 10"/>
+          <p:cNvSpPr txBox="1"/>
+          <p:nvPr/>
+        </p:nvSpPr>
+        <p:spPr>
+          <a:xfrm>
+            <a:off x="566928" y="6099048"/>
+            <a:ext cx="11057839" cy="237744"/>
+          </a:xfrm>
+          <a:prstGeom prst="rect">
+            <a:avLst/>
+          </a:prstGeom>
+          <a:noFill/>
+        </p:spPr>
+        <p:txBody>
+          <a:bodyPr wrap="square" anchor="t" lIns="0" rIns="0" tIns="0" bIns="0">
+            <a:spAutoFit/>
+          </a:bodyPr>
+          <a:lstStyle/>
+          <a:p>
+            <a:pPr algn="l">
+              <a:lnSpc>
+                <a:spcPct val="105000"/>
+              </a:lnSpc>
+              <a:spcBef>
+                <a:spcPts val="0"/>
+              </a:spcBef>
+              <a:spcAft>
+                <a:spcPts val="300"/>
+              </a:spcAft>
+            </a:pPr>
+            <a:r>
+              <a:rPr sz="750" b="0" i="0">
+                <a:solidFill>
+                  <a:srgbClr val="8A7B6B"/>
+                </a:solidFill>
+                <a:latin typeface="Arial"/>
+              </a:rPr>
+              <a:t>Source: predictive models on the FY2011-FY2014 ledger. Forecast: tested on FY2014 (mean error 10%). Demand response: controlled regression across all 51,290 lines. Churn: logistic model, AUC 0.80 on a customer holdout. Modelling estimates, not forecasts.</a:t>
+            </a:r>
+          </a:p>
+        </p:txBody>
+      </p:sp>
+    </p:spTree>
+  </p:cSld>
+  <p:clrMapOvr>
+    <a:masterClrMapping/>
+  </p:clrMapOvr>
+</p:sld>
+</file>
+
+<file path=ppt/slides/slide2.xml><?xml version="1.0" encoding="utf-8"?>
+<p:sld xmlns:a="http://schemas.openxmlformats.org/drawingml/2006/main" xmlns:p="http://schemas.openxmlformats.org/presentationml/2006/main" xmlns:r="http://schemas.openxmlformats.org/officeDocument/2006/relationships">
+  <p:cSld>
+    <p:spTree>
+      <p:nvGrpSpPr>
+        <p:cNvPr id="1" name=""/>
+        <p:cNvGrpSpPr/>
+        <p:nvPr/>
+      </p:nvGrpSpPr>
+      <p:grpSpPr/>
+      <p:sp>
+        <p:nvSpPr>
+          <p:cNvPr id="2" name="TextBox 1"/>
+          <p:cNvSpPr txBox="1"/>
+          <p:nvPr/>
+        </p:nvSpPr>
+        <p:spPr>
+          <a:xfrm>
+            <a:off x="566928" y="310896"/>
+            <a:ext cx="6634703" cy="310896"/>
+          </a:xfrm>
+          <a:prstGeom prst="rect">
+            <a:avLst/>
+          </a:prstGeom>
+          <a:noFill/>
+        </p:spPr>
+        <p:txBody>
+          <a:bodyPr wrap="square" anchor="t" lIns="0" rIns="0" tIns="0" bIns="0">
+            <a:spAutoFit/>
+          </a:bodyPr>
+          <a:lstStyle/>
+          <a:p>
+            <a:pPr algn="l">
+              <a:lnSpc>
+                <a:spcPct val="106000"/>
+              </a:lnSpc>
+              <a:spcBef>
+                <a:spcPts val="0"/>
+              </a:spcBef>
+              <a:spcAft>
+                <a:spcPts val="300"/>
+              </a:spcAft>
+            </a:pPr>
+            <a:r>
+              <a:rPr sz="1800" b="1" i="0">
+                <a:solidFill>
+                  <a:srgbClr val="322014"/>
+                </a:solidFill>
+                <a:latin typeface="Georgia"/>
+              </a:rPr>
+              <a:t>Global Superstore · Revival Strategy</a:t>
+            </a:r>
+          </a:p>
+        </p:txBody>
+      </p:sp>
+      <p:sp>
+        <p:nvSpPr>
+          <p:cNvPr id="3" name="TextBox 2"/>
+          <p:cNvSpPr txBox="1"/>
+          <p:nvPr/>
+        </p:nvSpPr>
+        <p:spPr>
+          <a:xfrm>
+            <a:off x="7784287" y="429768"/>
+            <a:ext cx="3840480" cy="219456"/>
+          </a:xfrm>
+          <a:prstGeom prst="rect">
+            <a:avLst/>
+          </a:prstGeom>
+          <a:noFill/>
+        </p:spPr>
+        <p:txBody>
+          <a:bodyPr wrap="square" anchor="t" lIns="0" rIns="0" tIns="0" bIns="0">
+            <a:spAutoFit/>
+          </a:bodyPr>
+          <a:lstStyle/>
+          <a:p>
+            <a:pPr algn="r">
+              <a:lnSpc>
+                <a:spcPct val="106000"/>
+              </a:lnSpc>
+              <a:spcBef>
+                <a:spcPts val="0"/>
+              </a:spcBef>
+              <a:spcAft>
+                <a:spcPts val="300"/>
+              </a:spcAft>
+            </a:pPr>
+            <a:r>
+              <a:rPr sz="750" b="1" i="0">
+                <a:solidFill>
+                  <a:srgbClr val="8A7B6B"/>
+                </a:solidFill>
+                <a:latin typeface="Arial"/>
+              </a:rPr>
+              <a:t>Executive summary</a:t>
+            </a:r>
+          </a:p>
+        </p:txBody>
+      </p:sp>
+      <p:cxnSp>
+        <p:nvCxnSpPr>
+          <p:cNvPr id="4" name="Connector 3"/>
+          <p:cNvCxnSpPr/>
+          <p:nvPr/>
+        </p:nvCxnSpPr>
+        <p:spPr>
+          <a:xfrm>
+            <a:off x="566928" y="658368"/>
+            <a:ext cx="11057839" cy="0"/>
+          </a:xfrm>
+          <a:prstGeom prst="line">
+            <a:avLst/>
+          </a:prstGeom>
+          <a:ln w="12700">
+            <a:solidFill>
+              <a:srgbClr val="322014"/>
+            </a:solidFill>
+          </a:ln>
+        </p:spPr>
+        <p:style>
+          <a:lnRef idx="2">
+            <a:schemeClr val="accent1"/>
+          </a:lnRef>
+          <a:fillRef idx="0">
+            <a:schemeClr val="accent1"/>
+          </a:fillRef>
+          <a:effectRef idx="1">
+            <a:schemeClr val="accent1"/>
+          </a:effectRef>
+          <a:fontRef idx="minor">
+            <a:schemeClr val="tx1"/>
+          </a:fontRef>
+        </p:style>
+      </p:cxnSp>
+      <p:cxnSp>
+        <p:nvCxnSpPr>
+          <p:cNvPr id="5" name="Connector 4"/>
+          <p:cNvCxnSpPr/>
+          <p:nvPr/>
+        </p:nvCxnSpPr>
+        <p:spPr>
+          <a:xfrm>
+            <a:off x="566928" y="6355080"/>
+            <a:ext cx="11057839" cy="0"/>
+          </a:xfrm>
+          <a:prstGeom prst="line">
+            <a:avLst/>
+          </a:prstGeom>
+          <a:ln w="9525">
+            <a:solidFill>
+              <a:srgbClr val="C5A681"/>
+            </a:solidFill>
+          </a:ln>
+        </p:spPr>
+        <p:style>
+          <a:lnRef idx="2">
+            <a:schemeClr val="accent1"/>
+          </a:lnRef>
+          <a:fillRef idx="0">
+            <a:schemeClr val="accent1"/>
+          </a:fillRef>
+          <a:effectRef idx="1">
+            <a:schemeClr val="accent1"/>
+          </a:effectRef>
+          <a:fontRef idx="minor">
+            <a:schemeClr val="tx1"/>
+          </a:fontRef>
+        </p:style>
+      </p:cxnSp>
+      <p:sp>
+        <p:nvSpPr>
+          <p:cNvPr id="6" name="TextBox 5"/>
+          <p:cNvSpPr txBox="1"/>
+          <p:nvPr/>
+        </p:nvSpPr>
+        <p:spPr>
+          <a:xfrm>
+            <a:off x="566928" y="6400800"/>
+            <a:ext cx="7740487" cy="219456"/>
+          </a:xfrm>
+          <a:prstGeom prst="rect">
+            <a:avLst/>
+          </a:prstGeom>
+          <a:noFill/>
+        </p:spPr>
+        <p:txBody>
+          <a:bodyPr wrap="square" anchor="t" lIns="0" rIns="0" tIns="0" bIns="0">
+            <a:spAutoFit/>
+          </a:bodyPr>
+          <a:lstStyle/>
+          <a:p>
+            <a:pPr algn="l">
+              <a:lnSpc>
+                <a:spcPct val="106000"/>
+              </a:lnSpc>
+              <a:spcBef>
+                <a:spcPts val="0"/>
+              </a:spcBef>
+              <a:spcAft>
+                <a:spcPts val="300"/>
+              </a:spcAft>
+            </a:pPr>
+            <a:r>
+              <a:rPr sz="850" b="1" i="0">
+                <a:solidFill>
+                  <a:srgbClr val="322014"/>
+                </a:solidFill>
+                <a:latin typeface="Arial"/>
+              </a:rPr>
+              <a:t>Global Superstore · Revival Strategy</a:t>
+            </a:r>
+          </a:p>
+        </p:txBody>
+      </p:sp>
+      <p:sp>
+        <p:nvSpPr>
+          <p:cNvPr id="7" name="TextBox 6"/>
+          <p:cNvSpPr txBox="1"/>
+          <p:nvPr/>
+        </p:nvSpPr>
+        <p:spPr>
+          <a:xfrm>
+            <a:off x="10710367" y="6400800"/>
+            <a:ext cx="914400" cy="219456"/>
+          </a:xfrm>
+          <a:prstGeom prst="rect">
+            <a:avLst/>
+          </a:prstGeom>
+          <a:noFill/>
+        </p:spPr>
+        <p:txBody>
+          <a:bodyPr wrap="square" anchor="t" lIns="0" rIns="0" tIns="0" bIns="0">
+            <a:spAutoFit/>
+          </a:bodyPr>
+          <a:lstStyle/>
+          <a:p>
+            <a:pPr algn="r">
+              <a:lnSpc>
+                <a:spcPct val="106000"/>
+              </a:lnSpc>
+              <a:spcBef>
+                <a:spcPts val="0"/>
+              </a:spcBef>
+              <a:spcAft>
+                <a:spcPts val="300"/>
+              </a:spcAft>
+            </a:pPr>
+            <a:r>
+              <a:rPr sz="850" b="0" i="0">
+                <a:solidFill>
+                  <a:srgbClr val="8A7B6B"/>
+                </a:solidFill>
+                <a:latin typeface="Arial"/>
+              </a:rPr>
               <a:t>1</a:t>
             </a:r>
           </a:p>
@@ -23200,6 +24187,54 @@
                 <a:latin typeface="Arial"/>
               </a:rPr>
               <a:t>Gross margin cannot cover concessions deeper than 20%, so the cap follows from the data.</a:t>
+            </a:r>
+          </a:p>
+          <a:p>
+            <a:pPr algn="l" marL="155448" indent="-155448">
+              <a:lnSpc>
+                <a:spcPct val="114000"/>
+              </a:lnSpc>
+              <a:spcBef>
+                <a:spcPts val="0"/>
+              </a:spcBef>
+              <a:spcAft>
+                <a:spcPts val="300"/>
+              </a:spcAft>
+              <a:buFont typeface="Arial"/>
+              <a:buChar char="•"/>
+            </a:pPr>
+            <a:r>
+              <a:rPr sz="1100" b="0" i="0">
+                <a:solidFill>
+                  <a:srgbClr val="322014"/>
+                </a:solidFill>
+                <a:latin typeface="Arial"/>
+              </a:rPr>
+              <a:t>Past 50% off, every single order loses money - even the best orders in that band are down 73%.</a:t>
+            </a:r>
+          </a:p>
+          <a:p>
+            <a:pPr algn="l" marL="155448" indent="-155448">
+              <a:lnSpc>
+                <a:spcPct val="114000"/>
+              </a:lnSpc>
+              <a:spcBef>
+                <a:spcPts val="0"/>
+              </a:spcBef>
+              <a:spcAft>
+                <a:spcPts val="300"/>
+              </a:spcAft>
+              <a:buFont typeface="Arial"/>
+              <a:buChar char="•"/>
+            </a:pPr>
+            <a:r>
+              <a:rPr sz="1100" b="0" i="0">
+                <a:solidFill>
+                  <a:srgbClr val="322014"/>
+                </a:solidFill>
+                <a:latin typeface="Arial"/>
+              </a:rPr>
+              <a:t>Rank correlation between discount and profit: -0.60 (Pearson: -0.32). The damage is a cliff, not a straight line.</a:t>
             </a:r>
           </a:p>
         </p:txBody>

</xml_diff>

<commit_message>
feat: added logo & fixed presentation
</commit_message>
<xml_diff>
--- a/presentation/board_deck.pptx
+++ b/presentation/board_deck.pptx
@@ -2575,22 +2575,22 @@
           <a:lstStyle/>
           <a:p>
             <a:r>
-              <a:t>[0:30 - Slide 1 of 17]</a:t>
-            </a:r>
-          </a:p>
-          <a:p>
-            <a:r>
-              <a:t>SAY: "Good morning. Four years of transaction data - 51,290 order lines - and one finding: Global Superstore does not have a growth problem. It has a pricing problem. In the next ten minutes we will show you exactly where the profit leaks, and a three-lever plan that recovers $1.23M without a dollar of new capital."</a:t>
-            </a:r>
-          </a:p>
-          <a:p>
-            <a:r>
-              <a:t>DELIVERY: One line of team intro - Syndicate 6, seven analysts - then move. Do not read the roster aloud.</a:t>
-            </a:r>
-          </a:p>
-          <a:p>
-            <a:r>
-              <a:t>TRANSITION: "Let us start with the headline number."</a:t>
+              <a:t>[0:30 - Slide 1 of 18]</a:t>
+            </a:r>
+          </a:p>
+          <a:p>
+            <a:r>
+              <a:t>SAY: "Good morning. We studied four years of sales data - 51,290 order lines. We found one thing: Global Superstore does not have a growth problem. It has a pricing problem. In the next ten minutes we will show you where the profit is going, and a three-step plan that brings back $1.23M without spending any new money."</a:t>
+            </a:r>
+          </a:p>
+          <a:p>
+            <a:r>
+              <a:t>DELIVERY: Say one line about the team - Syndicate 6, seven analysts - then move on. Do not read the name list.</a:t>
+            </a:r>
+          </a:p>
+          <a:p>
+            <a:r>
+              <a:t>TRANSITION: "Let us start with the headline."</a:t>
             </a:r>
           </a:p>
         </p:txBody>
@@ -2660,17 +2660,17 @@
           <a:lstStyle/>
           <a:p>
             <a:r>
-              <a:t>[0:30 - Slide 10 of 17]</a:t>
-            </a:r>
-          </a:p>
-          <a:p>
-            <a:r>
-              <a:t>SAY: Three root causes, all policy, none market-driven. Uncontrolled discounting, worth +$1.03M to fix. Loss-making overseas territories served direct, +$0.18M. Bulky Tables freight never billed, +$0.05M. Recovery exceeds the reported $921K leak because capping discounts returns those lines to positive margin - not just to break-even.</a:t>
-            </a:r>
-          </a:p>
-          <a:p>
-            <a:r>
-              <a:t>TRANSITION: "Before we commit to this plan - what else did we consider?"</a:t>
+              <a:t>[0:30 - Slide 10 of 18]</a:t>
+            </a:r>
+          </a:p>
+          <a:p>
+            <a:r>
+              <a:t>SAY: Three root causes, and all three are our own rules. Uncontrolled discounts: +$1.03M to fix. Direct shipping to Turkey and Nigeria: +$0.18M. Free freight on Tables: +$0.05M. The recovery is bigger than the $921K leak, because capping discounts turns those orders back into profitable ones.</a:t>
+            </a:r>
+          </a:p>
+          <a:p>
+            <a:r>
+              <a:t>TRANSITION: "Before the plan - what else did we consider?"</a:t>
             </a:r>
           </a:p>
         </p:txBody>
@@ -2740,22 +2740,22 @@
           <a:lstStyle/>
           <a:p>
             <a:r>
-              <a:t>[0:45 - Slide 11 of 17]</a:t>
-            </a:r>
-          </a:p>
-          <a:p>
-            <a:r>
-              <a:t>SAY: Three alternatives, three eliminations. First: raise list prices and allow deeper discounts - rejected, because the leak follows the discount depth, not the list price: 88.5% of loss dollars sit above the 20% line, so a bigger cap re-opens the wound. Second: exit Turkey and Nigeria - rejected: it forfeits $163K of revenue; 3PL removes the same $179K loss while keeping every sale. Third: renegotiate all carrier rates - demoted to support: a realistic 10% cut returns about $0.14M after a year of contracting and never touches the $814,682 discount leak.</a:t>
-            </a:r>
-          </a:p>
-          <a:p>
-            <a:r>
-              <a:t>IF ASKED "why not raise prices anyway?": A price rise hits our 75.5% healthy lines too. The cap only touches the 22% that lose money.</a:t>
-            </a:r>
-          </a:p>
-          <a:p>
-            <a:r>
-              <a:t>TRANSITION: "That leaves the three-lever plan - here it is."</a:t>
+              <a:t>[0:45 - Slide 11 of 18]</a:t>
+            </a:r>
+          </a:p>
+          <a:p>
+            <a:r>
+              <a:t>SAY: We tested three other ideas, and rejected all three. First: raise prices but allow bigger discounts. No - the loss follows the size of the discount, not the list price: 88.5% of the lost money sits above 20%. Second: stop selling in Turkey and Nigeria. No - that gives up $163K of sales; local partners remove the same $179K loss and keep every sale. Third: ask all carriers for cheaper shipping. Not enough - a 10% better price returns about $0.14M after a year of talks, and does not touch the $814,682 discount problem.</a:t>
+            </a:r>
+          </a:p>
+          <a:p>
+            <a:r>
+              <a:t>IF ASKED "why not raise prices anyway?": "Higher prices hit the 75.5% of orders that are healthy. The cap only touches the 22% that lose money."</a:t>
+            </a:r>
+          </a:p>
+          <a:p>
+            <a:r>
+              <a:t>TRANSITION: "So here is the plan."</a:t>
             </a:r>
           </a:p>
         </p:txBody>
@@ -2825,17 +2825,17 @@
           <a:lstStyle/>
           <a:p>
             <a:r>
-              <a:t>[0:45 - Slide 12 of 17]</a:t>
-            </a:r>
-          </a:p>
-          <a:p>
-            <a:r>
-              <a:t>SAY: Three initiatives, each with an owner and a date. One: pricing governance - a hard 20% cap in order entry - Chief Commercial Officer, months 1-2, +$1.03M. Two: Turkey and Nigeria restructured to bonded third-party logistics - VP Global Supply Chain, months 3-4, +$0.18M. Three: Tables freight pass-through and repricing - Head of Merchandising, months 5-7, +$0.05M. Note the KPI column: the first one is "no order above 15% discount below 2% of orders".</a:t>
-            </a:r>
-          </a:p>
-          <a:p>
-            <a:r>
-              <a:t>TRANSITION: "Net of churn, here is the money."</a:t>
+              <a:t>[0:45 - Slide 12 of 18]</a:t>
+            </a:r>
+          </a:p>
+          <a:p>
+            <a:r>
+              <a:t>SAY: Three actions, each with an owner and a date. One: cap all discounts at 20% in the ordering system - Chief Commercial Officer, months 1-2, +$1.03M. Two: move Turkey and Nigeria to local delivery partners - VP Supply Chain, months 3-4, +$0.18M. Three: charge shipping costs on Tables - Head of Merchandising, months 5-7, +$0.05M. Each action has a KPI, shown on the slide.</a:t>
+            </a:r>
+          </a:p>
+          <a:p>
+            <a:r>
+              <a:t>TRANSITION: "After customer losses, here is the money."</a:t>
             </a:r>
           </a:p>
         </p:txBody>
@@ -2905,22 +2905,22 @@
           <a:lstStyle/>
           <a:p>
             <a:r>
-              <a:t>[0:30 - Slide 13 of 17]</a:t>
-            </a:r>
-          </a:p>
-          <a:p>
-            <a:r>
-              <a:t>SAY: From $1.47M baseline: plus $1.03M from the cap, plus $0.18M from 3PL, plus $0.05M freight, minus $0.02M for a 5% churn allowance - landing at $2.70M projected. Margin moves from 11.6% to 19.9%. That is about $0.31M a year on the same run-rate.</a:t>
-            </a:r>
-          </a:p>
-          <a:p>
-            <a:r>
-              <a:t>IF ASKED about the 5% churn: It is a deliberate penalty for price-sensitive buyers who walk. The stress test on the next slide shows we are robust even at 7%.</a:t>
-            </a:r>
-          </a:p>
-          <a:p>
-            <a:r>
-              <a:t>TRANSITION: "And the plan holds under stress."</a:t>
+              <a:t>[0:30 - Slide 13 of 18]</a:t>
+            </a:r>
+          </a:p>
+          <a:p>
+            <a:r>
+              <a:t>SAY: From $1.47M today: add $1.03M from the cap, $0.18M from local partners, $0.05M from freight fees, take away $0.02M for customers who leave - and we reach $2.70M. Margin goes from 11.6% to 19.9%. That is about $0.31M more per year.</a:t>
+            </a:r>
+          </a:p>
+          <a:p>
+            <a:r>
+              <a:t>IF ASKED about the 5%: "It is a safety margin for customers who leave. The next slide shows we are safe even at 7%."</a:t>
+            </a:r>
+          </a:p>
+          <a:p>
+            <a:r>
+              <a:t>TRANSITION: "And the plan survives a stress test."</a:t>
             </a:r>
           </a:p>
         </p:txBody>
@@ -2990,17 +2990,17 @@
           <a:lstStyle/>
           <a:p>
             <a:r>
-              <a:t>[0:30 - Slide 14 of 17]</a:t>
-            </a:r>
-          </a:p>
-          <a:p>
-            <a:r>
-              <a:t>SAY: The conservative case - a 25% cap, no surcharge, 7% churn, half the 3PL transition - still lifts profit +$0.91M to $2.37M. The aggressive case reaches $3.0M. The recommendation does not depend on optimism; every scenario beats the status quo decisively.</a:t>
-            </a:r>
-          </a:p>
-          <a:p>
-            <a:r>
-              <a:t>TRANSITION: "Execution is a four-phase, twelve-month program."</a:t>
+              <a:t>[0:15 - Slide 14 of 18]</a:t>
+            </a:r>
+          </a:p>
+          <a:p>
+            <a:r>
+              <a:t>SAY: The careful case - a 25% cap, no fees, 7% customer loss, half the local-partner change - still adds +$0.91M, to $2.37M. The strong case reaches $3.0M. One sentence: the recommendation does not depend on optimism.</a:t>
+            </a:r>
+          </a:p>
+          <a:p>
+            <a:r>
+              <a:t>TRANSITION: "Execution is a four-phase plan over twelve months."</a:t>
             </a:r>
           </a:p>
         </p:txBody>
@@ -3070,17 +3070,17 @@
           <a:lstStyle/>
           <a:p>
             <a:r>
-              <a:t>[0:30 - Slide 15 of 17]</a:t>
-            </a:r>
-          </a:p>
-          <a:p>
-            <a:r>
-              <a:t>SAY: Phase 1, months 1-2, is an order-entry rule - no capital, no new systems. Phase 2, months 3-4, cuts the regional loss by 70%. Phase 3, months 5-7, brings Tables back to break-even. Phase 4, months 8-12, makes it permanent: quarterly margin audits and a standing margin committee, with company margin above 15.5% as the exit target.</a:t>
-            </a:r>
-          </a:p>
-          <a:p>
-            <a:r>
-              <a:t>TRANSITION: "Which brings us to the three approvals we need today."</a:t>
+              <a:t>[0:30 - Slide 15 of 18]</a:t>
+            </a:r>
+          </a:p>
+          <a:p>
+            <a:r>
+              <a:t>SAY: Phase 1, months 1-2, is one rule in the ordering system - no new money, no new software. Phase 2, months 3-4, cuts the regional loss by 70%. Phase 3, months 5-7, brings Tables back to zero loss. Phase 4, months 8-12, makes it permanent with quarterly reviews and a margin committee. Target: margin above 15.5%.</a:t>
+            </a:r>
+          </a:p>
+          <a:p>
+            <a:r>
+              <a:t>TRANSITION: "So what does the future look like if we do this?"</a:t>
             </a:r>
           </a:p>
         </p:txBody>
@@ -3150,17 +3150,17 @@
           <a:lstStyle/>
           <a:p>
             <a:r>
-              <a:t>[0:30 - Slide 16 of 17]</a:t>
-            </a:r>
-          </a:p>
-          <a:p>
-            <a:r>
-              <a:t>SAY: Three decisions. Approve the 20% discount cap with VP sign-off between 15% and 20% and a hard block above 20%. Authorize the 3PL transition for Turkey and Nigeria. Charter a margin committee chaired by the CFO. Zero new capital; first savings inside 90 days; +$1.23M and a 19.9% margin on the full ledger.</a:t>
-            </a:r>
-          </a:p>
-          <a:p>
-            <a:r>
-              <a:t>IF ASKED "what if we only approve the cap?": The cap alone delivers $1.03M of the $1.23M - but the territories keep bleeding $179K, so we would be back asking for phase 2 within the year.</a:t>
+              <a:t>[0:30 - Slide 17 of 18]</a:t>
+            </a:r>
+          </a:p>
+          <a:p>
+            <a:r>
+              <a:t>SAY: Three decisions. Approve the 20% discount cap - manager approval between 15% and 20%, blocked above 20%. Approve the change to local delivery partners in Turkey and Nigeria. Start a margin committee led by the CFO. No new money is needed; first savings come inside 90 days; the full gain is $1.23M and a 19.9% margin.</a:t>
+            </a:r>
+          </a:p>
+          <a:p>
+            <a:r>
+              <a:t>IF ASKED "what if we approve only the cap?": "The cap alone gives $1.03M of the $1.23M - but Turkey and Nigeria keep losing $179K, so we would ask for that step again within a year."</a:t>
             </a:r>
           </a:p>
           <a:p>
@@ -3235,32 +3235,122 @@
           <a:lstStyle/>
           <a:p>
             <a:r>
-              <a:t>[0:15 - Slide 17 of 17]</a:t>
-            </a:r>
-          </a:p>
-          <a:p>
-            <a:r>
-              <a:t>SAY: Close on the quote, then: "The ship is taking on $921K a year. We know exactly where the leak is, and the repair is three decisions - not a rescue plan. We recommend approval this quarter."</a:t>
-            </a:r>
-          </a:p>
-          <a:p>
-            <a:r>
-              <a:t>Q&amp;A PREP - the three toughest questions:</a:t>
-            </a:r>
-          </a:p>
-          <a:p>
-            <a:r>
-              <a:t>1. "Is 5% churn not optimistic?" - Conservative case carries 7% churn and still returns +$0.91M (slide 14).</a:t>
-            </a:r>
-          </a:p>
-          <a:p>
-            <a:r>
-              <a:t>2. "Why not simply raise prices?" - The leak follows discount depth, not list price; 88.5% of losses sit above the 20% cap (slide 11).</a:t>
-            </a:r>
-          </a:p>
-          <a:p>
-            <a:r>
-              <a:t>3. "3PL execution risk in volatile markets?" - Phased and reversible per country, bonded master distributors, break-even KPI inside 90 days (slide 12).</a:t>
+              <a:t>[0:15 - Slide 18 of 18]</a:t>
+            </a:r>
+          </a:p>
+          <a:p>
+            <a:r>
+              <a:t>SAY: End with the quote, then: "This company is losing $921K a year. We know exactly where the money goes, and the repair is three decisions - not a rescue plan. We ask for approval this quarter."</a:t>
+            </a:r>
+          </a:p>
+          <a:p>
+            <a:r>
+              <a:t>Q&amp;A PREP - the three hardest questions:</a:t>
+            </a:r>
+          </a:p>
+          <a:p>
+            <a:r>
+              <a:t>1. "Is 5% customer loss too optimistic?" - The careful case uses 7% and still gains +$0.91M (slide 14).</a:t>
+            </a:r>
+          </a:p>
+          <a:p>
+            <a:r>
+              <a:t>2. "Why not simply raise prices?" - The loss follows the discount size, not the list price; 88.5% of losses sit above the 20% cap (slide 11).</a:t>
+            </a:r>
+          </a:p>
+          <a:p>
+            <a:r>
+              <a:t>3. "Is the local-partner change risky?" - It goes step by step, per country, with a break-even target in 90 days (slide 12).</a:t>
+            </a:r>
+          </a:p>
+        </p:txBody>
+      </p:sp>
+      <p:sp>
+        <p:nvSpPr>
+          <p:cNvPr id="4" name="Slide Number Placeholder 3"/>
+          <p:cNvSpPr>
+            <a:spLocks noGrp="1"/>
+          </p:cNvSpPr>
+          <p:nvPr>
+            <p:ph type="sldNum" idx="5" sz="quarter"/>
+          </p:nvPr>
+        </p:nvSpPr>
+        <p:spPr/>
+      </p:sp>
+    </p:spTree>
+  </p:cSld>
+  <p:clrMapOvr>
+    <a:masterClrMapping/>
+  </p:clrMapOvr>
+</p:notes>
+</file>
+
+<file path=ppt/notesSlides/notesSlide18.xml><?xml version="1.0" encoding="utf-8"?>
+<p:notes xmlns:a="http://schemas.openxmlformats.org/drawingml/2006/main" xmlns:p="http://schemas.openxmlformats.org/presentationml/2006/main" xmlns:r="http://schemas.openxmlformats.org/officeDocument/2006/relationships">
+  <p:cSld>
+    <p:spTree>
+      <p:nvGrpSpPr>
+        <p:cNvPr id="1" name=""/>
+        <p:cNvGrpSpPr/>
+        <p:nvPr/>
+      </p:nvGrpSpPr>
+      <p:grpSpPr>
+        <a:xfrm>
+          <a:off x="0" y="0"/>
+          <a:ext cx="0" cy="0"/>
+          <a:chOff x="0" y="0"/>
+          <a:chExt cx="0" cy="0"/>
+        </a:xfrm>
+      </p:grpSpPr>
+      <p:sp>
+        <p:nvSpPr>
+          <p:cNvPr id="2" name="Slide Image Placeholder 1"/>
+          <p:cNvSpPr>
+            <a:spLocks noGrp="1"/>
+          </p:cNvSpPr>
+          <p:nvPr>
+            <p:ph type="sldImg" idx="2"/>
+          </p:nvPr>
+        </p:nvSpPr>
+        <p:spPr/>
+      </p:sp>
+      <p:sp>
+        <p:nvSpPr>
+          <p:cNvPr id="3" name="Notes Placeholder 2"/>
+          <p:cNvSpPr>
+            <a:spLocks noGrp="1"/>
+          </p:cNvSpPr>
+          <p:nvPr>
+            <p:ph type="body" idx="3" sz="quarter"/>
+          </p:nvPr>
+        </p:nvSpPr>
+        <p:spPr/>
+        <p:txBody>
+          <a:bodyPr/>
+          <a:lstStyle/>
+          <a:p>
+            <a:r>
+              <a:t>[0:30 - Slide 16 of 18]</a:t>
+            </a:r>
+          </a:p>
+          <a:p>
+            <a:r>
+              <a:t>SAY: Three predictions, all tested on data the models never saw. One: FY2015 revenue will be about $5.28M, up 23%, if trends continue. Two: the 20% cap keeps almost all volume - about 101% - because big discounts never brought many sales. Three: we can name the customers most likely to stop buying. The riskiest tenth of them leave at almost three times the average rate.</a:t>
+            </a:r>
+          </a:p>
+          <a:p>
+            <a:r>
+              <a:t>DELIVERY: Say slowly: "the cap costs us almost no volume." This is the key new fact.</a:t>
+            </a:r>
+          </a:p>
+          <a:p>
+            <a:r>
+              <a:t>IF ASKED "how reliable are these numbers?": "The forecast was tested on FY2014: error 10%. The churn model was tested on held-out customers: 0.80 AUC."</a:t>
+            </a:r>
+          </a:p>
+          <a:p>
+            <a:r>
+              <a:t>TRANSITION: "That brings us to the three approvals we need today."</a:t>
             </a:r>
           </a:p>
         </p:txBody>
@@ -3330,27 +3420,27 @@
           <a:lstStyle/>
           <a:p>
             <a:r>
-              <a:t>[1:00 - Slide 2 of 17]</a:t>
-            </a:r>
-          </a:p>
-          <a:p>
-            <a:r>
-              <a:t>SAY: Four numbers tell the whole story. Revenue nearly doubled, $2.26M to $4.30M, up 90.3% - so the rumors of stagnation are false. Yet margin is stuck at 11.6%. Why? One in four order lines sells at a loss, destroying $920,646. The fix is not more sales - it is three policy levers that recover $1.23M, an 84% uplift, with zero new capital.</a:t>
-            </a:r>
-          </a:p>
-          <a:p>
-            <a:r>
-              <a:t>DELIVERY: Point at each of the four cards as you name it. Pause after "$920,646".</a:t>
-            </a:r>
-          </a:p>
-          <a:p>
-            <a:r>
-              <a:t>IF ASKED "is $1.23M realistic?": It is the base case of our simulator; even the conservative case returns +$0.91M - slide 14 covers the stress test.</a:t>
-            </a:r>
-          </a:p>
-          <a:p>
-            <a:r>
-              <a:t>TRANSITION: "First, the diagnosis. Is the growth real?"</a:t>
+              <a:t>[0:45 - Slide 2 of 18]</a:t>
+            </a:r>
+          </a:p>
+          <a:p>
+            <a:r>
+              <a:t>SAY: Four numbers tell the whole story. Revenue almost doubled, from $2.26M to $4.30M - up 90.3% - so the rumours about falling sales are wrong. But margin stayed at 11.6%. Why? One in four order lines was sold at a loss, and those losses destroyed $920,646. The fix is not more sales - it is three actions that bring back $1.23M, an 84% increase, with no new money.</a:t>
+            </a:r>
+          </a:p>
+          <a:p>
+            <a:r>
+              <a:t>DELIVERY: Point at each of the four cards as you say it. Pause after "$920,646".</a:t>
+            </a:r>
+          </a:p>
+          <a:p>
+            <a:r>
+              <a:t>IF ASKED "is $1.23M realistic?": "It is the base case of our simulator. Even the careful case gives +$0.91M - slide 14 shows that test."</a:t>
+            </a:r>
+          </a:p>
+          <a:p>
+            <a:r>
+              <a:t>TRANSITION: "First: is the growth real?"</a:t>
             </a:r>
           </a:p>
         </p:txBody>
@@ -3420,17 +3510,17 @@
           <a:lstStyle/>
           <a:p>
             <a:r>
-              <a:t>[0:30 - Slide 3 of 17]</a:t>
-            </a:r>
-          </a:p>
-          <a:p>
-            <a:r>
-              <a:t>SAY: Growth is genuine and volume-driven. Revenue rose every single year - +18.5%, +27.2%, +26.3% - and operating profit more than doubled to $504K. Orders grew from 4,440 to 8,531; average order value stayed flat at about $505. We grew by adding customers and orders, not by raising prices - which is precisely why margin never improved.</a:t>
-            </a:r>
-          </a:p>
-          <a:p>
-            <a:r>
-              <a:t>TRANSITION: "Zoom out and the pattern is stark: every extra dollar arrived at the same thin margin."</a:t>
+              <a:t>[0:30 - Slide 3 of 18]</a:t>
+            </a:r>
+          </a:p>
+          <a:p>
+            <a:r>
+              <a:t>SAY: The growth is real, and it comes from more orders. Revenue rose every year: +18.5%, +27.2%, +26.3%. Operating profit more than doubled, to $504K. Orders grew from 4,440 to 8,531. The average order stayed at about $505. We grew by adding customers, not by raising prices - and that is why margin never improved.</a:t>
+            </a:r>
+          </a:p>
+          <a:p>
+            <a:r>
+              <a:t>TRANSITION: "Look at the margin line: every extra dollar came with the same thin profit."</a:t>
             </a:r>
           </a:p>
         </p:txBody>
@@ -3500,17 +3590,17 @@
           <a:lstStyle/>
           <a:p>
             <a:r>
-              <a:t>[0:30 - Slide 4 of 17]</a:t>
-            </a:r>
-          </a:p>
-          <a:p>
-            <a:r>
-              <a:t>SAY: Margin hovered between 11.0% and 11.9% for four straight years - profit grew exactly in line with revenue, so scale bought us nothing. The reason is incentive design: we measure and pay for gross volume, so nobody defended price. Margin - not revenue - is the number this Board should track from here.</a:t>
-            </a:r>
-          </a:p>
-          <a:p>
-            <a:r>
-              <a:t>TRANSITION: "So where does the profit actually go? A quarter of everything we sell loses money."</a:t>
+              <a:t>[0:30 - Slide 4 of 18]</a:t>
+            </a:r>
+          </a:p>
+          <a:p>
+            <a:r>
+              <a:t>SAY: Margin stayed between 11.0% and 11.9% for four years. Profit grew at the same speed as sales, so getting bigger did not make us more profitable. Why? The company pays bonuses for sales volume, so nobody protected the price. From today, margin - not revenue - is the number to watch.</a:t>
+            </a:r>
+          </a:p>
+          <a:p>
+            <a:r>
+              <a:t>TRANSITION: "So where does the profit go? One in four orders loses money."</a:t>
             </a:r>
           </a:p>
         </p:txBody>
@@ -3580,12 +3670,12 @@
           <a:lstStyle/>
           <a:p>
             <a:r>
-              <a:t>[0:45 - Slide 5 of 17]</a:t>
-            </a:r>
-          </a:p>
-          <a:p>
-            <a:r>
-              <a:t>SAY: Walk the bridge. Profitable lines earn $2.39M - that core is strong on its own. But 12,544 lines - one in four - were priced below cost and wiped out $920,646 of it. Reported profit: $1.47M. Our healthy core is being taxed by our own pricing.</a:t>
+              <a:t>[0:45 - Slide 5 of 18]</a:t>
+            </a:r>
+          </a:p>
+          <a:p>
+            <a:r>
+              <a:t>SAY: Read the bridge from left to right. Orders that make money bring in $2.39M - that part is strong. But 12,544 order lines - one in four - were sold below cost, and they destroyed $920,646 of it. What is left: $1.47M.</a:t>
             </a:r>
           </a:p>
           <a:p>
@@ -3595,12 +3685,12 @@
           </a:p>
           <a:p>
             <a:r>
-              <a:t>IF ASKED "is 24.5% normal?": Healthy retail runs low-single-digit loss-line rates. Ours is an outlier caused by policy, not by the market - slide 8 shows the exact mechanism.</a:t>
-            </a:r>
-          </a:p>
-          <a:p>
-            <a:r>
-              <a:t>TRANSITION: "Where is the loss concentrated? First, geography."</a:t>
+              <a:t>IF ASKED "is 24.5% normal?": "Healthy shops lose money on only a few percent of orders. Our number is high because of our own pricing rules - slide 8 shows exactly how."</a:t>
+            </a:r>
+          </a:p>
+          <a:p>
+            <a:r>
+              <a:t>TRANSITION: "Where is the loss? First, the map."</a:t>
             </a:r>
           </a:p>
         </p:txBody>
@@ -3670,17 +3760,17 @@
           <a:lstStyle/>
           <a:p>
             <a:r>
-              <a:t>[0:30 - Slide 6 of 17]</a:t>
-            </a:r>
-          </a:p>
-          <a:p>
-            <a:r>
-              <a:t>SAY: 29 of 147 countries are net-negative, and Turkey (-$98K) and Nigeria (-$81K) carry most of the deficit. Both were sold at 60-70% average discounts, with cross-border freight absorbed centrally. This is a company-policy loss, not a market loss: EMEA runs 5.4% margin against 12-13% in our healthy markets.</a:t>
-            </a:r>
-          </a:p>
-          <a:p>
-            <a:r>
-              <a:t>TRANSITION: "One product line tells exactly the same story."</a:t>
+              <a:t>[0:30 - Slide 6 of 18]</a:t>
+            </a:r>
+          </a:p>
+          <a:p>
+            <a:r>
+              <a:t>SAY: 29 of 147 countries lose money. Turkey (-$98K) and Nigeria (-$81K) are the biggest. Both sold with 60-70% discounts, and we paid their shipping costs ourselves. This is a policy problem, not a market problem: EMEA earns 5.4% margin while our healthy markets earn 12-13%.</a:t>
+            </a:r>
+          </a:p>
+          <a:p>
+            <a:r>
+              <a:t>TRANSITION: "One product tells the same story."</a:t>
             </a:r>
           </a:p>
         </p:txBody>
@@ -3750,17 +3840,17 @@
           <a:lstStyle/>
           <a:p>
             <a:r>
-              <a:t>[0:30 - Slide 7 of 17]</a:t>
-            </a:r>
-          </a:p>
-          <a:p>
-            <a:r>
-              <a:t>SAY: Sixteen of seventeen sub-categories are profitable - Copiers +$259K, Phones +$217K. Tables is the only loser: -$64.1K on $757K of sales, carrying a 29.1% average discount plus the highest freight per unit in the catalogue. That drags Furniture to a 6.9% margin against Technology's 14.0%.</a:t>
-            </a:r>
-          </a:p>
-          <a:p>
-            <a:r>
-              <a:t>TRANSITION: "But the biggest single cause is a line you can draw on a chart: twenty percent."</a:t>
+              <a:t>[0:30 - Slide 7 of 18]</a:t>
+            </a:r>
+          </a:p>
+          <a:p>
+            <a:r>
+              <a:t>SAY: 16 of 17 product lines make money - Copiers +$259K, Phones +$217K. Only Tables loses: -$64K on $757K of sales, with a 29.1% average discount and the highest shipping cost per item. That is why Furniture earns 6.9% and Technology 14.0%.</a:t>
+            </a:r>
+          </a:p>
+          <a:p>
+            <a:r>
+              <a:t>TRANSITION: "But the biggest single cause is one number: 20%."</a:t>
             </a:r>
           </a:p>
         </p:txBody>
@@ -3830,27 +3920,32 @@
           <a:lstStyle/>
           <a:p>
             <a:r>
-              <a:t>[1:00 - Slide 8 of 17]</a:t>
-            </a:r>
-          </a:p>
-          <a:p>
-            <a:r>
-              <a:t>SAY: This is the most important chart in the deck. Below 20% discount, every band is profitable: +25.3% with no discount, still +9.9% at 10-20%. Above 20%, every band loses: -5.5%, worsening to -111% past 50%. 11,328 lines - 22.1% of the ledger - were priced past that line and lost $814,682: that is 88.5% of ALL loss dollars.</a:t>
-            </a:r>
-          </a:p>
-          <a:p>
-            <a:r>
-              <a:t>DELIVERY: Trace the cliff with your hand. Pause at "88.5%".</a:t>
-            </a:r>
-          </a:p>
-          <a:p>
-            <a:r>
-              <a:t>IF ASKED "why 20% exactly?": It is where the data inverts, not a round number we picked - gross margin cannot carry concessions deeper than 20%.</a:t>
-            </a:r>
-          </a:p>
-          <a:p>
-            <a:r>
-              <a:t>TRANSITION: "Discounting has an accomplice: freight."</a:t>
+              <a:t>[1:00 - Slide 8 of 18]</a:t>
+            </a:r>
+          </a:p>
+          <a:p>
+            <a:r>
+              <a:t>SAY: This is the most important chart in the deck. Below 20% discount, every group makes money: +25.3% with no discount, still +9.9% at 10-20%. Above 20%, every group loses: -5.5%, then -111% past 50%. 11,328 order lines - 22.1% - crossed that line and lost $814,682. That is 88.5% of all the money we lose.</a:t>
+            </a:r>
+          </a:p>
+          <a:p>
+            <a:r>
+              <a:t>DELIVERY: Move your hand along the fall. Pause on "88.5%".</a:t>
+            </a:r>
+          </a:p>
+          <a:p>
+            <a:r>
+              <a:t>NEW ON THIS SLIDE: past 50% off, 100% of orders lose money. The correlation between discount and profit is -0.60 (rank) - proof that the damage is a cliff, not a slow slide.</a:t>
+            </a:r>
+          </a:p>
+          <a:p>
+            <a:r>
+              <a:t>IF ASKED "why exactly 20%?": "Because that is where the data turns negative. It is not a round number we picked - our margin cannot survive discounts deeper than 20%."</a:t>
+            </a:r>
+          </a:p>
+          <a:p>
+            <a:r>
+              <a:t>TRANSITION: "Shipping is the second cause."</a:t>
             </a:r>
           </a:p>
         </p:txBody>
@@ -3920,17 +4015,17 @@
           <a:lstStyle/>
           <a:p>
             <a:r>
-              <a:t>[0:30 - Slide 9 of 17]</a:t>
-            </a:r>
-          </a:p>
-          <a:p>
-            <a:r>
-              <a:t>SAY: Critical-priority orders spend 23.8% of their sales value on freight; Same Day spends 17.4% - against 8.1% for Standard Class, a third of the rate. Company-wide, freight is 10.7% of sales and is never charged back. Deep discounts and heavy freight land on the same orders - that is why they never recover.</a:t>
-            </a:r>
-          </a:p>
-          <a:p>
-            <a:r>
-              <a:t>TRANSITION: "Put the three together and the root causes are simple and few."</a:t>
+              <a:t>[0:30 - Slide 9 of 18]</a:t>
+            </a:r>
+          </a:p>
+          <a:p>
+            <a:r>
+              <a:t>SAY: Critical-priority orders spend 23.8% of their sales value on shipping; Same Day spends 17.4%. Standard Class spends only 8.1%. Across the company, shipping is 10.7% of sales, and we never charge it to the customer. Big discounts and heavy shipping land on the same orders.</a:t>
+            </a:r>
+          </a:p>
+          <a:p>
+            <a:r>
+              <a:t>TRANSITION: "Put the three causes together and the picture is simple."</a:t>
             </a:r>
           </a:p>
         </p:txBody>
@@ -15585,1597 +15680,6 @@
                 </a:solidFill>
                 <a:latin typeface="Arial"/>
               </a:rPr>
-              <a:t>Board decision</a:t>
-            </a:r>
-          </a:p>
-        </p:txBody>
-      </p:sp>
-      <p:cxnSp>
-        <p:nvCxnSpPr>
-          <p:cNvPr id="4" name="Connector 3"/>
-          <p:cNvCxnSpPr/>
-          <p:nvPr/>
-        </p:nvCxnSpPr>
-        <p:spPr>
-          <a:xfrm>
-            <a:off x="566928" y="658368"/>
-            <a:ext cx="11057839" cy="0"/>
-          </a:xfrm>
-          <a:prstGeom prst="line">
-            <a:avLst/>
-          </a:prstGeom>
-          <a:ln w="12700">
-            <a:solidFill>
-              <a:srgbClr val="322014"/>
-            </a:solidFill>
-          </a:ln>
-        </p:spPr>
-        <p:style>
-          <a:lnRef idx="2">
-            <a:schemeClr val="accent1"/>
-          </a:lnRef>
-          <a:fillRef idx="0">
-            <a:schemeClr val="accent1"/>
-          </a:fillRef>
-          <a:effectRef idx="1">
-            <a:schemeClr val="accent1"/>
-          </a:effectRef>
-          <a:fontRef idx="minor">
-            <a:schemeClr val="tx1"/>
-          </a:fontRef>
-        </p:style>
-      </p:cxnSp>
-      <p:cxnSp>
-        <p:nvCxnSpPr>
-          <p:cNvPr id="5" name="Connector 4"/>
-          <p:cNvCxnSpPr/>
-          <p:nvPr/>
-        </p:nvCxnSpPr>
-        <p:spPr>
-          <a:xfrm>
-            <a:off x="566928" y="6355080"/>
-            <a:ext cx="11057839" cy="0"/>
-          </a:xfrm>
-          <a:prstGeom prst="line">
-            <a:avLst/>
-          </a:prstGeom>
-          <a:ln w="9525">
-            <a:solidFill>
-              <a:srgbClr val="C5A681"/>
-            </a:solidFill>
-          </a:ln>
-        </p:spPr>
-        <p:style>
-          <a:lnRef idx="2">
-            <a:schemeClr val="accent1"/>
-          </a:lnRef>
-          <a:fillRef idx="0">
-            <a:schemeClr val="accent1"/>
-          </a:fillRef>
-          <a:effectRef idx="1">
-            <a:schemeClr val="accent1"/>
-          </a:effectRef>
-          <a:fontRef idx="minor">
-            <a:schemeClr val="tx1"/>
-          </a:fontRef>
-        </p:style>
-      </p:cxnSp>
-      <p:sp>
-        <p:nvSpPr>
-          <p:cNvPr id="6" name="TextBox 5"/>
-          <p:cNvSpPr txBox="1"/>
-          <p:nvPr/>
-        </p:nvSpPr>
-        <p:spPr>
-          <a:xfrm>
-            <a:off x="566928" y="6400800"/>
-            <a:ext cx="7740487" cy="219456"/>
-          </a:xfrm>
-          <a:prstGeom prst="rect">
-            <a:avLst/>
-          </a:prstGeom>
-          <a:noFill/>
-        </p:spPr>
-        <p:txBody>
-          <a:bodyPr wrap="square" anchor="t" lIns="0" rIns="0" tIns="0" bIns="0">
-            <a:spAutoFit/>
-          </a:bodyPr>
-          <a:lstStyle/>
-          <a:p>
-            <a:pPr algn="l">
-              <a:lnSpc>
-                <a:spcPct val="106000"/>
-              </a:lnSpc>
-              <a:spcBef>
-                <a:spcPts val="0"/>
-              </a:spcBef>
-              <a:spcAft>
-                <a:spcPts val="300"/>
-              </a:spcAft>
-            </a:pPr>
-            <a:r>
-              <a:rPr sz="850" b="1" i="0">
-                <a:solidFill>
-                  <a:srgbClr val="322014"/>
-                </a:solidFill>
-                <a:latin typeface="Arial"/>
-              </a:rPr>
-              <a:t>Global Superstore · Revival Strategy</a:t>
-            </a:r>
-          </a:p>
-        </p:txBody>
-      </p:sp>
-      <p:sp>
-        <p:nvSpPr>
-          <p:cNvPr id="7" name="TextBox 6"/>
-          <p:cNvSpPr txBox="1"/>
-          <p:nvPr/>
-        </p:nvSpPr>
-        <p:spPr>
-          <a:xfrm>
-            <a:off x="10710367" y="6400800"/>
-            <a:ext cx="914400" cy="219456"/>
-          </a:xfrm>
-          <a:prstGeom prst="rect">
-            <a:avLst/>
-          </a:prstGeom>
-          <a:noFill/>
-        </p:spPr>
-        <p:txBody>
-          <a:bodyPr wrap="square" anchor="t" lIns="0" rIns="0" tIns="0" bIns="0">
-            <a:spAutoFit/>
-          </a:bodyPr>
-          <a:lstStyle/>
-          <a:p>
-            <a:pPr algn="r">
-              <a:lnSpc>
-                <a:spcPct val="106000"/>
-              </a:lnSpc>
-              <a:spcBef>
-                <a:spcPts val="0"/>
-              </a:spcBef>
-              <a:spcAft>
-                <a:spcPts val="300"/>
-              </a:spcAft>
-            </a:pPr>
-            <a:r>
-              <a:rPr sz="850" b="0" i="0">
-                <a:solidFill>
-                  <a:srgbClr val="8A7B6B"/>
-                </a:solidFill>
-                <a:latin typeface="Arial"/>
-              </a:rPr>
-              <a:t>16</a:t>
-            </a:r>
-          </a:p>
-        </p:txBody>
-      </p:sp>
-      <p:sp>
-        <p:nvSpPr>
-          <p:cNvPr id="8" name="TextBox 7"/>
-          <p:cNvSpPr txBox="1"/>
-          <p:nvPr/>
-        </p:nvSpPr>
-        <p:spPr>
-          <a:xfrm>
-            <a:off x="566928" y="731520"/>
-            <a:ext cx="11057839" cy="640080"/>
-          </a:xfrm>
-          <a:prstGeom prst="rect">
-            <a:avLst/>
-          </a:prstGeom>
-          <a:noFill/>
-        </p:spPr>
-        <p:txBody>
-          <a:bodyPr wrap="square" anchor="t" lIns="0" rIns="0" tIns="0" bIns="0">
-            <a:spAutoFit/>
-          </a:bodyPr>
-          <a:lstStyle/>
-          <a:p>
-            <a:pPr algn="l">
-              <a:lnSpc>
-                <a:spcPct val="102000"/>
-              </a:lnSpc>
-              <a:spcBef>
-                <a:spcPts val="0"/>
-              </a:spcBef>
-              <a:spcAft>
-                <a:spcPts val="300"/>
-              </a:spcAft>
-            </a:pPr>
-            <a:r>
-              <a:rPr sz="2200" b="1" i="0">
-                <a:solidFill>
-                  <a:srgbClr val="322014"/>
-                </a:solidFill>
-                <a:latin typeface="Georgia"/>
-              </a:rPr>
-              <a:t>The Board must approve the 20% discount cap and 3PL restructuring this quarter</a:t>
-            </a:r>
-          </a:p>
-        </p:txBody>
-      </p:sp>
-      <p:sp>
-        <p:nvSpPr>
-          <p:cNvPr id="9" name="TextBox 8"/>
-          <p:cNvSpPr txBox="1"/>
-          <p:nvPr/>
-        </p:nvSpPr>
-        <p:spPr>
-          <a:xfrm>
-            <a:off x="566928" y="1737360"/>
-            <a:ext cx="6400800" cy="274320"/>
-          </a:xfrm>
-          <a:prstGeom prst="rect">
-            <a:avLst/>
-          </a:prstGeom>
-          <a:noFill/>
-        </p:spPr>
-        <p:txBody>
-          <a:bodyPr wrap="square" anchor="t" lIns="0" rIns="0" tIns="0" bIns="0">
-            <a:spAutoFit/>
-          </a:bodyPr>
-          <a:lstStyle/>
-          <a:p>
-            <a:pPr algn="l">
-              <a:lnSpc>
-                <a:spcPct val="106000"/>
-              </a:lnSpc>
-              <a:spcBef>
-                <a:spcPts val="0"/>
-              </a:spcBef>
-              <a:spcAft>
-                <a:spcPts val="300"/>
-              </a:spcAft>
-            </a:pPr>
-            <a:r>
-              <a:rPr sz="1200" b="1" i="0">
-                <a:solidFill>
-                  <a:srgbClr val="5A3921"/>
-                </a:solidFill>
-                <a:latin typeface="Georgia"/>
-              </a:rPr>
-              <a:t>Three decisions requested</a:t>
-            </a:r>
-          </a:p>
-        </p:txBody>
-      </p:sp>
-      <p:cxnSp>
-        <p:nvCxnSpPr>
-          <p:cNvPr id="10" name="Connector 9"/>
-          <p:cNvCxnSpPr/>
-          <p:nvPr/>
-        </p:nvCxnSpPr>
-        <p:spPr>
-          <a:xfrm>
-            <a:off x="566928" y="2011680"/>
-            <a:ext cx="6400800" cy="0"/>
-          </a:xfrm>
-          <a:prstGeom prst="line">
-            <a:avLst/>
-          </a:prstGeom>
-          <a:ln w="19050">
-            <a:solidFill>
-              <a:srgbClr val="322014"/>
-            </a:solidFill>
-          </a:ln>
-        </p:spPr>
-        <p:style>
-          <a:lnRef idx="2">
-            <a:schemeClr val="accent1"/>
-          </a:lnRef>
-          <a:fillRef idx="0">
-            <a:schemeClr val="accent1"/>
-          </a:fillRef>
-          <a:effectRef idx="1">
-            <a:schemeClr val="accent1"/>
-          </a:effectRef>
-          <a:fontRef idx="minor">
-            <a:schemeClr val="tx1"/>
-          </a:fontRef>
-        </p:style>
-      </p:cxnSp>
-      <p:sp>
-        <p:nvSpPr>
-          <p:cNvPr id="11" name="TextBox 10"/>
-          <p:cNvSpPr txBox="1"/>
-          <p:nvPr/>
-        </p:nvSpPr>
-        <p:spPr>
-          <a:xfrm>
-            <a:off x="566928" y="2194560"/>
-            <a:ext cx="6309360" cy="2926080"/>
-          </a:xfrm>
-          <a:prstGeom prst="rect">
-            <a:avLst/>
-          </a:prstGeom>
-          <a:noFill/>
-        </p:spPr>
-        <p:txBody>
-          <a:bodyPr wrap="square" anchor="t" lIns="0" rIns="0" tIns="0" bIns="0">
-            <a:spAutoFit/>
-          </a:bodyPr>
-          <a:lstStyle/>
-          <a:p>
-            <a:pPr algn="l" marL="155448" indent="-155448">
-              <a:lnSpc>
-                <a:spcPct val="114000"/>
-              </a:lnSpc>
-              <a:spcBef>
-                <a:spcPts val="0"/>
-              </a:spcBef>
-              <a:spcAft>
-                <a:spcPts val="1200"/>
-              </a:spcAft>
-              <a:buFont typeface="Arial"/>
-              <a:buChar char="•"/>
-            </a:pPr>
-            <a:r>
-              <a:rPr sz="1100" b="1" i="0">
-                <a:solidFill>
-                  <a:srgbClr val="322014"/>
-                </a:solidFill>
-                <a:latin typeface="Arial"/>
-              </a:rPr>
-              <a:t>Approve the 20% discount cap</a:t>
-            </a:r>
-            <a:r>
-              <a:rPr sz="1100" b="0" i="0">
-                <a:solidFill>
-                  <a:srgbClr val="322014"/>
-                </a:solidFill>
-                <a:latin typeface="Arial"/>
-              </a:rPr>
-              <a:t> in order entry, with VP sign-off for discounts between 15% and 20% and a hard block above 20%.</a:t>
-            </a:r>
-          </a:p>
-          <a:p>
-            <a:pPr algn="l" marL="155448" indent="-155448">
-              <a:lnSpc>
-                <a:spcPct val="114000"/>
-              </a:lnSpc>
-              <a:spcBef>
-                <a:spcPts val="0"/>
-              </a:spcBef>
-              <a:spcAft>
-                <a:spcPts val="1200"/>
-              </a:spcAft>
-              <a:buFont typeface="Arial"/>
-              <a:buChar char="•"/>
-            </a:pPr>
-            <a:r>
-              <a:rPr sz="1100" b="1" i="0">
-                <a:solidFill>
-                  <a:srgbClr val="322014"/>
-                </a:solidFill>
-                <a:latin typeface="Arial"/>
-              </a:rPr>
-              <a:t>Authorise the 3PL transition</a:t>
-            </a:r>
-            <a:r>
-              <a:rPr sz="1100" b="0" i="0">
-                <a:solidFill>
-                  <a:srgbClr val="322014"/>
-                </a:solidFill>
-                <a:latin typeface="Arial"/>
-              </a:rPr>
-              <a:t> for Turkey and Nigeria to remove the cross-border loss.</a:t>
-            </a:r>
-          </a:p>
-          <a:p>
-            <a:pPr algn="l" marL="155448" indent="-155448">
-              <a:lnSpc>
-                <a:spcPct val="114000"/>
-              </a:lnSpc>
-              <a:spcBef>
-                <a:spcPts val="0"/>
-              </a:spcBef>
-              <a:spcAft>
-                <a:spcPts val="300"/>
-              </a:spcAft>
-              <a:buFont typeface="Arial"/>
-              <a:buChar char="•"/>
-            </a:pPr>
-            <a:r>
-              <a:rPr sz="1100" b="1" i="0">
-                <a:solidFill>
-                  <a:srgbClr val="322014"/>
-                </a:solidFill>
-                <a:latin typeface="Arial"/>
-              </a:rPr>
-              <a:t>Charter a margin committee</a:t>
-            </a:r>
-            <a:r>
-              <a:rPr sz="1100" b="0" i="0">
-                <a:solidFill>
-                  <a:srgbClr val="322014"/>
-                </a:solidFill>
-                <a:latin typeface="Arial"/>
-              </a:rPr>
-              <a:t> chaired by the CFO to review discount leakage and Tables margin every quarter.</a:t>
-            </a:r>
-          </a:p>
-        </p:txBody>
-      </p:sp>
-      <p:cxnSp>
-        <p:nvCxnSpPr>
-          <p:cNvPr id="12" name="Connector 11"/>
-          <p:cNvCxnSpPr/>
-          <p:nvPr/>
-        </p:nvCxnSpPr>
-        <p:spPr>
-          <a:xfrm>
-            <a:off x="566928" y="5349240"/>
-            <a:ext cx="6309360" cy="0"/>
-          </a:xfrm>
-          <a:prstGeom prst="line">
-            <a:avLst/>
-          </a:prstGeom>
-          <a:ln w="19050">
-            <a:solidFill>
-              <a:srgbClr val="322014"/>
-            </a:solidFill>
-          </a:ln>
-        </p:spPr>
-        <p:style>
-          <a:lnRef idx="2">
-            <a:schemeClr val="accent1"/>
-          </a:lnRef>
-          <a:fillRef idx="0">
-            <a:schemeClr val="accent1"/>
-          </a:fillRef>
-          <a:effectRef idx="1">
-            <a:schemeClr val="accent1"/>
-          </a:effectRef>
-          <a:fontRef idx="minor">
-            <a:schemeClr val="tx1"/>
-          </a:fontRef>
-        </p:style>
-      </p:cxnSp>
-      <p:sp>
-        <p:nvSpPr>
-          <p:cNvPr id="13" name="TextBox 12"/>
-          <p:cNvSpPr txBox="1"/>
-          <p:nvPr/>
-        </p:nvSpPr>
-        <p:spPr>
-          <a:xfrm>
-            <a:off x="566928" y="5422392"/>
-            <a:ext cx="6309360" cy="274320"/>
-          </a:xfrm>
-          <a:prstGeom prst="rect">
-            <a:avLst/>
-          </a:prstGeom>
-          <a:noFill/>
-        </p:spPr>
-        <p:txBody>
-          <a:bodyPr wrap="square" anchor="t" lIns="0" rIns="0" tIns="0" bIns="0">
-            <a:spAutoFit/>
-          </a:bodyPr>
-          <a:lstStyle/>
-          <a:p>
-            <a:pPr algn="l">
-              <a:lnSpc>
-                <a:spcPct val="106000"/>
-              </a:lnSpc>
-              <a:spcBef>
-                <a:spcPts val="0"/>
-              </a:spcBef>
-              <a:spcAft>
-                <a:spcPts val="300"/>
-              </a:spcAft>
-            </a:pPr>
-            <a:r>
-              <a:rPr sz="1500" b="1" i="0">
-                <a:solidFill>
-                  <a:srgbClr val="322014"/>
-                </a:solidFill>
-                <a:latin typeface="Arial"/>
-              </a:rPr>
-              <a:t>Decision today, first savings inside 90 days</a:t>
-            </a:r>
-          </a:p>
-        </p:txBody>
-      </p:sp>
-      <p:sp>
-        <p:nvSpPr>
-          <p:cNvPr id="14" name="TextBox 13"/>
-          <p:cNvSpPr txBox="1"/>
-          <p:nvPr/>
-        </p:nvSpPr>
-        <p:spPr>
-          <a:xfrm>
-            <a:off x="566928" y="5760720"/>
-            <a:ext cx="6309360" cy="274320"/>
-          </a:xfrm>
-          <a:prstGeom prst="rect">
-            <a:avLst/>
-          </a:prstGeom>
-          <a:noFill/>
-        </p:spPr>
-        <p:txBody>
-          <a:bodyPr wrap="square" anchor="t" lIns="0" rIns="0" tIns="0" bIns="0">
-            <a:spAutoFit/>
-          </a:bodyPr>
-          <a:lstStyle/>
-          <a:p>
-            <a:pPr algn="l">
-              <a:lnSpc>
-                <a:spcPct val="106000"/>
-              </a:lnSpc>
-              <a:spcBef>
-                <a:spcPts val="0"/>
-              </a:spcBef>
-              <a:spcAft>
-                <a:spcPts val="300"/>
-              </a:spcAft>
-            </a:pPr>
-            <a:r>
-              <a:rPr sz="900" b="0" i="0">
-                <a:solidFill>
-                  <a:srgbClr val="322014"/>
-                </a:solidFill>
-                <a:latin typeface="Arial"/>
-              </a:rPr>
-              <a:t>Phase 1 needs no new capital and no new systems beyond an order-entry rule.</a:t>
-            </a:r>
-          </a:p>
-        </p:txBody>
-      </p:sp>
-      <p:sp>
-        <p:nvSpPr>
-          <p:cNvPr id="15" name="TextBox 14"/>
-          <p:cNvSpPr txBox="1"/>
-          <p:nvPr/>
-        </p:nvSpPr>
-        <p:spPr>
-          <a:xfrm>
-            <a:off x="7287768" y="1737360"/>
-            <a:ext cx="4336999" cy="274320"/>
-          </a:xfrm>
-          <a:prstGeom prst="rect">
-            <a:avLst/>
-          </a:prstGeom>
-          <a:noFill/>
-        </p:spPr>
-        <p:txBody>
-          <a:bodyPr wrap="square" anchor="t" lIns="0" rIns="0" tIns="0" bIns="0">
-            <a:spAutoFit/>
-          </a:bodyPr>
-          <a:lstStyle/>
-          <a:p>
-            <a:pPr algn="l">
-              <a:lnSpc>
-                <a:spcPct val="106000"/>
-              </a:lnSpc>
-              <a:spcBef>
-                <a:spcPts val="0"/>
-              </a:spcBef>
-              <a:spcAft>
-                <a:spcPts val="300"/>
-              </a:spcAft>
-            </a:pPr>
-            <a:r>
-              <a:rPr sz="1200" b="1" i="0">
-                <a:solidFill>
-                  <a:srgbClr val="5A3921"/>
-                </a:solidFill>
-                <a:latin typeface="Georgia"/>
-              </a:rPr>
-              <a:t>What the Board gets in return</a:t>
-            </a:r>
-          </a:p>
-        </p:txBody>
-      </p:sp>
-      <p:cxnSp>
-        <p:nvCxnSpPr>
-          <p:cNvPr id="16" name="Connector 15"/>
-          <p:cNvCxnSpPr/>
-          <p:nvPr/>
-        </p:nvCxnSpPr>
-        <p:spPr>
-          <a:xfrm>
-            <a:off x="7287768" y="2011680"/>
-            <a:ext cx="4336999" cy="0"/>
-          </a:xfrm>
-          <a:prstGeom prst="line">
-            <a:avLst/>
-          </a:prstGeom>
-          <a:ln w="19050">
-            <a:solidFill>
-              <a:srgbClr val="322014"/>
-            </a:solidFill>
-          </a:ln>
-        </p:spPr>
-        <p:style>
-          <a:lnRef idx="2">
-            <a:schemeClr val="accent1"/>
-          </a:lnRef>
-          <a:fillRef idx="0">
-            <a:schemeClr val="accent1"/>
-          </a:fillRef>
-          <a:effectRef idx="1">
-            <a:schemeClr val="accent1"/>
-          </a:effectRef>
-          <a:fontRef idx="minor">
-            <a:schemeClr val="tx1"/>
-          </a:fontRef>
-        </p:style>
-      </p:cxnSp>
-      <p:cxnSp>
-        <p:nvCxnSpPr>
-          <p:cNvPr id="17" name="Connector 16"/>
-          <p:cNvCxnSpPr/>
-          <p:nvPr/>
-        </p:nvCxnSpPr>
-        <p:spPr>
-          <a:xfrm>
-            <a:off x="7287768" y="2212848"/>
-            <a:ext cx="4336999" cy="0"/>
-          </a:xfrm>
-          <a:prstGeom prst="line">
-            <a:avLst/>
-          </a:prstGeom>
-          <a:ln w="19050">
-            <a:solidFill>
-              <a:srgbClr val="322014"/>
-            </a:solidFill>
-          </a:ln>
-        </p:spPr>
-        <p:style>
-          <a:lnRef idx="2">
-            <a:schemeClr val="accent1"/>
-          </a:lnRef>
-          <a:fillRef idx="0">
-            <a:schemeClr val="accent1"/>
-          </a:fillRef>
-          <a:effectRef idx="1">
-            <a:schemeClr val="accent1"/>
-          </a:effectRef>
-          <a:fontRef idx="minor">
-            <a:schemeClr val="tx1"/>
-          </a:fontRef>
-        </p:style>
-      </p:cxnSp>
-      <p:sp>
-        <p:nvSpPr>
-          <p:cNvPr id="18" name="TextBox 17"/>
-          <p:cNvSpPr txBox="1"/>
-          <p:nvPr/>
-        </p:nvSpPr>
-        <p:spPr>
-          <a:xfrm>
-            <a:off x="7287768" y="2267712"/>
-            <a:ext cx="4336999" cy="310896"/>
-          </a:xfrm>
-          <a:prstGeom prst="rect">
-            <a:avLst/>
-          </a:prstGeom>
-          <a:noFill/>
-        </p:spPr>
-        <p:txBody>
-          <a:bodyPr wrap="square" anchor="t" lIns="0" rIns="0" tIns="0" bIns="0">
-            <a:spAutoFit/>
-          </a:bodyPr>
-          <a:lstStyle/>
-          <a:p>
-            <a:pPr algn="l">
-              <a:lnSpc>
-                <a:spcPct val="106000"/>
-              </a:lnSpc>
-              <a:spcBef>
-                <a:spcPts val="0"/>
-              </a:spcBef>
-              <a:spcAft>
-                <a:spcPts val="300"/>
-              </a:spcAft>
-            </a:pPr>
-            <a:r>
-              <a:rPr sz="1500" b="1" i="0">
-                <a:solidFill>
-                  <a:srgbClr val="322014"/>
-                </a:solidFill>
-                <a:latin typeface="Arial"/>
-              </a:rPr>
-              <a:t>+$1.23M</a:t>
-            </a:r>
-          </a:p>
-        </p:txBody>
-      </p:sp>
-      <p:sp>
-        <p:nvSpPr>
-          <p:cNvPr id="19" name="TextBox 18"/>
-          <p:cNvSpPr txBox="1"/>
-          <p:nvPr/>
-        </p:nvSpPr>
-        <p:spPr>
-          <a:xfrm>
-            <a:off x="7287768" y="2578608"/>
-            <a:ext cx="4336999" cy="365760"/>
-          </a:xfrm>
-          <a:prstGeom prst="rect">
-            <a:avLst/>
-          </a:prstGeom>
-          <a:noFill/>
-        </p:spPr>
-        <p:txBody>
-          <a:bodyPr wrap="square" anchor="t" lIns="0" rIns="0" tIns="0" bIns="0">
-            <a:spAutoFit/>
-          </a:bodyPr>
-          <a:lstStyle/>
-          <a:p>
-            <a:pPr algn="l">
-              <a:lnSpc>
-                <a:spcPct val="108000"/>
-              </a:lnSpc>
-              <a:spcBef>
-                <a:spcPts val="0"/>
-              </a:spcBef>
-              <a:spcAft>
-                <a:spcPts val="300"/>
-              </a:spcAft>
-            </a:pPr>
-            <a:r>
-              <a:rPr sz="900" b="0" i="0">
-                <a:solidFill>
-                  <a:srgbClr val="322014"/>
-                </a:solidFill>
-                <a:latin typeface="Arial"/>
-              </a:rPr>
-              <a:t>Operating profit, full-ledger basis (+84% on $1.467M)</a:t>
-            </a:r>
-          </a:p>
-        </p:txBody>
-      </p:sp>
-      <p:cxnSp>
-        <p:nvCxnSpPr>
-          <p:cNvPr id="20" name="Connector 19"/>
-          <p:cNvCxnSpPr/>
-          <p:nvPr/>
-        </p:nvCxnSpPr>
-        <p:spPr>
-          <a:xfrm>
-            <a:off x="7287768" y="3538728"/>
-            <a:ext cx="4336999" cy="0"/>
-          </a:xfrm>
-          <a:prstGeom prst="line">
-            <a:avLst/>
-          </a:prstGeom>
-          <a:ln w="19050">
-            <a:solidFill>
-              <a:srgbClr val="322014"/>
-            </a:solidFill>
-          </a:ln>
-        </p:spPr>
-        <p:style>
-          <a:lnRef idx="2">
-            <a:schemeClr val="accent1"/>
-          </a:lnRef>
-          <a:fillRef idx="0">
-            <a:schemeClr val="accent1"/>
-          </a:fillRef>
-          <a:effectRef idx="1">
-            <a:schemeClr val="accent1"/>
-          </a:effectRef>
-          <a:fontRef idx="minor">
-            <a:schemeClr val="tx1"/>
-          </a:fontRef>
-        </p:style>
-      </p:cxnSp>
-      <p:sp>
-        <p:nvSpPr>
-          <p:cNvPr id="21" name="TextBox 20"/>
-          <p:cNvSpPr txBox="1"/>
-          <p:nvPr/>
-        </p:nvSpPr>
-        <p:spPr>
-          <a:xfrm>
-            <a:off x="7287768" y="3593592"/>
-            <a:ext cx="4336999" cy="310896"/>
-          </a:xfrm>
-          <a:prstGeom prst="rect">
-            <a:avLst/>
-          </a:prstGeom>
-          <a:noFill/>
-        </p:spPr>
-        <p:txBody>
-          <a:bodyPr wrap="square" anchor="t" lIns="0" rIns="0" tIns="0" bIns="0">
-            <a:spAutoFit/>
-          </a:bodyPr>
-          <a:lstStyle/>
-          <a:p>
-            <a:pPr algn="l">
-              <a:lnSpc>
-                <a:spcPct val="106000"/>
-              </a:lnSpc>
-              <a:spcBef>
-                <a:spcPts val="0"/>
-              </a:spcBef>
-              <a:spcAft>
-                <a:spcPts val="300"/>
-              </a:spcAft>
-            </a:pPr>
-            <a:r>
-              <a:rPr sz="1500" b="1" i="0">
-                <a:solidFill>
-                  <a:srgbClr val="322014"/>
-                </a:solidFill>
-                <a:latin typeface="Arial"/>
-              </a:rPr>
-              <a:t>19.9%</a:t>
-            </a:r>
-          </a:p>
-        </p:txBody>
-      </p:sp>
-      <p:sp>
-        <p:nvSpPr>
-          <p:cNvPr id="22" name="TextBox 21"/>
-          <p:cNvSpPr txBox="1"/>
-          <p:nvPr/>
-        </p:nvSpPr>
-        <p:spPr>
-          <a:xfrm>
-            <a:off x="7287768" y="3904488"/>
-            <a:ext cx="4336999" cy="365760"/>
-          </a:xfrm>
-          <a:prstGeom prst="rect">
-            <a:avLst/>
-          </a:prstGeom>
-          <a:noFill/>
-        </p:spPr>
-        <p:txBody>
-          <a:bodyPr wrap="square" anchor="t" lIns="0" rIns="0" tIns="0" bIns="0">
-            <a:spAutoFit/>
-          </a:bodyPr>
-          <a:lstStyle/>
-          <a:p>
-            <a:pPr algn="l">
-              <a:lnSpc>
-                <a:spcPct val="108000"/>
-              </a:lnSpc>
-              <a:spcBef>
-                <a:spcPts val="0"/>
-              </a:spcBef>
-              <a:spcAft>
-                <a:spcPts val="300"/>
-              </a:spcAft>
-            </a:pPr>
-            <a:r>
-              <a:rPr sz="900" b="0" i="0">
-                <a:solidFill>
-                  <a:srgbClr val="322014"/>
-                </a:solidFill>
-                <a:latin typeface="Arial"/>
-              </a:rPr>
-              <a:t>Operating margin, from 11.6% and above the 15.5% target</a:t>
-            </a:r>
-          </a:p>
-        </p:txBody>
-      </p:sp>
-      <p:cxnSp>
-        <p:nvCxnSpPr>
-          <p:cNvPr id="23" name="Connector 22"/>
-          <p:cNvCxnSpPr/>
-          <p:nvPr/>
-        </p:nvCxnSpPr>
-        <p:spPr>
-          <a:xfrm>
-            <a:off x="7287768" y="4864608"/>
-            <a:ext cx="4336999" cy="0"/>
-          </a:xfrm>
-          <a:prstGeom prst="line">
-            <a:avLst/>
-          </a:prstGeom>
-          <a:ln w="19050">
-            <a:solidFill>
-              <a:srgbClr val="322014"/>
-            </a:solidFill>
-          </a:ln>
-        </p:spPr>
-        <p:style>
-          <a:lnRef idx="2">
-            <a:schemeClr val="accent1"/>
-          </a:lnRef>
-          <a:fillRef idx="0">
-            <a:schemeClr val="accent1"/>
-          </a:fillRef>
-          <a:effectRef idx="1">
-            <a:schemeClr val="accent1"/>
-          </a:effectRef>
-          <a:fontRef idx="minor">
-            <a:schemeClr val="tx1"/>
-          </a:fontRef>
-        </p:style>
-      </p:cxnSp>
-      <p:sp>
-        <p:nvSpPr>
-          <p:cNvPr id="24" name="TextBox 23"/>
-          <p:cNvSpPr txBox="1"/>
-          <p:nvPr/>
-        </p:nvSpPr>
-        <p:spPr>
-          <a:xfrm>
-            <a:off x="7287768" y="4919472"/>
-            <a:ext cx="4336999" cy="310896"/>
-          </a:xfrm>
-          <a:prstGeom prst="rect">
-            <a:avLst/>
-          </a:prstGeom>
-          <a:noFill/>
-        </p:spPr>
-        <p:txBody>
-          <a:bodyPr wrap="square" anchor="t" lIns="0" rIns="0" tIns="0" bIns="0">
-            <a:spAutoFit/>
-          </a:bodyPr>
-          <a:lstStyle/>
-          <a:p>
-            <a:pPr algn="l">
-              <a:lnSpc>
-                <a:spcPct val="106000"/>
-              </a:lnSpc>
-              <a:spcBef>
-                <a:spcPts val="0"/>
-              </a:spcBef>
-              <a:spcAft>
-                <a:spcPts val="300"/>
-              </a:spcAft>
-            </a:pPr>
-            <a:r>
-              <a:rPr sz="1500" b="1" i="0">
-                <a:solidFill>
-                  <a:srgbClr val="322014"/>
-                </a:solidFill>
-                <a:latin typeface="Arial"/>
-              </a:rPr>
-              <a:t>$0</a:t>
-            </a:r>
-          </a:p>
-        </p:txBody>
-      </p:sp>
-      <p:sp>
-        <p:nvSpPr>
-          <p:cNvPr id="25" name="TextBox 24"/>
-          <p:cNvSpPr txBox="1"/>
-          <p:nvPr/>
-        </p:nvSpPr>
-        <p:spPr>
-          <a:xfrm>
-            <a:off x="7287768" y="5230368"/>
-            <a:ext cx="4336999" cy="365760"/>
-          </a:xfrm>
-          <a:prstGeom prst="rect">
-            <a:avLst/>
-          </a:prstGeom>
-          <a:noFill/>
-        </p:spPr>
-        <p:txBody>
-          <a:bodyPr wrap="square" anchor="t" lIns="0" rIns="0" tIns="0" bIns="0">
-            <a:spAutoFit/>
-          </a:bodyPr>
-          <a:lstStyle/>
-          <a:p>
-            <a:pPr algn="l">
-              <a:lnSpc>
-                <a:spcPct val="108000"/>
-              </a:lnSpc>
-              <a:spcBef>
-                <a:spcPts val="0"/>
-              </a:spcBef>
-              <a:spcAft>
-                <a:spcPts val="300"/>
-              </a:spcAft>
-            </a:pPr>
-            <a:r>
-              <a:rPr sz="900" b="0" i="0">
-                <a:solidFill>
-                  <a:srgbClr val="322014"/>
-                </a:solidFill>
-                <a:latin typeface="Arial"/>
-              </a:rPr>
-              <a:t>New capital spend required; Phase 1 is an order-entry rule</a:t>
-            </a:r>
-          </a:p>
-        </p:txBody>
-      </p:sp>
-      <p:sp>
-        <p:nvSpPr>
-          <p:cNvPr id="26" name="TextBox 25"/>
-          <p:cNvSpPr txBox="1"/>
-          <p:nvPr/>
-        </p:nvSpPr>
-        <p:spPr>
-          <a:xfrm>
-            <a:off x="566928" y="6099048"/>
-            <a:ext cx="11057839" cy="237744"/>
-          </a:xfrm>
-          <a:prstGeom prst="rect">
-            <a:avLst/>
-          </a:prstGeom>
-          <a:noFill/>
-        </p:spPr>
-        <p:txBody>
-          <a:bodyPr wrap="square" anchor="t" lIns="0" rIns="0" tIns="0" bIns="0">
-            <a:spAutoFit/>
-          </a:bodyPr>
-          <a:lstStyle/>
-          <a:p>
-            <a:pPr algn="l">
-              <a:lnSpc>
-                <a:spcPct val="105000"/>
-              </a:lnSpc>
-              <a:spcBef>
-                <a:spcPts val="0"/>
-              </a:spcBef>
-              <a:spcAft>
-                <a:spcPts val="300"/>
-              </a:spcAft>
-            </a:pPr>
-            <a:r>
-              <a:rPr sz="750" b="0" i="0">
-                <a:solidFill>
-                  <a:srgbClr val="8A7B6B"/>
-                </a:solidFill>
-                <a:latin typeface="Arial"/>
-              </a:rPr>
-              <a:t>Source: base-case simulation on the FY2011-FY2014 ledger. Returns are on the four-year ledger basis and depend on the 5% churn assumption holding. Modelling estimate, not a forecast.</a:t>
-            </a:r>
-          </a:p>
-        </p:txBody>
-      </p:sp>
-      <p:pic>
-        <p:nvPicPr>
-          <p:cNvPr id="27" name="Picture 26" descr="gavel_check.png"/>
-          <p:cNvPicPr>
-            <a:picLocks noChangeAspect="1"/>
-          </p:cNvPicPr>
-          <p:nvPr/>
-        </p:nvPicPr>
-        <p:blipFill>
-          <a:blip r:embed="rId2"/>
-          <a:stretch>
-            <a:fillRect/>
-          </a:stretch>
-        </p:blipFill>
-        <p:spPr>
-          <a:xfrm>
-            <a:off x="4069080" y="3639312"/>
-            <a:ext cx="2743200" cy="1481328"/>
-          </a:xfrm>
-          <a:prstGeom prst="rect">
-            <a:avLst/>
-          </a:prstGeom>
-        </p:spPr>
-      </p:pic>
-    </p:spTree>
-  </p:cSld>
-  <p:clrMapOvr>
-    <a:masterClrMapping/>
-  </p:clrMapOvr>
-</p:sld>
-</file>
-
-<file path=ppt/slides/slide17.xml><?xml version="1.0" encoding="utf-8"?>
-<p:sld xmlns:a="http://schemas.openxmlformats.org/drawingml/2006/main" xmlns:p="http://schemas.openxmlformats.org/presentationml/2006/main" xmlns:r="http://schemas.openxmlformats.org/officeDocument/2006/relationships">
-  <p:cSld>
-    <p:spTree>
-      <p:nvGrpSpPr>
-        <p:cNvPr id="1" name=""/>
-        <p:cNvGrpSpPr/>
-        <p:nvPr/>
-      </p:nvGrpSpPr>
-      <p:grpSpPr/>
-      <p:pic>
-        <p:nvPicPr>
-          <p:cNvPr id="11" name="Sea Background Photo" descr="sea_bg.jpg"/>
-          <p:cNvPicPr>
-            <a:picLocks noChangeAspect="1"/>
-          </p:cNvPicPr>
-          <p:nvPr/>
-        </p:nvPicPr>
-        <p:blipFill>
-          <a:blip r:embed="rId3"/>
-          <a:stretch>
-            <a:fillRect/>
-          </a:stretch>
-        </p:blipFill>
-        <p:spPr>
-          <a:xfrm>
-            <a:off x="0" y="0"/>
-            <a:ext cx="12191695" cy="6858000"/>
-          </a:xfrm>
-          <a:prstGeom prst="rect">
-            <a:avLst/>
-          </a:prstGeom>
-        </p:spPr>
-      </p:pic>
-      <p:sp>
-        <p:nvSpPr>
-          <p:cNvPr id="2" name="TextBox 1"/>
-          <p:cNvSpPr txBox="1"/>
-          <p:nvPr/>
-        </p:nvSpPr>
-        <p:spPr>
-          <a:xfrm>
-            <a:off x="566928" y="310896"/>
-            <a:ext cx="5486400" cy="310896"/>
-          </a:xfrm>
-          <a:prstGeom prst="rect">
-            <a:avLst/>
-          </a:prstGeom>
-          <a:noFill/>
-        </p:spPr>
-        <p:txBody>
-          <a:bodyPr wrap="square" anchor="t" lIns="0" rIns="0" tIns="0" bIns="0">
-            <a:spAutoFit/>
-          </a:bodyPr>
-          <a:lstStyle/>
-          <a:p>
-            <a:pPr algn="l">
-              <a:lnSpc>
-                <a:spcPct val="106000"/>
-              </a:lnSpc>
-              <a:spcBef>
-                <a:spcPts val="0"/>
-              </a:spcBef>
-              <a:spcAft>
-                <a:spcPts val="300"/>
-              </a:spcAft>
-            </a:pPr>
-            <a:r>
-              <a:rPr sz="1800" b="1" i="0">
-                <a:solidFill>
-                  <a:srgbClr val="322014"/>
-                </a:solidFill>
-                <a:latin typeface="Georgia"/>
-              </a:rPr>
-              <a:t>Global Superstore</a:t>
-            </a:r>
-          </a:p>
-        </p:txBody>
-      </p:sp>
-      <p:sp>
-        <p:nvSpPr>
-          <p:cNvPr id="3" name="TextBox 2"/>
-          <p:cNvSpPr txBox="1"/>
-          <p:nvPr/>
-        </p:nvSpPr>
-        <p:spPr>
-          <a:xfrm>
-            <a:off x="7784287" y="429768"/>
-            <a:ext cx="3840480" cy="219456"/>
-          </a:xfrm>
-          <a:prstGeom prst="rect">
-            <a:avLst/>
-          </a:prstGeom>
-          <a:noFill/>
-        </p:spPr>
-        <p:txBody>
-          <a:bodyPr wrap="square" anchor="t" lIns="0" rIns="0" tIns="0" bIns="0">
-            <a:spAutoFit/>
-          </a:bodyPr>
-          <a:lstStyle/>
-          <a:p>
-            <a:pPr algn="r">
-              <a:lnSpc>
-                <a:spcPct val="106000"/>
-              </a:lnSpc>
-              <a:spcBef>
-                <a:spcPts val="0"/>
-              </a:spcBef>
-              <a:spcAft>
-                <a:spcPts val="300"/>
-              </a:spcAft>
-            </a:pPr>
-            <a:r>
-              <a:rPr sz="750" b="1" i="0">
-                <a:solidFill>
-                  <a:srgbClr val="8A7B6B"/>
-                </a:solidFill>
-                <a:latin typeface="Arial"/>
-              </a:rPr>
-              <a:t>Revival Strategy</a:t>
-            </a:r>
-          </a:p>
-        </p:txBody>
-      </p:sp>
-      <p:cxnSp>
-        <p:nvCxnSpPr>
-          <p:cNvPr id="4" name="Connector 3"/>
-          <p:cNvCxnSpPr/>
-          <p:nvPr/>
-        </p:nvCxnSpPr>
-        <p:spPr>
-          <a:xfrm>
-            <a:off x="566928" y="658368"/>
-            <a:ext cx="11057839" cy="0"/>
-          </a:xfrm>
-          <a:prstGeom prst="line">
-            <a:avLst/>
-          </a:prstGeom>
-          <a:ln w="12700">
-            <a:solidFill>
-              <a:srgbClr val="322014"/>
-            </a:solidFill>
-          </a:ln>
-        </p:spPr>
-        <p:style>
-          <a:lnRef idx="2">
-            <a:schemeClr val="accent1"/>
-          </a:lnRef>
-          <a:fillRef idx="0">
-            <a:schemeClr val="accent1"/>
-          </a:fillRef>
-          <a:effectRef idx="1">
-            <a:schemeClr val="accent1"/>
-          </a:effectRef>
-          <a:fontRef idx="minor">
-            <a:schemeClr val="tx1"/>
-          </a:fontRef>
-        </p:style>
-      </p:cxnSp>
-      <p:sp>
-        <p:nvSpPr>
-          <p:cNvPr id="5" name="TextBox 4"/>
-          <p:cNvSpPr txBox="1"/>
-          <p:nvPr/>
-        </p:nvSpPr>
-        <p:spPr>
-          <a:xfrm>
-            <a:off x="566928" y="2560320"/>
-            <a:ext cx="9399163" cy="1097280"/>
-          </a:xfrm>
-          <a:prstGeom prst="rect">
-            <a:avLst/>
-          </a:prstGeom>
-          <a:noFill/>
-        </p:spPr>
-        <p:txBody>
-          <a:bodyPr wrap="square" anchor="t" lIns="0" rIns="0" tIns="0" bIns="0">
-            <a:spAutoFit/>
-          </a:bodyPr>
-          <a:lstStyle/>
-          <a:p>
-            <a:pPr algn="ctr">
-              <a:lnSpc>
-                <a:spcPct val="120000"/>
-              </a:lnSpc>
-              <a:spcBef>
-                <a:spcPts val="0"/>
-              </a:spcBef>
-              <a:spcAft>
-                <a:spcPts val="300"/>
-              </a:spcAft>
-            </a:pPr>
-            <a:r>
-              <a:rPr sz="2000" b="1" i="0">
-                <a:solidFill>
-                  <a:srgbClr val="322014"/>
-                </a:solidFill>
-                <a:latin typeface="Georgia"/>
-              </a:rPr>
-              <a:t>“Beware of little expenses; a small leak will sink a great ship.”</a:t>
-            </a:r>
-          </a:p>
-        </p:txBody>
-      </p:sp>
-      <p:sp>
-        <p:nvSpPr>
-          <p:cNvPr id="6" name="TextBox 5"/>
-          <p:cNvSpPr txBox="1"/>
-          <p:nvPr/>
-        </p:nvSpPr>
-        <p:spPr>
-          <a:xfrm>
-            <a:off x="566928" y="3840480"/>
-            <a:ext cx="9399163" cy="365760"/>
-          </a:xfrm>
-          <a:prstGeom prst="rect">
-            <a:avLst/>
-          </a:prstGeom>
-          <a:noFill/>
-        </p:spPr>
-        <p:txBody>
-          <a:bodyPr wrap="square" anchor="t" lIns="0" rIns="0" tIns="0" bIns="0">
-            <a:spAutoFit/>
-          </a:bodyPr>
-          <a:lstStyle/>
-          <a:p>
-            <a:pPr algn="ctr">
-              <a:lnSpc>
-                <a:spcPct val="106000"/>
-              </a:lnSpc>
-              <a:spcBef>
-                <a:spcPts val="0"/>
-              </a:spcBef>
-              <a:spcAft>
-                <a:spcPts val="300"/>
-              </a:spcAft>
-            </a:pPr>
-            <a:r>
-              <a:rPr sz="1400" b="1" i="0">
-                <a:solidFill>
-                  <a:srgbClr val="8A7B6B"/>
-                </a:solidFill>
-                <a:latin typeface="Georgia"/>
-              </a:rPr>
-              <a:t>Benjamin Franklin</a:t>
-            </a:r>
-          </a:p>
-        </p:txBody>
-      </p:sp>
-      <p:sp>
-        <p:nvSpPr>
-          <p:cNvPr id="7" name="TextBox 6"/>
-          <p:cNvSpPr txBox="1"/>
-          <p:nvPr/>
-        </p:nvSpPr>
-        <p:spPr>
-          <a:xfrm>
-            <a:off x="566928" y="4389120"/>
-            <a:ext cx="9399163" cy="365760"/>
-          </a:xfrm>
-          <a:prstGeom prst="rect">
-            <a:avLst/>
-          </a:prstGeom>
-          <a:noFill/>
-        </p:spPr>
-        <p:txBody>
-          <a:bodyPr wrap="square" anchor="t" lIns="0" rIns="0" tIns="0" bIns="0">
-            <a:spAutoFit/>
-          </a:bodyPr>
-          <a:lstStyle/>
-          <a:p>
-            <a:pPr algn="ctr">
-              <a:lnSpc>
-                <a:spcPct val="106000"/>
-              </a:lnSpc>
-              <a:spcBef>
-                <a:spcPts val="0"/>
-              </a:spcBef>
-              <a:spcAft>
-                <a:spcPts val="300"/>
-              </a:spcAft>
-            </a:pPr>
-            <a:r>
-              <a:rPr sz="1500" b="1" i="0">
-                <a:solidFill>
-                  <a:srgbClr val="5A3921"/>
-                </a:solidFill>
-                <a:latin typeface="Georgia"/>
-              </a:rPr>
-              <a:t>Prepared for the Board of Directors</a:t>
-            </a:r>
-          </a:p>
-        </p:txBody>
-      </p:sp>
-      <p:cxnSp>
-        <p:nvCxnSpPr>
-          <p:cNvPr id="8" name="Connector 7"/>
-          <p:cNvCxnSpPr/>
-          <p:nvPr/>
-        </p:nvCxnSpPr>
-        <p:spPr>
-          <a:xfrm>
-            <a:off x="566928" y="6355080"/>
-            <a:ext cx="11057839" cy="0"/>
-          </a:xfrm>
-          <a:prstGeom prst="line">
-            <a:avLst/>
-          </a:prstGeom>
-          <a:ln w="9525">
-            <a:solidFill>
-              <a:srgbClr val="C5A681"/>
-            </a:solidFill>
-          </a:ln>
-        </p:spPr>
-        <p:style>
-          <a:lnRef idx="2">
-            <a:schemeClr val="accent1"/>
-          </a:lnRef>
-          <a:fillRef idx="0">
-            <a:schemeClr val="accent1"/>
-          </a:fillRef>
-          <a:effectRef idx="1">
-            <a:schemeClr val="accent1"/>
-          </a:effectRef>
-          <a:fontRef idx="minor">
-            <a:schemeClr val="tx1"/>
-          </a:fontRef>
-        </p:style>
-      </p:cxnSp>
-      <p:sp>
-        <p:nvSpPr>
-          <p:cNvPr id="9" name="TextBox 8"/>
-          <p:cNvSpPr txBox="1"/>
-          <p:nvPr/>
-        </p:nvSpPr>
-        <p:spPr>
-          <a:xfrm>
-            <a:off x="566928" y="6400800"/>
-            <a:ext cx="7740487" cy="219456"/>
-          </a:xfrm>
-          <a:prstGeom prst="rect">
-            <a:avLst/>
-          </a:prstGeom>
-          <a:noFill/>
-        </p:spPr>
-        <p:txBody>
-          <a:bodyPr wrap="square" anchor="t" lIns="0" rIns="0" tIns="0" bIns="0">
-            <a:spAutoFit/>
-          </a:bodyPr>
-          <a:lstStyle/>
-          <a:p>
-            <a:pPr algn="l">
-              <a:lnSpc>
-                <a:spcPct val="106000"/>
-              </a:lnSpc>
-              <a:spcBef>
-                <a:spcPts val="0"/>
-              </a:spcBef>
-              <a:spcAft>
-                <a:spcPts val="300"/>
-              </a:spcAft>
-            </a:pPr>
-            <a:r>
-              <a:rPr sz="850" b="1" i="0">
-                <a:solidFill>
-                  <a:srgbClr val="322014"/>
-                </a:solidFill>
-                <a:latin typeface="Arial"/>
-              </a:rPr>
-              <a:t>Global Superstore · Revival Strategy</a:t>
-            </a:r>
-          </a:p>
-        </p:txBody>
-      </p:sp>
-      <p:sp>
-        <p:nvSpPr>
-          <p:cNvPr id="10" name="TextBox 9"/>
-          <p:cNvSpPr txBox="1"/>
-          <p:nvPr/>
-        </p:nvSpPr>
-        <p:spPr>
-          <a:xfrm>
-            <a:off x="566928" y="5623560"/>
-            <a:ext cx="11057839" cy="274320"/>
-          </a:xfrm>
-          <a:prstGeom prst="rect">
-            <a:avLst/>
-          </a:prstGeom>
-          <a:noFill/>
-        </p:spPr>
-        <p:txBody>
-          <a:bodyPr wrap="square" anchor="t" lIns="0" rIns="0" tIns="0" bIns="0">
-            <a:spAutoFit/>
-          </a:bodyPr>
-          <a:lstStyle/>
-          <a:p>
-            <a:pPr algn="l">
-              <a:lnSpc>
-                <a:spcPct val="106000"/>
-              </a:lnSpc>
-              <a:spcBef>
-                <a:spcPts val="0"/>
-              </a:spcBef>
-              <a:spcAft>
-                <a:spcPts val="300"/>
-              </a:spcAft>
-            </a:pPr>
-            <a:r>
-              <a:rPr sz="800" b="0" i="0">
-                <a:solidFill>
-                  <a:srgbClr val="8A7B6B"/>
-                </a:solidFill>
-                <a:latin typeface="Arial"/>
-              </a:rPr>
-              <a:t>Source data: Global Superstore transaction ledger, FY2011-FY2014 (51,290 order lines). Deck produced with consulting-pptx-skill (github.com/carnot-tech/consulting-pptx-skill).</a:t>
-            </a:r>
-          </a:p>
-        </p:txBody>
-      </p:sp>
-    </p:spTree>
-  </p:cSld>
-  <p:clrMapOvr>
-    <a:masterClrMapping/>
-  </p:clrMapOvr>
-</p:sld>
-</file>
-
-<file path=ppt/slides/slide18.xml><?xml version="1.0" encoding="utf-8"?>
-<p:sld xmlns:a="http://schemas.openxmlformats.org/drawingml/2006/main" xmlns:p="http://schemas.openxmlformats.org/presentationml/2006/main" xmlns:r="http://schemas.openxmlformats.org/officeDocument/2006/relationships">
-  <p:cSld>
-    <p:spTree>
-      <p:nvGrpSpPr>
-        <p:cNvPr id="1" name=""/>
-        <p:cNvGrpSpPr/>
-        <p:nvPr/>
-      </p:nvGrpSpPr>
-      <p:grpSpPr/>
-      <p:sp>
-        <p:nvSpPr>
-          <p:cNvPr id="2" name="TextBox 1"/>
-          <p:cNvSpPr txBox="1"/>
-          <p:nvPr/>
-        </p:nvSpPr>
-        <p:spPr>
-          <a:xfrm>
-            <a:off x="566928" y="310896"/>
-            <a:ext cx="6634703" cy="310896"/>
-          </a:xfrm>
-          <a:prstGeom prst="rect">
-            <a:avLst/>
-          </a:prstGeom>
-          <a:noFill/>
-        </p:spPr>
-        <p:txBody>
-          <a:bodyPr wrap="square" anchor="t" lIns="0" rIns="0" tIns="0" bIns="0">
-            <a:spAutoFit/>
-          </a:bodyPr>
-          <a:lstStyle/>
-          <a:p>
-            <a:pPr algn="l">
-              <a:lnSpc>
-                <a:spcPct val="106000"/>
-              </a:lnSpc>
-              <a:spcBef>
-                <a:spcPts val="0"/>
-              </a:spcBef>
-              <a:spcAft>
-                <a:spcPts val="300"/>
-              </a:spcAft>
-            </a:pPr>
-            <a:r>
-              <a:rPr sz="1800" b="1" i="0">
-                <a:solidFill>
-                  <a:srgbClr val="322014"/>
-                </a:solidFill>
-                <a:latin typeface="Georgia"/>
-              </a:rPr>
-              <a:t>Global Superstore · Revival Strategy</a:t>
-            </a:r>
-          </a:p>
-        </p:txBody>
-      </p:sp>
-      <p:sp>
-        <p:nvSpPr>
-          <p:cNvPr id="3" name="TextBox 2"/>
-          <p:cNvSpPr txBox="1"/>
-          <p:nvPr/>
-        </p:nvSpPr>
-        <p:spPr>
-          <a:xfrm>
-            <a:off x="7784287" y="429768"/>
-            <a:ext cx="3840480" cy="219456"/>
-          </a:xfrm>
-          <a:prstGeom prst="rect">
-            <a:avLst/>
-          </a:prstGeom>
-          <a:noFill/>
-        </p:spPr>
-        <p:txBody>
-          <a:bodyPr wrap="square" anchor="t" lIns="0" rIns="0" tIns="0" bIns="0">
-            <a:spAutoFit/>
-          </a:bodyPr>
-          <a:lstStyle/>
-          <a:p>
-            <a:pPr algn="r">
-              <a:lnSpc>
-                <a:spcPct val="106000"/>
-              </a:lnSpc>
-              <a:spcBef>
-                <a:spcPts val="0"/>
-              </a:spcBef>
-              <a:spcAft>
-                <a:spcPts val="300"/>
-              </a:spcAft>
-            </a:pPr>
-            <a:r>
-              <a:rPr sz="750" b="1" i="0">
-                <a:solidFill>
-                  <a:srgbClr val="8A7B6B"/>
-                </a:solidFill>
-                <a:latin typeface="Arial"/>
-              </a:rPr>
               <a:t>What's next</a:t>
             </a:r>
           </a:p>
@@ -18067,7 +16571,7 @@
 </p:sld>
 </file>
 
-<file path=ppt/slides/slide2.xml><?xml version="1.0" encoding="utf-8"?>
+<file path=ppt/slides/slide17.xml><?xml version="1.0" encoding="utf-8"?>
 <p:sld xmlns:a="http://schemas.openxmlformats.org/drawingml/2006/main" xmlns:p="http://schemas.openxmlformats.org/presentationml/2006/main" xmlns:r="http://schemas.openxmlformats.org/officeDocument/2006/relationships">
   <p:cSld>
     <p:spTree>
@@ -18162,7 +16666,7 @@
                 </a:solidFill>
                 <a:latin typeface="Arial"/>
               </a:rPr>
-              <a:t>Executive summary</a:t>
+              <a:t>Board decision</a:t>
             </a:r>
           </a:p>
         </p:txBody>
@@ -18322,6 +16826,1597 @@
                 </a:solidFill>
                 <a:latin typeface="Arial"/>
               </a:rPr>
+              <a:t>16</a:t>
+            </a:r>
+          </a:p>
+        </p:txBody>
+      </p:sp>
+      <p:sp>
+        <p:nvSpPr>
+          <p:cNvPr id="8" name="TextBox 7"/>
+          <p:cNvSpPr txBox="1"/>
+          <p:nvPr/>
+        </p:nvSpPr>
+        <p:spPr>
+          <a:xfrm>
+            <a:off x="566928" y="731520"/>
+            <a:ext cx="11057839" cy="640080"/>
+          </a:xfrm>
+          <a:prstGeom prst="rect">
+            <a:avLst/>
+          </a:prstGeom>
+          <a:noFill/>
+        </p:spPr>
+        <p:txBody>
+          <a:bodyPr wrap="square" anchor="t" lIns="0" rIns="0" tIns="0" bIns="0">
+            <a:spAutoFit/>
+          </a:bodyPr>
+          <a:lstStyle/>
+          <a:p>
+            <a:pPr algn="l">
+              <a:lnSpc>
+                <a:spcPct val="102000"/>
+              </a:lnSpc>
+              <a:spcBef>
+                <a:spcPts val="0"/>
+              </a:spcBef>
+              <a:spcAft>
+                <a:spcPts val="300"/>
+              </a:spcAft>
+            </a:pPr>
+            <a:r>
+              <a:rPr sz="2200" b="1" i="0">
+                <a:solidFill>
+                  <a:srgbClr val="322014"/>
+                </a:solidFill>
+                <a:latin typeface="Georgia"/>
+              </a:rPr>
+              <a:t>The Board must approve the 20% discount cap and 3PL restructuring this quarter</a:t>
+            </a:r>
+          </a:p>
+        </p:txBody>
+      </p:sp>
+      <p:sp>
+        <p:nvSpPr>
+          <p:cNvPr id="9" name="TextBox 8"/>
+          <p:cNvSpPr txBox="1"/>
+          <p:nvPr/>
+        </p:nvSpPr>
+        <p:spPr>
+          <a:xfrm>
+            <a:off x="566928" y="1737360"/>
+            <a:ext cx="6400800" cy="274320"/>
+          </a:xfrm>
+          <a:prstGeom prst="rect">
+            <a:avLst/>
+          </a:prstGeom>
+          <a:noFill/>
+        </p:spPr>
+        <p:txBody>
+          <a:bodyPr wrap="square" anchor="t" lIns="0" rIns="0" tIns="0" bIns="0">
+            <a:spAutoFit/>
+          </a:bodyPr>
+          <a:lstStyle/>
+          <a:p>
+            <a:pPr algn="l">
+              <a:lnSpc>
+                <a:spcPct val="106000"/>
+              </a:lnSpc>
+              <a:spcBef>
+                <a:spcPts val="0"/>
+              </a:spcBef>
+              <a:spcAft>
+                <a:spcPts val="300"/>
+              </a:spcAft>
+            </a:pPr>
+            <a:r>
+              <a:rPr sz="1200" b="1" i="0">
+                <a:solidFill>
+                  <a:srgbClr val="5A3921"/>
+                </a:solidFill>
+                <a:latin typeface="Georgia"/>
+              </a:rPr>
+              <a:t>Three decisions requested</a:t>
+            </a:r>
+          </a:p>
+        </p:txBody>
+      </p:sp>
+      <p:cxnSp>
+        <p:nvCxnSpPr>
+          <p:cNvPr id="10" name="Connector 9"/>
+          <p:cNvCxnSpPr/>
+          <p:nvPr/>
+        </p:nvCxnSpPr>
+        <p:spPr>
+          <a:xfrm>
+            <a:off x="566928" y="2011680"/>
+            <a:ext cx="6400800" cy="0"/>
+          </a:xfrm>
+          <a:prstGeom prst="line">
+            <a:avLst/>
+          </a:prstGeom>
+          <a:ln w="19050">
+            <a:solidFill>
+              <a:srgbClr val="322014"/>
+            </a:solidFill>
+          </a:ln>
+        </p:spPr>
+        <p:style>
+          <a:lnRef idx="2">
+            <a:schemeClr val="accent1"/>
+          </a:lnRef>
+          <a:fillRef idx="0">
+            <a:schemeClr val="accent1"/>
+          </a:fillRef>
+          <a:effectRef idx="1">
+            <a:schemeClr val="accent1"/>
+          </a:effectRef>
+          <a:fontRef idx="minor">
+            <a:schemeClr val="tx1"/>
+          </a:fontRef>
+        </p:style>
+      </p:cxnSp>
+      <p:sp>
+        <p:nvSpPr>
+          <p:cNvPr id="11" name="TextBox 10"/>
+          <p:cNvSpPr txBox="1"/>
+          <p:nvPr/>
+        </p:nvSpPr>
+        <p:spPr>
+          <a:xfrm>
+            <a:off x="566928" y="2194560"/>
+            <a:ext cx="6309360" cy="2926080"/>
+          </a:xfrm>
+          <a:prstGeom prst="rect">
+            <a:avLst/>
+          </a:prstGeom>
+          <a:noFill/>
+        </p:spPr>
+        <p:txBody>
+          <a:bodyPr wrap="square" anchor="t" lIns="0" rIns="0" tIns="0" bIns="0">
+            <a:spAutoFit/>
+          </a:bodyPr>
+          <a:lstStyle/>
+          <a:p>
+            <a:pPr algn="l" marL="155448" indent="-155448">
+              <a:lnSpc>
+                <a:spcPct val="114000"/>
+              </a:lnSpc>
+              <a:spcBef>
+                <a:spcPts val="0"/>
+              </a:spcBef>
+              <a:spcAft>
+                <a:spcPts val="1200"/>
+              </a:spcAft>
+              <a:buFont typeface="Arial"/>
+              <a:buChar char="•"/>
+            </a:pPr>
+            <a:r>
+              <a:rPr sz="1100" b="1" i="0">
+                <a:solidFill>
+                  <a:srgbClr val="322014"/>
+                </a:solidFill>
+                <a:latin typeface="Arial"/>
+              </a:rPr>
+              <a:t>Approve the 20% discount cap</a:t>
+            </a:r>
+            <a:r>
+              <a:rPr sz="1100" b="0" i="0">
+                <a:solidFill>
+                  <a:srgbClr val="322014"/>
+                </a:solidFill>
+                <a:latin typeface="Arial"/>
+              </a:rPr>
+              <a:t> in order entry, with VP sign-off for discounts between 15% and 20% and a hard block above 20%.</a:t>
+            </a:r>
+          </a:p>
+          <a:p>
+            <a:pPr algn="l" marL="155448" indent="-155448">
+              <a:lnSpc>
+                <a:spcPct val="114000"/>
+              </a:lnSpc>
+              <a:spcBef>
+                <a:spcPts val="0"/>
+              </a:spcBef>
+              <a:spcAft>
+                <a:spcPts val="1200"/>
+              </a:spcAft>
+              <a:buFont typeface="Arial"/>
+              <a:buChar char="•"/>
+            </a:pPr>
+            <a:r>
+              <a:rPr sz="1100" b="1" i="0">
+                <a:solidFill>
+                  <a:srgbClr val="322014"/>
+                </a:solidFill>
+                <a:latin typeface="Arial"/>
+              </a:rPr>
+              <a:t>Authorise the 3PL transition</a:t>
+            </a:r>
+            <a:r>
+              <a:rPr sz="1100" b="0" i="0">
+                <a:solidFill>
+                  <a:srgbClr val="322014"/>
+                </a:solidFill>
+                <a:latin typeface="Arial"/>
+              </a:rPr>
+              <a:t> for Turkey and Nigeria to remove the cross-border loss.</a:t>
+            </a:r>
+          </a:p>
+          <a:p>
+            <a:pPr algn="l" marL="155448" indent="-155448">
+              <a:lnSpc>
+                <a:spcPct val="114000"/>
+              </a:lnSpc>
+              <a:spcBef>
+                <a:spcPts val="0"/>
+              </a:spcBef>
+              <a:spcAft>
+                <a:spcPts val="300"/>
+              </a:spcAft>
+              <a:buFont typeface="Arial"/>
+              <a:buChar char="•"/>
+            </a:pPr>
+            <a:r>
+              <a:rPr sz="1100" b="1" i="0">
+                <a:solidFill>
+                  <a:srgbClr val="322014"/>
+                </a:solidFill>
+                <a:latin typeface="Arial"/>
+              </a:rPr>
+              <a:t>Charter a margin committee</a:t>
+            </a:r>
+            <a:r>
+              <a:rPr sz="1100" b="0" i="0">
+                <a:solidFill>
+                  <a:srgbClr val="322014"/>
+                </a:solidFill>
+                <a:latin typeface="Arial"/>
+              </a:rPr>
+              <a:t> chaired by the CFO to review discount leakage and Tables margin every quarter.</a:t>
+            </a:r>
+          </a:p>
+        </p:txBody>
+      </p:sp>
+      <p:cxnSp>
+        <p:nvCxnSpPr>
+          <p:cNvPr id="12" name="Connector 11"/>
+          <p:cNvCxnSpPr/>
+          <p:nvPr/>
+        </p:nvCxnSpPr>
+        <p:spPr>
+          <a:xfrm>
+            <a:off x="566928" y="5349240"/>
+            <a:ext cx="6309360" cy="0"/>
+          </a:xfrm>
+          <a:prstGeom prst="line">
+            <a:avLst/>
+          </a:prstGeom>
+          <a:ln w="19050">
+            <a:solidFill>
+              <a:srgbClr val="322014"/>
+            </a:solidFill>
+          </a:ln>
+        </p:spPr>
+        <p:style>
+          <a:lnRef idx="2">
+            <a:schemeClr val="accent1"/>
+          </a:lnRef>
+          <a:fillRef idx="0">
+            <a:schemeClr val="accent1"/>
+          </a:fillRef>
+          <a:effectRef idx="1">
+            <a:schemeClr val="accent1"/>
+          </a:effectRef>
+          <a:fontRef idx="minor">
+            <a:schemeClr val="tx1"/>
+          </a:fontRef>
+        </p:style>
+      </p:cxnSp>
+      <p:sp>
+        <p:nvSpPr>
+          <p:cNvPr id="13" name="TextBox 12"/>
+          <p:cNvSpPr txBox="1"/>
+          <p:nvPr/>
+        </p:nvSpPr>
+        <p:spPr>
+          <a:xfrm>
+            <a:off x="566928" y="5422392"/>
+            <a:ext cx="6309360" cy="274320"/>
+          </a:xfrm>
+          <a:prstGeom prst="rect">
+            <a:avLst/>
+          </a:prstGeom>
+          <a:noFill/>
+        </p:spPr>
+        <p:txBody>
+          <a:bodyPr wrap="square" anchor="t" lIns="0" rIns="0" tIns="0" bIns="0">
+            <a:spAutoFit/>
+          </a:bodyPr>
+          <a:lstStyle/>
+          <a:p>
+            <a:pPr algn="l">
+              <a:lnSpc>
+                <a:spcPct val="106000"/>
+              </a:lnSpc>
+              <a:spcBef>
+                <a:spcPts val="0"/>
+              </a:spcBef>
+              <a:spcAft>
+                <a:spcPts val="300"/>
+              </a:spcAft>
+            </a:pPr>
+            <a:r>
+              <a:rPr sz="1500" b="1" i="0">
+                <a:solidFill>
+                  <a:srgbClr val="322014"/>
+                </a:solidFill>
+                <a:latin typeface="Arial"/>
+              </a:rPr>
+              <a:t>Decision today, first savings inside 90 days</a:t>
+            </a:r>
+          </a:p>
+        </p:txBody>
+      </p:sp>
+      <p:sp>
+        <p:nvSpPr>
+          <p:cNvPr id="14" name="TextBox 13"/>
+          <p:cNvSpPr txBox="1"/>
+          <p:nvPr/>
+        </p:nvSpPr>
+        <p:spPr>
+          <a:xfrm>
+            <a:off x="566928" y="5760720"/>
+            <a:ext cx="6309360" cy="274320"/>
+          </a:xfrm>
+          <a:prstGeom prst="rect">
+            <a:avLst/>
+          </a:prstGeom>
+          <a:noFill/>
+        </p:spPr>
+        <p:txBody>
+          <a:bodyPr wrap="square" anchor="t" lIns="0" rIns="0" tIns="0" bIns="0">
+            <a:spAutoFit/>
+          </a:bodyPr>
+          <a:lstStyle/>
+          <a:p>
+            <a:pPr algn="l">
+              <a:lnSpc>
+                <a:spcPct val="106000"/>
+              </a:lnSpc>
+              <a:spcBef>
+                <a:spcPts val="0"/>
+              </a:spcBef>
+              <a:spcAft>
+                <a:spcPts val="300"/>
+              </a:spcAft>
+            </a:pPr>
+            <a:r>
+              <a:rPr sz="900" b="0" i="0">
+                <a:solidFill>
+                  <a:srgbClr val="322014"/>
+                </a:solidFill>
+                <a:latin typeface="Arial"/>
+              </a:rPr>
+              <a:t>Phase 1 needs no new capital and no new systems beyond an order-entry rule.</a:t>
+            </a:r>
+          </a:p>
+        </p:txBody>
+      </p:sp>
+      <p:sp>
+        <p:nvSpPr>
+          <p:cNvPr id="15" name="TextBox 14"/>
+          <p:cNvSpPr txBox="1"/>
+          <p:nvPr/>
+        </p:nvSpPr>
+        <p:spPr>
+          <a:xfrm>
+            <a:off x="7287768" y="1737360"/>
+            <a:ext cx="4336999" cy="274320"/>
+          </a:xfrm>
+          <a:prstGeom prst="rect">
+            <a:avLst/>
+          </a:prstGeom>
+          <a:noFill/>
+        </p:spPr>
+        <p:txBody>
+          <a:bodyPr wrap="square" anchor="t" lIns="0" rIns="0" tIns="0" bIns="0">
+            <a:spAutoFit/>
+          </a:bodyPr>
+          <a:lstStyle/>
+          <a:p>
+            <a:pPr algn="l">
+              <a:lnSpc>
+                <a:spcPct val="106000"/>
+              </a:lnSpc>
+              <a:spcBef>
+                <a:spcPts val="0"/>
+              </a:spcBef>
+              <a:spcAft>
+                <a:spcPts val="300"/>
+              </a:spcAft>
+            </a:pPr>
+            <a:r>
+              <a:rPr sz="1200" b="1" i="0">
+                <a:solidFill>
+                  <a:srgbClr val="5A3921"/>
+                </a:solidFill>
+                <a:latin typeface="Georgia"/>
+              </a:rPr>
+              <a:t>What the Board gets in return</a:t>
+            </a:r>
+          </a:p>
+        </p:txBody>
+      </p:sp>
+      <p:cxnSp>
+        <p:nvCxnSpPr>
+          <p:cNvPr id="16" name="Connector 15"/>
+          <p:cNvCxnSpPr/>
+          <p:nvPr/>
+        </p:nvCxnSpPr>
+        <p:spPr>
+          <a:xfrm>
+            <a:off x="7287768" y="2011680"/>
+            <a:ext cx="4336999" cy="0"/>
+          </a:xfrm>
+          <a:prstGeom prst="line">
+            <a:avLst/>
+          </a:prstGeom>
+          <a:ln w="19050">
+            <a:solidFill>
+              <a:srgbClr val="322014"/>
+            </a:solidFill>
+          </a:ln>
+        </p:spPr>
+        <p:style>
+          <a:lnRef idx="2">
+            <a:schemeClr val="accent1"/>
+          </a:lnRef>
+          <a:fillRef idx="0">
+            <a:schemeClr val="accent1"/>
+          </a:fillRef>
+          <a:effectRef idx="1">
+            <a:schemeClr val="accent1"/>
+          </a:effectRef>
+          <a:fontRef idx="minor">
+            <a:schemeClr val="tx1"/>
+          </a:fontRef>
+        </p:style>
+      </p:cxnSp>
+      <p:cxnSp>
+        <p:nvCxnSpPr>
+          <p:cNvPr id="17" name="Connector 16"/>
+          <p:cNvCxnSpPr/>
+          <p:nvPr/>
+        </p:nvCxnSpPr>
+        <p:spPr>
+          <a:xfrm>
+            <a:off x="7287768" y="2212848"/>
+            <a:ext cx="4336999" cy="0"/>
+          </a:xfrm>
+          <a:prstGeom prst="line">
+            <a:avLst/>
+          </a:prstGeom>
+          <a:ln w="19050">
+            <a:solidFill>
+              <a:srgbClr val="322014"/>
+            </a:solidFill>
+          </a:ln>
+        </p:spPr>
+        <p:style>
+          <a:lnRef idx="2">
+            <a:schemeClr val="accent1"/>
+          </a:lnRef>
+          <a:fillRef idx="0">
+            <a:schemeClr val="accent1"/>
+          </a:fillRef>
+          <a:effectRef idx="1">
+            <a:schemeClr val="accent1"/>
+          </a:effectRef>
+          <a:fontRef idx="minor">
+            <a:schemeClr val="tx1"/>
+          </a:fontRef>
+        </p:style>
+      </p:cxnSp>
+      <p:sp>
+        <p:nvSpPr>
+          <p:cNvPr id="18" name="TextBox 17"/>
+          <p:cNvSpPr txBox="1"/>
+          <p:nvPr/>
+        </p:nvSpPr>
+        <p:spPr>
+          <a:xfrm>
+            <a:off x="7287768" y="2267712"/>
+            <a:ext cx="4336999" cy="310896"/>
+          </a:xfrm>
+          <a:prstGeom prst="rect">
+            <a:avLst/>
+          </a:prstGeom>
+          <a:noFill/>
+        </p:spPr>
+        <p:txBody>
+          <a:bodyPr wrap="square" anchor="t" lIns="0" rIns="0" tIns="0" bIns="0">
+            <a:spAutoFit/>
+          </a:bodyPr>
+          <a:lstStyle/>
+          <a:p>
+            <a:pPr algn="l">
+              <a:lnSpc>
+                <a:spcPct val="106000"/>
+              </a:lnSpc>
+              <a:spcBef>
+                <a:spcPts val="0"/>
+              </a:spcBef>
+              <a:spcAft>
+                <a:spcPts val="300"/>
+              </a:spcAft>
+            </a:pPr>
+            <a:r>
+              <a:rPr sz="1500" b="1" i="0">
+                <a:solidFill>
+                  <a:srgbClr val="322014"/>
+                </a:solidFill>
+                <a:latin typeface="Arial"/>
+              </a:rPr>
+              <a:t>+$1.23M</a:t>
+            </a:r>
+          </a:p>
+        </p:txBody>
+      </p:sp>
+      <p:sp>
+        <p:nvSpPr>
+          <p:cNvPr id="19" name="TextBox 18"/>
+          <p:cNvSpPr txBox="1"/>
+          <p:nvPr/>
+        </p:nvSpPr>
+        <p:spPr>
+          <a:xfrm>
+            <a:off x="7287768" y="2578608"/>
+            <a:ext cx="4336999" cy="365760"/>
+          </a:xfrm>
+          <a:prstGeom prst="rect">
+            <a:avLst/>
+          </a:prstGeom>
+          <a:noFill/>
+        </p:spPr>
+        <p:txBody>
+          <a:bodyPr wrap="square" anchor="t" lIns="0" rIns="0" tIns="0" bIns="0">
+            <a:spAutoFit/>
+          </a:bodyPr>
+          <a:lstStyle/>
+          <a:p>
+            <a:pPr algn="l">
+              <a:lnSpc>
+                <a:spcPct val="108000"/>
+              </a:lnSpc>
+              <a:spcBef>
+                <a:spcPts val="0"/>
+              </a:spcBef>
+              <a:spcAft>
+                <a:spcPts val="300"/>
+              </a:spcAft>
+            </a:pPr>
+            <a:r>
+              <a:rPr sz="900" b="0" i="0">
+                <a:solidFill>
+                  <a:srgbClr val="322014"/>
+                </a:solidFill>
+                <a:latin typeface="Arial"/>
+              </a:rPr>
+              <a:t>Operating profit, full-ledger basis (+84% on $1.467M)</a:t>
+            </a:r>
+          </a:p>
+        </p:txBody>
+      </p:sp>
+      <p:cxnSp>
+        <p:nvCxnSpPr>
+          <p:cNvPr id="20" name="Connector 19"/>
+          <p:cNvCxnSpPr/>
+          <p:nvPr/>
+        </p:nvCxnSpPr>
+        <p:spPr>
+          <a:xfrm>
+            <a:off x="7287768" y="3538728"/>
+            <a:ext cx="4336999" cy="0"/>
+          </a:xfrm>
+          <a:prstGeom prst="line">
+            <a:avLst/>
+          </a:prstGeom>
+          <a:ln w="19050">
+            <a:solidFill>
+              <a:srgbClr val="322014"/>
+            </a:solidFill>
+          </a:ln>
+        </p:spPr>
+        <p:style>
+          <a:lnRef idx="2">
+            <a:schemeClr val="accent1"/>
+          </a:lnRef>
+          <a:fillRef idx="0">
+            <a:schemeClr val="accent1"/>
+          </a:fillRef>
+          <a:effectRef idx="1">
+            <a:schemeClr val="accent1"/>
+          </a:effectRef>
+          <a:fontRef idx="minor">
+            <a:schemeClr val="tx1"/>
+          </a:fontRef>
+        </p:style>
+      </p:cxnSp>
+      <p:sp>
+        <p:nvSpPr>
+          <p:cNvPr id="21" name="TextBox 20"/>
+          <p:cNvSpPr txBox="1"/>
+          <p:nvPr/>
+        </p:nvSpPr>
+        <p:spPr>
+          <a:xfrm>
+            <a:off x="7287768" y="3593592"/>
+            <a:ext cx="4336999" cy="310896"/>
+          </a:xfrm>
+          <a:prstGeom prst="rect">
+            <a:avLst/>
+          </a:prstGeom>
+          <a:noFill/>
+        </p:spPr>
+        <p:txBody>
+          <a:bodyPr wrap="square" anchor="t" lIns="0" rIns="0" tIns="0" bIns="0">
+            <a:spAutoFit/>
+          </a:bodyPr>
+          <a:lstStyle/>
+          <a:p>
+            <a:pPr algn="l">
+              <a:lnSpc>
+                <a:spcPct val="106000"/>
+              </a:lnSpc>
+              <a:spcBef>
+                <a:spcPts val="0"/>
+              </a:spcBef>
+              <a:spcAft>
+                <a:spcPts val="300"/>
+              </a:spcAft>
+            </a:pPr>
+            <a:r>
+              <a:rPr sz="1500" b="1" i="0">
+                <a:solidFill>
+                  <a:srgbClr val="322014"/>
+                </a:solidFill>
+                <a:latin typeface="Arial"/>
+              </a:rPr>
+              <a:t>19.9%</a:t>
+            </a:r>
+          </a:p>
+        </p:txBody>
+      </p:sp>
+      <p:sp>
+        <p:nvSpPr>
+          <p:cNvPr id="22" name="TextBox 21"/>
+          <p:cNvSpPr txBox="1"/>
+          <p:nvPr/>
+        </p:nvSpPr>
+        <p:spPr>
+          <a:xfrm>
+            <a:off x="7287768" y="3904488"/>
+            <a:ext cx="4336999" cy="365760"/>
+          </a:xfrm>
+          <a:prstGeom prst="rect">
+            <a:avLst/>
+          </a:prstGeom>
+          <a:noFill/>
+        </p:spPr>
+        <p:txBody>
+          <a:bodyPr wrap="square" anchor="t" lIns="0" rIns="0" tIns="0" bIns="0">
+            <a:spAutoFit/>
+          </a:bodyPr>
+          <a:lstStyle/>
+          <a:p>
+            <a:pPr algn="l">
+              <a:lnSpc>
+                <a:spcPct val="108000"/>
+              </a:lnSpc>
+              <a:spcBef>
+                <a:spcPts val="0"/>
+              </a:spcBef>
+              <a:spcAft>
+                <a:spcPts val="300"/>
+              </a:spcAft>
+            </a:pPr>
+            <a:r>
+              <a:rPr sz="900" b="0" i="0">
+                <a:solidFill>
+                  <a:srgbClr val="322014"/>
+                </a:solidFill>
+                <a:latin typeface="Arial"/>
+              </a:rPr>
+              <a:t>Operating margin, from 11.6% and above the 15.5% target</a:t>
+            </a:r>
+          </a:p>
+        </p:txBody>
+      </p:sp>
+      <p:cxnSp>
+        <p:nvCxnSpPr>
+          <p:cNvPr id="23" name="Connector 22"/>
+          <p:cNvCxnSpPr/>
+          <p:nvPr/>
+        </p:nvCxnSpPr>
+        <p:spPr>
+          <a:xfrm>
+            <a:off x="7287768" y="4864608"/>
+            <a:ext cx="4336999" cy="0"/>
+          </a:xfrm>
+          <a:prstGeom prst="line">
+            <a:avLst/>
+          </a:prstGeom>
+          <a:ln w="19050">
+            <a:solidFill>
+              <a:srgbClr val="322014"/>
+            </a:solidFill>
+          </a:ln>
+        </p:spPr>
+        <p:style>
+          <a:lnRef idx="2">
+            <a:schemeClr val="accent1"/>
+          </a:lnRef>
+          <a:fillRef idx="0">
+            <a:schemeClr val="accent1"/>
+          </a:fillRef>
+          <a:effectRef idx="1">
+            <a:schemeClr val="accent1"/>
+          </a:effectRef>
+          <a:fontRef idx="minor">
+            <a:schemeClr val="tx1"/>
+          </a:fontRef>
+        </p:style>
+      </p:cxnSp>
+      <p:sp>
+        <p:nvSpPr>
+          <p:cNvPr id="24" name="TextBox 23"/>
+          <p:cNvSpPr txBox="1"/>
+          <p:nvPr/>
+        </p:nvSpPr>
+        <p:spPr>
+          <a:xfrm>
+            <a:off x="7287768" y="4919472"/>
+            <a:ext cx="4336999" cy="310896"/>
+          </a:xfrm>
+          <a:prstGeom prst="rect">
+            <a:avLst/>
+          </a:prstGeom>
+          <a:noFill/>
+        </p:spPr>
+        <p:txBody>
+          <a:bodyPr wrap="square" anchor="t" lIns="0" rIns="0" tIns="0" bIns="0">
+            <a:spAutoFit/>
+          </a:bodyPr>
+          <a:lstStyle/>
+          <a:p>
+            <a:pPr algn="l">
+              <a:lnSpc>
+                <a:spcPct val="106000"/>
+              </a:lnSpc>
+              <a:spcBef>
+                <a:spcPts val="0"/>
+              </a:spcBef>
+              <a:spcAft>
+                <a:spcPts val="300"/>
+              </a:spcAft>
+            </a:pPr>
+            <a:r>
+              <a:rPr sz="1500" b="1" i="0">
+                <a:solidFill>
+                  <a:srgbClr val="322014"/>
+                </a:solidFill>
+                <a:latin typeface="Arial"/>
+              </a:rPr>
+              <a:t>$0</a:t>
+            </a:r>
+          </a:p>
+        </p:txBody>
+      </p:sp>
+      <p:sp>
+        <p:nvSpPr>
+          <p:cNvPr id="25" name="TextBox 24"/>
+          <p:cNvSpPr txBox="1"/>
+          <p:nvPr/>
+        </p:nvSpPr>
+        <p:spPr>
+          <a:xfrm>
+            <a:off x="7287768" y="5230368"/>
+            <a:ext cx="4336999" cy="365760"/>
+          </a:xfrm>
+          <a:prstGeom prst="rect">
+            <a:avLst/>
+          </a:prstGeom>
+          <a:noFill/>
+        </p:spPr>
+        <p:txBody>
+          <a:bodyPr wrap="square" anchor="t" lIns="0" rIns="0" tIns="0" bIns="0">
+            <a:spAutoFit/>
+          </a:bodyPr>
+          <a:lstStyle/>
+          <a:p>
+            <a:pPr algn="l">
+              <a:lnSpc>
+                <a:spcPct val="108000"/>
+              </a:lnSpc>
+              <a:spcBef>
+                <a:spcPts val="0"/>
+              </a:spcBef>
+              <a:spcAft>
+                <a:spcPts val="300"/>
+              </a:spcAft>
+            </a:pPr>
+            <a:r>
+              <a:rPr sz="900" b="0" i="0">
+                <a:solidFill>
+                  <a:srgbClr val="322014"/>
+                </a:solidFill>
+                <a:latin typeface="Arial"/>
+              </a:rPr>
+              <a:t>New capital spend required; Phase 1 is an order-entry rule</a:t>
+            </a:r>
+          </a:p>
+        </p:txBody>
+      </p:sp>
+      <p:sp>
+        <p:nvSpPr>
+          <p:cNvPr id="26" name="TextBox 25"/>
+          <p:cNvSpPr txBox="1"/>
+          <p:nvPr/>
+        </p:nvSpPr>
+        <p:spPr>
+          <a:xfrm>
+            <a:off x="566928" y="6099048"/>
+            <a:ext cx="11057839" cy="237744"/>
+          </a:xfrm>
+          <a:prstGeom prst="rect">
+            <a:avLst/>
+          </a:prstGeom>
+          <a:noFill/>
+        </p:spPr>
+        <p:txBody>
+          <a:bodyPr wrap="square" anchor="t" lIns="0" rIns="0" tIns="0" bIns="0">
+            <a:spAutoFit/>
+          </a:bodyPr>
+          <a:lstStyle/>
+          <a:p>
+            <a:pPr algn="l">
+              <a:lnSpc>
+                <a:spcPct val="105000"/>
+              </a:lnSpc>
+              <a:spcBef>
+                <a:spcPts val="0"/>
+              </a:spcBef>
+              <a:spcAft>
+                <a:spcPts val="300"/>
+              </a:spcAft>
+            </a:pPr>
+            <a:r>
+              <a:rPr sz="750" b="0" i="0">
+                <a:solidFill>
+                  <a:srgbClr val="8A7B6B"/>
+                </a:solidFill>
+                <a:latin typeface="Arial"/>
+              </a:rPr>
+              <a:t>Source: base-case simulation on the FY2011-FY2014 ledger. Returns are on the four-year ledger basis and depend on the 5% churn assumption holding. Modelling estimate, not a forecast.</a:t>
+            </a:r>
+          </a:p>
+        </p:txBody>
+      </p:sp>
+      <p:pic>
+        <p:nvPicPr>
+          <p:cNvPr id="27" name="Picture 26" descr="gavel_check.png"/>
+          <p:cNvPicPr>
+            <a:picLocks noChangeAspect="1"/>
+          </p:cNvPicPr>
+          <p:nvPr/>
+        </p:nvPicPr>
+        <p:blipFill>
+          <a:blip r:embed="rId2"/>
+          <a:stretch>
+            <a:fillRect/>
+          </a:stretch>
+        </p:blipFill>
+        <p:spPr>
+          <a:xfrm>
+            <a:off x="4069080" y="3639312"/>
+            <a:ext cx="2743200" cy="1481328"/>
+          </a:xfrm>
+          <a:prstGeom prst="rect">
+            <a:avLst/>
+          </a:prstGeom>
+        </p:spPr>
+      </p:pic>
+    </p:spTree>
+  </p:cSld>
+  <p:clrMapOvr>
+    <a:masterClrMapping/>
+  </p:clrMapOvr>
+</p:sld>
+</file>
+
+<file path=ppt/slides/slide18.xml><?xml version="1.0" encoding="utf-8"?>
+<p:sld xmlns:a="http://schemas.openxmlformats.org/drawingml/2006/main" xmlns:p="http://schemas.openxmlformats.org/presentationml/2006/main" xmlns:r="http://schemas.openxmlformats.org/officeDocument/2006/relationships">
+  <p:cSld>
+    <p:spTree>
+      <p:nvGrpSpPr>
+        <p:cNvPr id="1" name=""/>
+        <p:cNvGrpSpPr/>
+        <p:nvPr/>
+      </p:nvGrpSpPr>
+      <p:grpSpPr/>
+      <p:pic>
+        <p:nvPicPr>
+          <p:cNvPr id="11" name="Sea Background Photo" descr="sea_bg.jpg"/>
+          <p:cNvPicPr>
+            <a:picLocks noChangeAspect="1"/>
+          </p:cNvPicPr>
+          <p:nvPr/>
+        </p:nvPicPr>
+        <p:blipFill>
+          <a:blip r:embed="rId3"/>
+          <a:stretch>
+            <a:fillRect/>
+          </a:stretch>
+        </p:blipFill>
+        <p:spPr>
+          <a:xfrm>
+            <a:off x="0" y="0"/>
+            <a:ext cx="12191695" cy="6858000"/>
+          </a:xfrm>
+          <a:prstGeom prst="rect">
+            <a:avLst/>
+          </a:prstGeom>
+        </p:spPr>
+      </p:pic>
+      <p:sp>
+        <p:nvSpPr>
+          <p:cNvPr id="2" name="TextBox 1"/>
+          <p:cNvSpPr txBox="1"/>
+          <p:nvPr/>
+        </p:nvSpPr>
+        <p:spPr>
+          <a:xfrm>
+            <a:off x="566928" y="310896"/>
+            <a:ext cx="5486400" cy="310896"/>
+          </a:xfrm>
+          <a:prstGeom prst="rect">
+            <a:avLst/>
+          </a:prstGeom>
+          <a:noFill/>
+        </p:spPr>
+        <p:txBody>
+          <a:bodyPr wrap="square" anchor="t" lIns="0" rIns="0" tIns="0" bIns="0">
+            <a:spAutoFit/>
+          </a:bodyPr>
+          <a:lstStyle/>
+          <a:p>
+            <a:pPr algn="l">
+              <a:lnSpc>
+                <a:spcPct val="106000"/>
+              </a:lnSpc>
+              <a:spcBef>
+                <a:spcPts val="0"/>
+              </a:spcBef>
+              <a:spcAft>
+                <a:spcPts val="300"/>
+              </a:spcAft>
+            </a:pPr>
+            <a:r>
+              <a:rPr sz="1800" b="1" i="0">
+                <a:solidFill>
+                  <a:srgbClr val="322014"/>
+                </a:solidFill>
+                <a:latin typeface="Georgia"/>
+              </a:rPr>
+              <a:t>Global Superstore</a:t>
+            </a:r>
+          </a:p>
+        </p:txBody>
+      </p:sp>
+      <p:sp>
+        <p:nvSpPr>
+          <p:cNvPr id="3" name="TextBox 2"/>
+          <p:cNvSpPr txBox="1"/>
+          <p:nvPr/>
+        </p:nvSpPr>
+        <p:spPr>
+          <a:xfrm>
+            <a:off x="7784287" y="429768"/>
+            <a:ext cx="3840480" cy="219456"/>
+          </a:xfrm>
+          <a:prstGeom prst="rect">
+            <a:avLst/>
+          </a:prstGeom>
+          <a:noFill/>
+        </p:spPr>
+        <p:txBody>
+          <a:bodyPr wrap="square" anchor="t" lIns="0" rIns="0" tIns="0" bIns="0">
+            <a:spAutoFit/>
+          </a:bodyPr>
+          <a:lstStyle/>
+          <a:p>
+            <a:pPr algn="r">
+              <a:lnSpc>
+                <a:spcPct val="106000"/>
+              </a:lnSpc>
+              <a:spcBef>
+                <a:spcPts val="0"/>
+              </a:spcBef>
+              <a:spcAft>
+                <a:spcPts val="300"/>
+              </a:spcAft>
+            </a:pPr>
+            <a:r>
+              <a:rPr sz="750" b="1" i="0">
+                <a:solidFill>
+                  <a:srgbClr val="8A7B6B"/>
+                </a:solidFill>
+                <a:latin typeface="Arial"/>
+              </a:rPr>
+              <a:t>Revival Strategy</a:t>
+            </a:r>
+          </a:p>
+        </p:txBody>
+      </p:sp>
+      <p:cxnSp>
+        <p:nvCxnSpPr>
+          <p:cNvPr id="4" name="Connector 3"/>
+          <p:cNvCxnSpPr/>
+          <p:nvPr/>
+        </p:nvCxnSpPr>
+        <p:spPr>
+          <a:xfrm>
+            <a:off x="566928" y="658368"/>
+            <a:ext cx="11057839" cy="0"/>
+          </a:xfrm>
+          <a:prstGeom prst="line">
+            <a:avLst/>
+          </a:prstGeom>
+          <a:ln w="12700">
+            <a:solidFill>
+              <a:srgbClr val="322014"/>
+            </a:solidFill>
+          </a:ln>
+        </p:spPr>
+        <p:style>
+          <a:lnRef idx="2">
+            <a:schemeClr val="accent1"/>
+          </a:lnRef>
+          <a:fillRef idx="0">
+            <a:schemeClr val="accent1"/>
+          </a:fillRef>
+          <a:effectRef idx="1">
+            <a:schemeClr val="accent1"/>
+          </a:effectRef>
+          <a:fontRef idx="minor">
+            <a:schemeClr val="tx1"/>
+          </a:fontRef>
+        </p:style>
+      </p:cxnSp>
+      <p:sp>
+        <p:nvSpPr>
+          <p:cNvPr id="5" name="TextBox 4"/>
+          <p:cNvSpPr txBox="1"/>
+          <p:nvPr/>
+        </p:nvSpPr>
+        <p:spPr>
+          <a:xfrm>
+            <a:off x="566928" y="2560320"/>
+            <a:ext cx="9399163" cy="1097280"/>
+          </a:xfrm>
+          <a:prstGeom prst="rect">
+            <a:avLst/>
+          </a:prstGeom>
+          <a:noFill/>
+        </p:spPr>
+        <p:txBody>
+          <a:bodyPr wrap="square" anchor="t" lIns="0" rIns="0" tIns="0" bIns="0">
+            <a:spAutoFit/>
+          </a:bodyPr>
+          <a:lstStyle/>
+          <a:p>
+            <a:pPr algn="ctr">
+              <a:lnSpc>
+                <a:spcPct val="120000"/>
+              </a:lnSpc>
+              <a:spcBef>
+                <a:spcPts val="0"/>
+              </a:spcBef>
+              <a:spcAft>
+                <a:spcPts val="300"/>
+              </a:spcAft>
+            </a:pPr>
+            <a:r>
+              <a:rPr sz="2000" b="1" i="0">
+                <a:solidFill>
+                  <a:srgbClr val="322014"/>
+                </a:solidFill>
+                <a:latin typeface="Georgia"/>
+              </a:rPr>
+              <a:t>“Beware of little expenses; a small leak will sink a great ship.”</a:t>
+            </a:r>
+          </a:p>
+        </p:txBody>
+      </p:sp>
+      <p:sp>
+        <p:nvSpPr>
+          <p:cNvPr id="6" name="TextBox 5"/>
+          <p:cNvSpPr txBox="1"/>
+          <p:nvPr/>
+        </p:nvSpPr>
+        <p:spPr>
+          <a:xfrm>
+            <a:off x="566928" y="3840480"/>
+            <a:ext cx="9399163" cy="365760"/>
+          </a:xfrm>
+          <a:prstGeom prst="rect">
+            <a:avLst/>
+          </a:prstGeom>
+          <a:noFill/>
+        </p:spPr>
+        <p:txBody>
+          <a:bodyPr wrap="square" anchor="t" lIns="0" rIns="0" tIns="0" bIns="0">
+            <a:spAutoFit/>
+          </a:bodyPr>
+          <a:lstStyle/>
+          <a:p>
+            <a:pPr algn="ctr">
+              <a:lnSpc>
+                <a:spcPct val="106000"/>
+              </a:lnSpc>
+              <a:spcBef>
+                <a:spcPts val="0"/>
+              </a:spcBef>
+              <a:spcAft>
+                <a:spcPts val="300"/>
+              </a:spcAft>
+            </a:pPr>
+            <a:r>
+              <a:rPr sz="1400" b="1" i="0">
+                <a:solidFill>
+                  <a:srgbClr val="8A7B6B"/>
+                </a:solidFill>
+                <a:latin typeface="Georgia"/>
+              </a:rPr>
+              <a:t>Benjamin Franklin</a:t>
+            </a:r>
+          </a:p>
+        </p:txBody>
+      </p:sp>
+      <p:sp>
+        <p:nvSpPr>
+          <p:cNvPr id="7" name="TextBox 6"/>
+          <p:cNvSpPr txBox="1"/>
+          <p:nvPr/>
+        </p:nvSpPr>
+        <p:spPr>
+          <a:xfrm>
+            <a:off x="566928" y="4389120"/>
+            <a:ext cx="9399163" cy="365760"/>
+          </a:xfrm>
+          <a:prstGeom prst="rect">
+            <a:avLst/>
+          </a:prstGeom>
+          <a:noFill/>
+        </p:spPr>
+        <p:txBody>
+          <a:bodyPr wrap="square" anchor="t" lIns="0" rIns="0" tIns="0" bIns="0">
+            <a:spAutoFit/>
+          </a:bodyPr>
+          <a:lstStyle/>
+          <a:p>
+            <a:pPr algn="ctr">
+              <a:lnSpc>
+                <a:spcPct val="106000"/>
+              </a:lnSpc>
+              <a:spcBef>
+                <a:spcPts val="0"/>
+              </a:spcBef>
+              <a:spcAft>
+                <a:spcPts val="300"/>
+              </a:spcAft>
+            </a:pPr>
+            <a:r>
+              <a:rPr sz="1500" b="1" i="0">
+                <a:solidFill>
+                  <a:srgbClr val="5A3921"/>
+                </a:solidFill>
+                <a:latin typeface="Georgia"/>
+              </a:rPr>
+              <a:t>Prepared for the Board of Directors</a:t>
+            </a:r>
+          </a:p>
+        </p:txBody>
+      </p:sp>
+      <p:cxnSp>
+        <p:nvCxnSpPr>
+          <p:cNvPr id="8" name="Connector 7"/>
+          <p:cNvCxnSpPr/>
+          <p:nvPr/>
+        </p:nvCxnSpPr>
+        <p:spPr>
+          <a:xfrm>
+            <a:off x="566928" y="6355080"/>
+            <a:ext cx="11057839" cy="0"/>
+          </a:xfrm>
+          <a:prstGeom prst="line">
+            <a:avLst/>
+          </a:prstGeom>
+          <a:ln w="9525">
+            <a:solidFill>
+              <a:srgbClr val="C5A681"/>
+            </a:solidFill>
+          </a:ln>
+        </p:spPr>
+        <p:style>
+          <a:lnRef idx="2">
+            <a:schemeClr val="accent1"/>
+          </a:lnRef>
+          <a:fillRef idx="0">
+            <a:schemeClr val="accent1"/>
+          </a:fillRef>
+          <a:effectRef idx="1">
+            <a:schemeClr val="accent1"/>
+          </a:effectRef>
+          <a:fontRef idx="minor">
+            <a:schemeClr val="tx1"/>
+          </a:fontRef>
+        </p:style>
+      </p:cxnSp>
+      <p:sp>
+        <p:nvSpPr>
+          <p:cNvPr id="9" name="TextBox 8"/>
+          <p:cNvSpPr txBox="1"/>
+          <p:nvPr/>
+        </p:nvSpPr>
+        <p:spPr>
+          <a:xfrm>
+            <a:off x="566928" y="6400800"/>
+            <a:ext cx="7740487" cy="219456"/>
+          </a:xfrm>
+          <a:prstGeom prst="rect">
+            <a:avLst/>
+          </a:prstGeom>
+          <a:noFill/>
+        </p:spPr>
+        <p:txBody>
+          <a:bodyPr wrap="square" anchor="t" lIns="0" rIns="0" tIns="0" bIns="0">
+            <a:spAutoFit/>
+          </a:bodyPr>
+          <a:lstStyle/>
+          <a:p>
+            <a:pPr algn="l">
+              <a:lnSpc>
+                <a:spcPct val="106000"/>
+              </a:lnSpc>
+              <a:spcBef>
+                <a:spcPts val="0"/>
+              </a:spcBef>
+              <a:spcAft>
+                <a:spcPts val="300"/>
+              </a:spcAft>
+            </a:pPr>
+            <a:r>
+              <a:rPr sz="850" b="1" i="0">
+                <a:solidFill>
+                  <a:srgbClr val="322014"/>
+                </a:solidFill>
+                <a:latin typeface="Arial"/>
+              </a:rPr>
+              <a:t>Global Superstore · Revival Strategy</a:t>
+            </a:r>
+          </a:p>
+        </p:txBody>
+      </p:sp>
+      <p:sp>
+        <p:nvSpPr>
+          <p:cNvPr id="10" name="TextBox 9"/>
+          <p:cNvSpPr txBox="1"/>
+          <p:nvPr/>
+        </p:nvSpPr>
+        <p:spPr>
+          <a:xfrm>
+            <a:off x="566928" y="5623560"/>
+            <a:ext cx="11057839" cy="274320"/>
+          </a:xfrm>
+          <a:prstGeom prst="rect">
+            <a:avLst/>
+          </a:prstGeom>
+          <a:noFill/>
+        </p:spPr>
+        <p:txBody>
+          <a:bodyPr wrap="square" anchor="t" lIns="0" rIns="0" tIns="0" bIns="0">
+            <a:spAutoFit/>
+          </a:bodyPr>
+          <a:lstStyle/>
+          <a:p>
+            <a:pPr algn="l">
+              <a:lnSpc>
+                <a:spcPct val="106000"/>
+              </a:lnSpc>
+              <a:spcBef>
+                <a:spcPts val="0"/>
+              </a:spcBef>
+              <a:spcAft>
+                <a:spcPts val="300"/>
+              </a:spcAft>
+            </a:pPr>
+            <a:r>
+              <a:rPr sz="800" b="0" i="0">
+                <a:solidFill>
+                  <a:srgbClr val="8A7B6B"/>
+                </a:solidFill>
+                <a:latin typeface="Arial"/>
+              </a:rPr>
+              <a:t>Source data: Global Superstore transaction ledger, FY2011-FY2014 (51,290 order lines). Deck produced with consulting-pptx-skill (github.com/carnot-tech/consulting-pptx-skill).</a:t>
+            </a:r>
+          </a:p>
+        </p:txBody>
+      </p:sp>
+    </p:spTree>
+  </p:cSld>
+  <p:clrMapOvr>
+    <a:masterClrMapping/>
+  </p:clrMapOvr>
+</p:sld>
+</file>
+
+<file path=ppt/slides/slide2.xml><?xml version="1.0" encoding="utf-8"?>
+<p:sld xmlns:a="http://schemas.openxmlformats.org/drawingml/2006/main" xmlns:p="http://schemas.openxmlformats.org/presentationml/2006/main" xmlns:r="http://schemas.openxmlformats.org/officeDocument/2006/relationships">
+  <p:cSld>
+    <p:spTree>
+      <p:nvGrpSpPr>
+        <p:cNvPr id="1" name=""/>
+        <p:cNvGrpSpPr/>
+        <p:nvPr/>
+      </p:nvGrpSpPr>
+      <p:grpSpPr/>
+      <p:sp>
+        <p:nvSpPr>
+          <p:cNvPr id="2" name="TextBox 1"/>
+          <p:cNvSpPr txBox="1"/>
+          <p:nvPr/>
+        </p:nvSpPr>
+        <p:spPr>
+          <a:xfrm>
+            <a:off x="566928" y="310896"/>
+            <a:ext cx="6634703" cy="310896"/>
+          </a:xfrm>
+          <a:prstGeom prst="rect">
+            <a:avLst/>
+          </a:prstGeom>
+          <a:noFill/>
+        </p:spPr>
+        <p:txBody>
+          <a:bodyPr wrap="square" anchor="t" lIns="0" rIns="0" tIns="0" bIns="0">
+            <a:spAutoFit/>
+          </a:bodyPr>
+          <a:lstStyle/>
+          <a:p>
+            <a:pPr algn="l">
+              <a:lnSpc>
+                <a:spcPct val="106000"/>
+              </a:lnSpc>
+              <a:spcBef>
+                <a:spcPts val="0"/>
+              </a:spcBef>
+              <a:spcAft>
+                <a:spcPts val="300"/>
+              </a:spcAft>
+            </a:pPr>
+            <a:r>
+              <a:rPr sz="1800" b="1" i="0">
+                <a:solidFill>
+                  <a:srgbClr val="322014"/>
+                </a:solidFill>
+                <a:latin typeface="Georgia"/>
+              </a:rPr>
+              <a:t>Global Superstore · Revival Strategy</a:t>
+            </a:r>
+          </a:p>
+        </p:txBody>
+      </p:sp>
+      <p:sp>
+        <p:nvSpPr>
+          <p:cNvPr id="3" name="TextBox 2"/>
+          <p:cNvSpPr txBox="1"/>
+          <p:nvPr/>
+        </p:nvSpPr>
+        <p:spPr>
+          <a:xfrm>
+            <a:off x="7784287" y="429768"/>
+            <a:ext cx="3840480" cy="219456"/>
+          </a:xfrm>
+          <a:prstGeom prst="rect">
+            <a:avLst/>
+          </a:prstGeom>
+          <a:noFill/>
+        </p:spPr>
+        <p:txBody>
+          <a:bodyPr wrap="square" anchor="t" lIns="0" rIns="0" tIns="0" bIns="0">
+            <a:spAutoFit/>
+          </a:bodyPr>
+          <a:lstStyle/>
+          <a:p>
+            <a:pPr algn="r">
+              <a:lnSpc>
+                <a:spcPct val="106000"/>
+              </a:lnSpc>
+              <a:spcBef>
+                <a:spcPts val="0"/>
+              </a:spcBef>
+              <a:spcAft>
+                <a:spcPts val="300"/>
+              </a:spcAft>
+            </a:pPr>
+            <a:r>
+              <a:rPr sz="750" b="1" i="0">
+                <a:solidFill>
+                  <a:srgbClr val="8A7B6B"/>
+                </a:solidFill>
+                <a:latin typeface="Arial"/>
+              </a:rPr>
+              <a:t>Executive summary</a:t>
+            </a:r>
+          </a:p>
+        </p:txBody>
+      </p:sp>
+      <p:cxnSp>
+        <p:nvCxnSpPr>
+          <p:cNvPr id="4" name="Connector 3"/>
+          <p:cNvCxnSpPr/>
+          <p:nvPr/>
+        </p:nvCxnSpPr>
+        <p:spPr>
+          <a:xfrm>
+            <a:off x="566928" y="658368"/>
+            <a:ext cx="11057839" cy="0"/>
+          </a:xfrm>
+          <a:prstGeom prst="line">
+            <a:avLst/>
+          </a:prstGeom>
+          <a:ln w="12700">
+            <a:solidFill>
+              <a:srgbClr val="322014"/>
+            </a:solidFill>
+          </a:ln>
+        </p:spPr>
+        <p:style>
+          <a:lnRef idx="2">
+            <a:schemeClr val="accent1"/>
+          </a:lnRef>
+          <a:fillRef idx="0">
+            <a:schemeClr val="accent1"/>
+          </a:fillRef>
+          <a:effectRef idx="1">
+            <a:schemeClr val="accent1"/>
+          </a:effectRef>
+          <a:fontRef idx="minor">
+            <a:schemeClr val="tx1"/>
+          </a:fontRef>
+        </p:style>
+      </p:cxnSp>
+      <p:cxnSp>
+        <p:nvCxnSpPr>
+          <p:cNvPr id="5" name="Connector 4"/>
+          <p:cNvCxnSpPr/>
+          <p:nvPr/>
+        </p:nvCxnSpPr>
+        <p:spPr>
+          <a:xfrm>
+            <a:off x="566928" y="6355080"/>
+            <a:ext cx="11057839" cy="0"/>
+          </a:xfrm>
+          <a:prstGeom prst="line">
+            <a:avLst/>
+          </a:prstGeom>
+          <a:ln w="9525">
+            <a:solidFill>
+              <a:srgbClr val="C5A681"/>
+            </a:solidFill>
+          </a:ln>
+        </p:spPr>
+        <p:style>
+          <a:lnRef idx="2">
+            <a:schemeClr val="accent1"/>
+          </a:lnRef>
+          <a:fillRef idx="0">
+            <a:schemeClr val="accent1"/>
+          </a:fillRef>
+          <a:effectRef idx="1">
+            <a:schemeClr val="accent1"/>
+          </a:effectRef>
+          <a:fontRef idx="minor">
+            <a:schemeClr val="tx1"/>
+          </a:fontRef>
+        </p:style>
+      </p:cxnSp>
+      <p:sp>
+        <p:nvSpPr>
+          <p:cNvPr id="6" name="TextBox 5"/>
+          <p:cNvSpPr txBox="1"/>
+          <p:nvPr/>
+        </p:nvSpPr>
+        <p:spPr>
+          <a:xfrm>
+            <a:off x="566928" y="6400800"/>
+            <a:ext cx="7740487" cy="219456"/>
+          </a:xfrm>
+          <a:prstGeom prst="rect">
+            <a:avLst/>
+          </a:prstGeom>
+          <a:noFill/>
+        </p:spPr>
+        <p:txBody>
+          <a:bodyPr wrap="square" anchor="t" lIns="0" rIns="0" tIns="0" bIns="0">
+            <a:spAutoFit/>
+          </a:bodyPr>
+          <a:lstStyle/>
+          <a:p>
+            <a:pPr algn="l">
+              <a:lnSpc>
+                <a:spcPct val="106000"/>
+              </a:lnSpc>
+              <a:spcBef>
+                <a:spcPts val="0"/>
+              </a:spcBef>
+              <a:spcAft>
+                <a:spcPts val="300"/>
+              </a:spcAft>
+            </a:pPr>
+            <a:r>
+              <a:rPr sz="850" b="1" i="0">
+                <a:solidFill>
+                  <a:srgbClr val="322014"/>
+                </a:solidFill>
+                <a:latin typeface="Arial"/>
+              </a:rPr>
+              <a:t>Global Superstore · Revival Strategy</a:t>
+            </a:r>
+          </a:p>
+        </p:txBody>
+      </p:sp>
+      <p:sp>
+        <p:nvSpPr>
+          <p:cNvPr id="7" name="TextBox 6"/>
+          <p:cNvSpPr txBox="1"/>
+          <p:nvPr/>
+        </p:nvSpPr>
+        <p:spPr>
+          <a:xfrm>
+            <a:off x="10710367" y="6400800"/>
+            <a:ext cx="914400" cy="219456"/>
+          </a:xfrm>
+          <a:prstGeom prst="rect">
+            <a:avLst/>
+          </a:prstGeom>
+          <a:noFill/>
+        </p:spPr>
+        <p:txBody>
+          <a:bodyPr wrap="square" anchor="t" lIns="0" rIns="0" tIns="0" bIns="0">
+            <a:spAutoFit/>
+          </a:bodyPr>
+          <a:lstStyle/>
+          <a:p>
+            <a:pPr algn="r">
+              <a:lnSpc>
+                <a:spcPct val="106000"/>
+              </a:lnSpc>
+              <a:spcBef>
+                <a:spcPts val="0"/>
+              </a:spcBef>
+              <a:spcAft>
+                <a:spcPts val="300"/>
+              </a:spcAft>
+            </a:pPr>
+            <a:r>
+              <a:rPr sz="850" b="0" i="0">
+                <a:solidFill>
+                  <a:srgbClr val="8A7B6B"/>
+                </a:solidFill>
+                <a:latin typeface="Arial"/>
+              </a:rPr>
               <a:t>1</a:t>
             </a:r>
           </a:p>
@@ -24210,31 +24305,7 @@
                 </a:solidFill>
                 <a:latin typeface="Arial"/>
               </a:rPr>
-              <a:t>Past 50% off, every single order loses money - even the best orders in that band are down 73%.</a:t>
-            </a:r>
-          </a:p>
-          <a:p>
-            <a:pPr algn="l" marL="155448" indent="-155448">
-              <a:lnSpc>
-                <a:spcPct val="114000"/>
-              </a:lnSpc>
-              <a:spcBef>
-                <a:spcPts val="0"/>
-              </a:spcBef>
-              <a:spcAft>
-                <a:spcPts val="300"/>
-              </a:spcAft>
-              <a:buFont typeface="Arial"/>
-              <a:buChar char="•"/>
-            </a:pPr>
-            <a:r>
-              <a:rPr sz="1100" b="0" i="0">
-                <a:solidFill>
-                  <a:srgbClr val="322014"/>
-                </a:solidFill>
-                <a:latin typeface="Arial"/>
-              </a:rPr>
-              <a:t>Rank correlation between discount and profit: -0.60 (Pearson: -0.32). The damage is a cliff, not a straight line.</a:t>
+              <a:t>Past 50% off, 100% of orders lose money.</a:t>
             </a:r>
           </a:p>
         </p:txBody>
@@ -24279,7 +24350,7 @@
                 </a:solidFill>
                 <a:latin typeface="Arial"/>
               </a:rPr>
-              <a:t>Source: Global Superstore transaction ledger, FY2011-FY2014. Bands follow the discount distribution in the ledger.</a:t>
+              <a:t>Source: Global Superstore transaction ledger, FY2011-FY2014. Bands follow the discount distribution in the ledger. Discount-profit rank correlation: -0.60 (Pearson: -0.32).</a:t>
             </a:r>
           </a:p>
         </p:txBody>

</xml_diff>